<commit_message>
swarm ex eow bookeeping
</commit_message>
<xml_diff>
--- a/SWARM-EX/Planning/COMMS-Quad_Chart_JustinLe S25.pptx
+++ b/SWARM-EX/Planning/COMMS-Quad_Chart_JustinLe S25.pptx
@@ -1,23 +1,121 @@
 
 <file path=ppt/presentation.xml><?xml version="1.0" encoding="utf-8"?>
-<p:presentation xmlns:a="http://schemas.openxmlformats.org/drawingml/2006/main" xmlns:p="http://schemas.openxmlformats.org/presentationml/2006/main" xmlns:r="http://schemas.openxmlformats.org/officeDocument/2006/relationships" xmlns:p14="http://schemas.microsoft.com/office/powerpoint/2010/main" xmlns:p15="http://schemas.microsoft.com/office/powerpoint/2012/main" xmlns:mc="http://schemas.openxmlformats.org/markup-compatibility/2006">
+<p:presentation xmlns:a="http://schemas.openxmlformats.org/drawingml/2006/main" xmlns:r="http://schemas.openxmlformats.org/officeDocument/2006/relationships" xmlns:p="http://schemas.openxmlformats.org/presentationml/2006/main">
   <p:sldMasterIdLst>
-    <p:sldMasterId id="2147483648" r:id="rId2"/>
+    <p:sldMasterId id="2147483648" r:id="rId1"/>
   </p:sldMasterIdLst>
   <p:notesMasterIdLst>
-    <p:notesMasterId r:id="rId3"/>
+    <p:notesMasterId r:id="rId4"/>
   </p:notesMasterIdLst>
   <p:sldIdLst>
-    <p:sldId id="256" r:id="rId4"/>
+    <p:sldId id="256" r:id="rId3"/>
+    <p:sldId id="257" r:id="rId5"/>
   </p:sldIdLst>
   <p:sldSz cx="9144000" cy="5143500"/>
   <p:notesSz cx="6858000" cy="9144000"/>
+  <p:defaultTextStyle>
+    <a:lvl1pPr marL="0" algn="l" defTabSz="914400" rtl="0" eaLnBrk="1" latinLnBrk="0" hangingPunct="1">
+      <a:defRPr sz="1800" kern="1200">
+        <a:solidFill>
+          <a:schemeClr val="tx1"/>
+        </a:solidFill>
+        <a:latin typeface="+mn-lt"/>
+        <a:ea typeface="+mn-ea"/>
+        <a:cs typeface="+mn-cs"/>
+      </a:defRPr>
+    </a:lvl1pPr>
+    <a:lvl2pPr marL="457200" algn="l" defTabSz="914400" rtl="0" eaLnBrk="1" latinLnBrk="0" hangingPunct="1">
+      <a:defRPr sz="1800" kern="1200">
+        <a:solidFill>
+          <a:schemeClr val="tx1"/>
+        </a:solidFill>
+        <a:latin typeface="+mn-lt"/>
+        <a:ea typeface="+mn-ea"/>
+        <a:cs typeface="+mn-cs"/>
+      </a:defRPr>
+    </a:lvl2pPr>
+    <a:lvl3pPr marL="914400" algn="l" defTabSz="914400" rtl="0" eaLnBrk="1" latinLnBrk="0" hangingPunct="1">
+      <a:defRPr sz="1800" kern="1200">
+        <a:solidFill>
+          <a:schemeClr val="tx1"/>
+        </a:solidFill>
+        <a:latin typeface="+mn-lt"/>
+        <a:ea typeface="+mn-ea"/>
+        <a:cs typeface="+mn-cs"/>
+      </a:defRPr>
+    </a:lvl3pPr>
+    <a:lvl4pPr marL="1371600" algn="l" defTabSz="914400" rtl="0" eaLnBrk="1" latinLnBrk="0" hangingPunct="1">
+      <a:defRPr sz="1800" kern="1200">
+        <a:solidFill>
+          <a:schemeClr val="tx1"/>
+        </a:solidFill>
+        <a:latin typeface="+mn-lt"/>
+        <a:ea typeface="+mn-ea"/>
+        <a:cs typeface="+mn-cs"/>
+      </a:defRPr>
+    </a:lvl4pPr>
+    <a:lvl5pPr marL="1828800" algn="l" defTabSz="914400" rtl="0" eaLnBrk="1" latinLnBrk="0" hangingPunct="1">
+      <a:defRPr sz="1800" kern="1200">
+        <a:solidFill>
+          <a:schemeClr val="tx1"/>
+        </a:solidFill>
+        <a:latin typeface="+mn-lt"/>
+        <a:ea typeface="+mn-ea"/>
+        <a:cs typeface="+mn-cs"/>
+      </a:defRPr>
+    </a:lvl5pPr>
+    <a:lvl6pPr marL="2286000" algn="l" defTabSz="914400" rtl="0" eaLnBrk="1" latinLnBrk="0" hangingPunct="1">
+      <a:defRPr sz="1800" kern="1200">
+        <a:solidFill>
+          <a:schemeClr val="tx1"/>
+        </a:solidFill>
+        <a:latin typeface="+mn-lt"/>
+        <a:ea typeface="+mn-ea"/>
+        <a:cs typeface="+mn-cs"/>
+      </a:defRPr>
+    </a:lvl6pPr>
+    <a:lvl7pPr marL="2743200" algn="l" defTabSz="914400" rtl="0" eaLnBrk="1" latinLnBrk="0" hangingPunct="1">
+      <a:defRPr sz="1800" kern="1200">
+        <a:solidFill>
+          <a:schemeClr val="tx1"/>
+        </a:solidFill>
+        <a:latin typeface="+mn-lt"/>
+        <a:ea typeface="+mn-ea"/>
+        <a:cs typeface="+mn-cs"/>
+      </a:defRPr>
+    </a:lvl7pPr>
+    <a:lvl8pPr marL="3200400" algn="l" defTabSz="914400" rtl="0" eaLnBrk="1" latinLnBrk="0" hangingPunct="1">
+      <a:defRPr sz="1800" kern="1200">
+        <a:solidFill>
+          <a:schemeClr val="tx1"/>
+        </a:solidFill>
+        <a:latin typeface="+mn-lt"/>
+        <a:ea typeface="+mn-ea"/>
+        <a:cs typeface="+mn-cs"/>
+      </a:defRPr>
+    </a:lvl8pPr>
+    <a:lvl9pPr marL="3657600" algn="l" defTabSz="914400" rtl="0" eaLnBrk="1" latinLnBrk="0" hangingPunct="1">
+      <a:defRPr sz="1800" kern="1200">
+        <a:solidFill>
+          <a:schemeClr val="tx1"/>
+        </a:solidFill>
+        <a:latin typeface="+mn-lt"/>
+        <a:ea typeface="+mn-ea"/>
+        <a:cs typeface="+mn-cs"/>
+      </a:defRPr>
+    </a:lvl9pPr>
+  </p:defaultTextStyle>
 </p:presentation>
 </file>
 
 <file path=ppt/notesMasters/notesMaster1.xml><?xml version="1.0" encoding="utf-8"?>
-<p:notesMaster xmlns:a="http://schemas.openxmlformats.org/drawingml/2006/main" xmlns:p="http://schemas.openxmlformats.org/presentationml/2006/main" xmlns:r="http://schemas.openxmlformats.org/officeDocument/2006/relationships" xmlns:p14="http://schemas.microsoft.com/office/powerpoint/2010/main" xmlns:p15="http://schemas.microsoft.com/office/powerpoint/2012/main" xmlns:mc="http://schemas.openxmlformats.org/markup-compatibility/2006">
+<p:notesMaster xmlns:a="http://schemas.openxmlformats.org/drawingml/2006/main" xmlns:r="http://schemas.openxmlformats.org/officeDocument/2006/relationships" xmlns:p="http://schemas.openxmlformats.org/presentationml/2006/main">
   <p:cSld>
+    <p:bg>
+      <p:bgRef idx="1001">
+        <a:schemeClr val="bg1"/>
+      </p:bgRef>
+    </p:bg>
     <p:spTree>
       <p:nvGrpSpPr>
         <p:cNvPr id="1" name=""/>
@@ -56,25 +154,25 @@
           </a:ln>
         </p:spPr>
         <p:txBody>
-          <a:bodyPr lIns="0" rIns="0" tIns="0" bIns="0" anchor="ctr">
+          <a:bodyPr lIns="0" tIns="0" rIns="0" bIns="0" anchor="ctr">
             <a:noAutofit/>
           </a:bodyPr>
           <a:p>
             <a:pPr algn="ctr"/>
             <a:r>
-              <a:rPr b="0" lang="en-US" sz="4400" spc="-1" strike="noStrike">
-                <a:solidFill>
-                  <a:srgbClr val="000000"/>
-                </a:solidFill>
-                <a:latin typeface="Arial"/>
+              <a:rPr lang="en-US" sz="4400" b="0" strike="noStrike" spc="-1">
+                <a:solidFill>
+                  <a:srgbClr val="000000"/>
+                </a:solidFill>
+                <a:latin typeface="Arial" panose="020B0604020202020204"/>
               </a:rPr>
               <a:t>Click to move the slide</a:t>
             </a:r>
-            <a:endParaRPr b="0" lang="en-US" sz="4400" spc="-1" strike="noStrike">
-              <a:solidFill>
-                <a:srgbClr val="000000"/>
-              </a:solidFill>
-              <a:latin typeface="Arial"/>
+            <a:endParaRPr lang="en-US" sz="4400" b="0" strike="noStrike" spc="-1">
+              <a:solidFill>
+                <a:srgbClr val="000000"/>
+              </a:solidFill>
+              <a:latin typeface="Arial" panose="020B0604020202020204"/>
             </a:endParaRPr>
           </a:p>
         </p:txBody>
@@ -103,27 +201,27 @@
           </a:ln>
         </p:spPr>
         <p:txBody>
-          <a:bodyPr lIns="0" rIns="0" tIns="0" bIns="0" anchor="t">
+          <a:bodyPr lIns="0" tIns="0" rIns="0" bIns="0" anchor="t">
             <a:noAutofit/>
           </a:bodyPr>
           <a:p>
-            <a:pPr marL="216000" indent="-216000">
+            <a:pPr marL="215900" indent="-215900">
               <a:buNone/>
             </a:pPr>
             <a:r>
-              <a:rPr b="0" lang="en-US" sz="2000" spc="-1" strike="noStrike">
-                <a:solidFill>
-                  <a:srgbClr val="000000"/>
-                </a:solidFill>
-                <a:latin typeface="Arial"/>
+              <a:rPr lang="en-US" sz="2000" b="0" strike="noStrike" spc="-1">
+                <a:solidFill>
+                  <a:srgbClr val="000000"/>
+                </a:solidFill>
+                <a:latin typeface="Arial" panose="020B0604020202020204"/>
               </a:rPr>
               <a:t>Click to edit the notes format</a:t>
             </a:r>
-            <a:endParaRPr b="0" lang="en-US" sz="2000" spc="-1" strike="noStrike">
-              <a:solidFill>
-                <a:srgbClr val="000000"/>
-              </a:solidFill>
-              <a:latin typeface="Arial"/>
+            <a:endParaRPr lang="en-US" sz="2000" b="0" strike="noStrike" spc="-1">
+              <a:solidFill>
+                <a:srgbClr val="000000"/>
+              </a:solidFill>
+              <a:latin typeface="Arial" panose="020B0604020202020204"/>
             </a:endParaRPr>
           </a:p>
         </p:txBody>
@@ -152,7 +250,7 @@
           </a:ln>
         </p:spPr>
         <p:txBody>
-          <a:bodyPr lIns="0" rIns="0" tIns="0" bIns="0" anchor="t">
+          <a:bodyPr lIns="0" tIns="0" rIns="0" bIns="0" anchor="t">
             <a:noAutofit/>
           </a:bodyPr>
           <a:p>
@@ -160,19 +258,19 @@
               <a:buNone/>
             </a:pPr>
             <a:r>
-              <a:rPr b="0" lang="en-US" sz="1400" spc="-1" strike="noStrike">
-                <a:solidFill>
-                  <a:srgbClr val="000000"/>
-                </a:solidFill>
-                <a:latin typeface="Times New Roman"/>
+              <a:rPr lang="en-US" sz="1400" b="0" strike="noStrike" spc="-1">
+                <a:solidFill>
+                  <a:srgbClr val="000000"/>
+                </a:solidFill>
+                <a:latin typeface="Times New Roman" panose="02020603050405020304"/>
               </a:rPr>
               <a:t>&lt;header&gt;</a:t>
             </a:r>
-            <a:endParaRPr b="0" lang="en-US" sz="1400" spc="-1" strike="noStrike">
-              <a:solidFill>
-                <a:srgbClr val="000000"/>
-              </a:solidFill>
-              <a:latin typeface="Times New Roman"/>
+            <a:endParaRPr lang="en-US" sz="1400" b="0" strike="noStrike" spc="-1">
+              <a:solidFill>
+                <a:srgbClr val="000000"/>
+              </a:solidFill>
+              <a:latin typeface="Times New Roman" panose="02020603050405020304"/>
             </a:endParaRPr>
           </a:p>
         </p:txBody>
@@ -201,17 +299,17 @@
           </a:ln>
         </p:spPr>
         <p:txBody>
-          <a:bodyPr lIns="0" rIns="0" tIns="0" bIns="0" anchor="t">
+          <a:bodyPr lIns="0" tIns="0" rIns="0" bIns="0" anchor="t">
             <a:noAutofit/>
           </a:bodyPr>
           <a:lstStyle>
             <a:lvl1pPr indent="0" algn="r">
               <a:buNone/>
-              <a:defRPr b="0" lang="en-US" sz="1400" spc="-1" strike="noStrike">
-                <a:solidFill>
-                  <a:srgbClr val="000000"/>
-                </a:solidFill>
-                <a:latin typeface="Times New Roman"/>
+              <a:defRPr lang="en-US" sz="1400" b="0" strike="noStrike" spc="-1">
+                <a:solidFill>
+                  <a:srgbClr val="000000"/>
+                </a:solidFill>
+                <a:latin typeface="Times New Roman" panose="02020603050405020304"/>
               </a:defRPr>
             </a:lvl1pPr>
           </a:lstStyle>
@@ -220,19 +318,19 @@
               <a:buNone/>
             </a:pPr>
             <a:r>
-              <a:rPr b="0" lang="en-US" sz="1400" spc="-1" strike="noStrike">
-                <a:solidFill>
-                  <a:srgbClr val="000000"/>
-                </a:solidFill>
-                <a:latin typeface="Times New Roman"/>
+              <a:rPr lang="en-US" sz="1400" b="0" strike="noStrike" spc="-1">
+                <a:solidFill>
+                  <a:srgbClr val="000000"/>
+                </a:solidFill>
+                <a:latin typeface="Times New Roman" panose="02020603050405020304"/>
               </a:rPr>
               <a:t>&lt;date/time&gt;</a:t>
             </a:r>
-            <a:endParaRPr b="0" lang="en-US" sz="1400" spc="-1" strike="noStrike">
-              <a:solidFill>
-                <a:srgbClr val="000000"/>
-              </a:solidFill>
-              <a:latin typeface="Times New Roman"/>
+            <a:endParaRPr lang="en-US" sz="1400" b="0" strike="noStrike" spc="-1">
+              <a:solidFill>
+                <a:srgbClr val="000000"/>
+              </a:solidFill>
+              <a:latin typeface="Times New Roman" panose="02020603050405020304"/>
             </a:endParaRPr>
           </a:p>
         </p:txBody>
@@ -261,17 +359,17 @@
           </a:ln>
         </p:spPr>
         <p:txBody>
-          <a:bodyPr lIns="0" rIns="0" tIns="0" bIns="0" anchor="b">
+          <a:bodyPr lIns="0" tIns="0" rIns="0" bIns="0" anchor="b">
             <a:noAutofit/>
           </a:bodyPr>
           <a:lstStyle>
             <a:lvl1pPr indent="0">
               <a:buNone/>
-              <a:defRPr b="0" lang="en-US" sz="1400" spc="-1" strike="noStrike">
-                <a:solidFill>
-                  <a:srgbClr val="000000"/>
-                </a:solidFill>
-                <a:latin typeface="Times New Roman"/>
+              <a:defRPr lang="en-US" sz="1400" b="0" strike="noStrike" spc="-1">
+                <a:solidFill>
+                  <a:srgbClr val="000000"/>
+                </a:solidFill>
+                <a:latin typeface="Times New Roman" panose="02020603050405020304"/>
               </a:defRPr>
             </a:lvl1pPr>
           </a:lstStyle>
@@ -280,19 +378,19 @@
               <a:buNone/>
             </a:pPr>
             <a:r>
-              <a:rPr b="0" lang="en-US" sz="1400" spc="-1" strike="noStrike">
-                <a:solidFill>
-                  <a:srgbClr val="000000"/>
-                </a:solidFill>
-                <a:latin typeface="Times New Roman"/>
+              <a:rPr lang="en-US" sz="1400" b="0" strike="noStrike" spc="-1">
+                <a:solidFill>
+                  <a:srgbClr val="000000"/>
+                </a:solidFill>
+                <a:latin typeface="Times New Roman" panose="02020603050405020304"/>
               </a:rPr>
               <a:t>&lt;footer&gt;</a:t>
             </a:r>
-            <a:endParaRPr b="0" lang="en-US" sz="1400" spc="-1" strike="noStrike">
-              <a:solidFill>
-                <a:srgbClr val="000000"/>
-              </a:solidFill>
-              <a:latin typeface="Times New Roman"/>
+            <a:endParaRPr lang="en-US" sz="1400" b="0" strike="noStrike" spc="-1">
+              <a:solidFill>
+                <a:srgbClr val="000000"/>
+              </a:solidFill>
+              <a:latin typeface="Times New Roman" panose="02020603050405020304"/>
             </a:endParaRPr>
           </a:p>
         </p:txBody>
@@ -321,17 +419,17 @@
           </a:ln>
         </p:spPr>
         <p:txBody>
-          <a:bodyPr lIns="0" rIns="0" tIns="0" bIns="0" anchor="b">
+          <a:bodyPr lIns="0" tIns="0" rIns="0" bIns="0" anchor="b">
             <a:noAutofit/>
           </a:bodyPr>
           <a:lstStyle>
             <a:lvl1pPr indent="0" algn="r">
               <a:buNone/>
-              <a:defRPr b="0" lang="en-US" sz="1400" spc="-1" strike="noStrike">
-                <a:solidFill>
-                  <a:srgbClr val="000000"/>
-                </a:solidFill>
-                <a:latin typeface="Times New Roman"/>
+              <a:defRPr lang="en-US" sz="1400" b="0" strike="noStrike" spc="-1">
+                <a:solidFill>
+                  <a:srgbClr val="000000"/>
+                </a:solidFill>
+                <a:latin typeface="Times New Roman" panose="02020603050405020304"/>
               </a:defRPr>
             </a:lvl1pPr>
           </a:lstStyle>
@@ -340,31 +438,31 @@
               <a:buNone/>
             </a:pPr>
             <a:fld id="{6AC63BDB-8897-44C1-B00C-2A9DD42156EC}" type="slidenum">
-              <a:rPr b="0" lang="en-US" sz="1400" spc="-1" strike="noStrike">
-                <a:solidFill>
-                  <a:srgbClr val="000000"/>
-                </a:solidFill>
-                <a:latin typeface="Times New Roman"/>
-              </a:rPr>
-              <a:t>&lt;number&gt;</a:t>
+              <a:rPr lang="en-US" sz="1400" b="0" strike="noStrike" spc="-1">
+                <a:solidFill>
+                  <a:srgbClr val="000000"/>
+                </a:solidFill>
+                <a:latin typeface="Times New Roman" panose="02020603050405020304"/>
+              </a:rPr>
             </a:fld>
-            <a:endParaRPr b="0" lang="en-US" sz="1400" spc="-1" strike="noStrike">
-              <a:solidFill>
-                <a:srgbClr val="000000"/>
-              </a:solidFill>
-              <a:latin typeface="Times New Roman"/>
+            <a:endParaRPr lang="en-US" sz="1400" b="0" strike="noStrike" spc="-1">
+              <a:solidFill>
+                <a:srgbClr val="000000"/>
+              </a:solidFill>
+              <a:latin typeface="Times New Roman" panose="02020603050405020304"/>
             </a:endParaRPr>
           </a:p>
         </p:txBody>
       </p:sp>
     </p:spTree>
   </p:cSld>
-  <p:clrMap bg1="lt1" bg2="lt2" tx1="dk1" tx2="dk2" accent1="accent1" accent2="accent2" accent3="accent3" accent4="accent4" accent5="accent5" accent6="accent6" hlink="hlink" folHlink="folHlink"/>
+  <p:clrMap bg1="lt1" tx1="dk1" bg2="lt2" tx2="dk2" accent1="accent1" accent2="accent2" accent3="accent3" accent4="accent4" accent5="accent5" accent6="accent6" hlink="hlink" folHlink="folHlink"/>
+  <p:notesStyle/>
 </p:notesMaster>
 </file>
 
 <file path=ppt/notesSlides/notesSlide1.xml><?xml version="1.0" encoding="utf-8"?>
-<p:notes xmlns:a="http://schemas.openxmlformats.org/drawingml/2006/main" xmlns:p="http://schemas.openxmlformats.org/presentationml/2006/main" xmlns:r="http://schemas.openxmlformats.org/officeDocument/2006/relationships" xmlns:p14="http://schemas.microsoft.com/office/powerpoint/2010/main" xmlns:p15="http://schemas.microsoft.com/office/powerpoint/2012/main" xmlns:mc="http://schemas.openxmlformats.org/markup-compatibility/2006">
+<p:notes xmlns:a="http://schemas.openxmlformats.org/drawingml/2006/main" xmlns:r="http://schemas.openxmlformats.org/officeDocument/2006/relationships" xmlns:p="http://schemas.openxmlformats.org/presentationml/2006/main">
   <p:cSld>
     <p:spTree>
       <p:nvGrpSpPr>
@@ -427,127 +525,127 @@
           </a:ln>
         </p:spPr>
         <p:txBody>
-          <a:bodyPr lIns="91440" rIns="91440" tIns="91440" bIns="91440" anchor="t">
+          <a:bodyPr lIns="91440" tIns="91440" rIns="91440" bIns="91440" anchor="t">
             <a:noAutofit/>
           </a:bodyPr>
           <a:p>
-            <a:pPr marL="216000" indent="0">
+            <a:pPr marL="215900" indent="0">
               <a:lnSpc>
                 <a:spcPct val="100000"/>
               </a:lnSpc>
               <a:buNone/>
               <a:tabLst>
-                <a:tab algn="l" pos="0"/>
+                <a:tab pos="0" algn="l"/>
               </a:tabLst>
             </a:pPr>
             <a:r>
-              <a:rPr b="0" lang="en-US" sz="1100" spc="-1" strike="noStrike">
-                <a:solidFill>
-                  <a:srgbClr val="000000"/>
-                </a:solidFill>
-                <a:latin typeface="Arial"/>
+              <a:rPr lang="en-US" sz="1100" b="0" strike="noStrike" spc="-1">
+                <a:solidFill>
+                  <a:srgbClr val="000000"/>
+                </a:solidFill>
+                <a:latin typeface="Arial" panose="020B0604020202020204"/>
               </a:rPr>
               <a:t>Notes</a:t>
             </a:r>
-            <a:endParaRPr b="0" lang="en-US" sz="1100" spc="-1" strike="noStrike">
-              <a:solidFill>
-                <a:srgbClr val="000000"/>
-              </a:solidFill>
-              <a:latin typeface="Arial"/>
-            </a:endParaRPr>
-          </a:p>
-          <a:p>
-            <a:pPr marL="171360" indent="-171360">
+            <a:endParaRPr lang="en-US" sz="1100" b="0" strike="noStrike" spc="-1">
+              <a:solidFill>
+                <a:srgbClr val="000000"/>
+              </a:solidFill>
+              <a:latin typeface="Arial" panose="020B0604020202020204"/>
+            </a:endParaRPr>
+          </a:p>
+          <a:p>
+            <a:pPr marL="171450" indent="-171450">
               <a:lnSpc>
                 <a:spcPct val="100000"/>
               </a:lnSpc>
               <a:buClr>
                 <a:srgbClr val="000000"/>
               </a:buClr>
-              <a:buFont typeface="Wingdings" charset="2"/>
+              <a:buFont typeface="Wingdings" panose="05000000000000000000" pitchFamily="2" charset="2"/>
               <a:buChar char=""/>
               <a:tabLst>
-                <a:tab algn="l" pos="0"/>
+                <a:tab pos="0" algn="l"/>
               </a:tabLst>
             </a:pPr>
             <a:r>
-              <a:rPr b="0" lang="en-US" sz="1100" spc="-1" strike="noStrike">
-                <a:solidFill>
-                  <a:srgbClr val="000000"/>
-                </a:solidFill>
-                <a:latin typeface="Arial"/>
+              <a:rPr lang="en-US" sz="1100" b="0" strike="noStrike" spc="-1">
+                <a:solidFill>
+                  <a:srgbClr val="000000"/>
+                </a:solidFill>
+                <a:latin typeface="Arial" panose="020B0604020202020204"/>
               </a:rPr>
               <a:t>Accomplishments:  These should be high level and focus on what you accomplished in the past week.</a:t>
             </a:r>
-            <a:endParaRPr b="0" lang="en-US" sz="1100" spc="-1" strike="noStrike">
-              <a:solidFill>
-                <a:srgbClr val="000000"/>
-              </a:solidFill>
-              <a:latin typeface="Arial"/>
-            </a:endParaRPr>
-          </a:p>
-          <a:p>
-            <a:pPr marL="171360" indent="-171360">
+            <a:endParaRPr lang="en-US" sz="1100" b="0" strike="noStrike" spc="-1">
+              <a:solidFill>
+                <a:srgbClr val="000000"/>
+              </a:solidFill>
+              <a:latin typeface="Arial" panose="020B0604020202020204"/>
+            </a:endParaRPr>
+          </a:p>
+          <a:p>
+            <a:pPr marL="171450" indent="-171450">
               <a:lnSpc>
                 <a:spcPct val="100000"/>
               </a:lnSpc>
               <a:buClr>
                 <a:srgbClr val="000000"/>
               </a:buClr>
-              <a:buFont typeface="Wingdings" charset="2"/>
+              <a:buFont typeface="Wingdings" panose="05000000000000000000" pitchFamily="2" charset="2"/>
               <a:buChar char=""/>
               <a:tabLst>
-                <a:tab algn="l" pos="0"/>
+                <a:tab pos="0" algn="l"/>
               </a:tabLst>
             </a:pPr>
             <a:r>
-              <a:rPr b="0" lang="en-US" sz="1100" spc="-1" strike="noStrike">
-                <a:solidFill>
-                  <a:srgbClr val="000000"/>
-                </a:solidFill>
-                <a:latin typeface="Arial"/>
+              <a:rPr lang="en-US" sz="1100" b="0" strike="noStrike" spc="-1">
+                <a:solidFill>
+                  <a:srgbClr val="000000"/>
+                </a:solidFill>
+                <a:latin typeface="Arial" panose="020B0604020202020204"/>
               </a:rPr>
               <a:t>Plans for the Week: Focus on the tasks you will be working on this week</a:t>
             </a:r>
-            <a:endParaRPr b="0" lang="en-US" sz="1100" spc="-1" strike="noStrike">
-              <a:solidFill>
-                <a:srgbClr val="000000"/>
-              </a:solidFill>
-              <a:latin typeface="Arial"/>
-            </a:endParaRPr>
-          </a:p>
-          <a:p>
-            <a:pPr marL="171360" indent="-171360">
+            <a:endParaRPr lang="en-US" sz="1100" b="0" strike="noStrike" spc="-1">
+              <a:solidFill>
+                <a:srgbClr val="000000"/>
+              </a:solidFill>
+              <a:latin typeface="Arial" panose="020B0604020202020204"/>
+            </a:endParaRPr>
+          </a:p>
+          <a:p>
+            <a:pPr marL="171450" indent="-171450">
               <a:lnSpc>
                 <a:spcPct val="100000"/>
               </a:lnSpc>
               <a:buClr>
                 <a:srgbClr val="000000"/>
               </a:buClr>
-              <a:buFont typeface="Wingdings" charset="2"/>
+              <a:buFont typeface="Wingdings" panose="05000000000000000000" pitchFamily="2" charset="2"/>
               <a:buChar char=""/>
               <a:tabLst>
-                <a:tab algn="l" pos="0"/>
+                <a:tab pos="0" algn="l"/>
               </a:tabLst>
             </a:pPr>
             <a:r>
-              <a:rPr b="0" lang="en-US" sz="1100" spc="-1" strike="noStrike">
-                <a:solidFill>
-                  <a:srgbClr val="000000"/>
-                </a:solidFill>
-                <a:latin typeface="Arial"/>
+              <a:rPr lang="en-US" sz="1100" b="0" strike="noStrike" spc="-1">
+                <a:solidFill>
+                  <a:srgbClr val="000000"/>
+                </a:solidFill>
+                <a:latin typeface="Arial" panose="020B0604020202020204"/>
               </a:rPr>
               <a:t>Issue Impeding Progress:  </a:t>
             </a:r>
-            <a:endParaRPr b="0" lang="en-US" sz="1100" spc="-1" strike="noStrike">
-              <a:solidFill>
-                <a:srgbClr val="000000"/>
-              </a:solidFill>
-              <a:latin typeface="Arial"/>
-            </a:endParaRPr>
-          </a:p>
-          <a:p>
-            <a:pPr lvl="1" marL="628560" indent="-171360">
+            <a:endParaRPr lang="en-US" sz="1100" b="0" strike="noStrike" spc="-1">
+              <a:solidFill>
+                <a:srgbClr val="000000"/>
+              </a:solidFill>
+              <a:latin typeface="Arial" panose="020B0604020202020204"/>
+            </a:endParaRPr>
+          </a:p>
+          <a:p>
+            <a:pPr marL="628650" lvl="1" indent="-171450">
               <a:lnSpc>
                 <a:spcPct val="100000"/>
               </a:lnSpc>
@@ -557,27 +655,27 @@
               <a:buFont typeface="Wingdings 2" charset="2"/>
               <a:buChar char=""/>
               <a:tabLst>
-                <a:tab algn="l" pos="0"/>
+                <a:tab pos="0" algn="l"/>
               </a:tabLst>
             </a:pPr>
             <a:r>
-              <a:rPr b="0" lang="en-US" sz="1100" spc="-1" strike="noStrike">
-                <a:solidFill>
-                  <a:srgbClr val="000000"/>
-                </a:solidFill>
-                <a:latin typeface="Arial"/>
+              <a:rPr lang="en-US" sz="1100" b="0" strike="noStrike" spc="-1">
+                <a:solidFill>
+                  <a:srgbClr val="000000"/>
+                </a:solidFill>
+                <a:latin typeface="Arial" panose="020B0604020202020204"/>
               </a:rPr>
               <a:t>List any items that are blocking your tasks.  </a:t>
             </a:r>
-            <a:endParaRPr b="0" lang="en-US" sz="1100" spc="-1" strike="noStrike">
-              <a:solidFill>
-                <a:srgbClr val="000000"/>
-              </a:solidFill>
-              <a:latin typeface="Arial"/>
-            </a:endParaRPr>
-          </a:p>
-          <a:p>
-            <a:pPr lvl="1" marL="628560" indent="-171360">
+            <a:endParaRPr lang="en-US" sz="1100" b="0" strike="noStrike" spc="-1">
+              <a:solidFill>
+                <a:srgbClr val="000000"/>
+              </a:solidFill>
+              <a:latin typeface="Arial" panose="020B0604020202020204"/>
+            </a:endParaRPr>
+          </a:p>
+          <a:p>
+            <a:pPr marL="628650" lvl="1" indent="-171450">
               <a:lnSpc>
                 <a:spcPct val="100000"/>
               </a:lnSpc>
@@ -587,27 +685,27 @@
               <a:buFont typeface="Wingdings 2" charset="2"/>
               <a:buChar char=""/>
               <a:tabLst>
-                <a:tab algn="l" pos="0"/>
+                <a:tab pos="0" algn="l"/>
               </a:tabLst>
             </a:pPr>
             <a:r>
-              <a:rPr b="0" lang="en-US" sz="1100" spc="-1" strike="noStrike">
-                <a:solidFill>
-                  <a:srgbClr val="000000"/>
-                </a:solidFill>
-                <a:latin typeface="Arial"/>
+              <a:rPr lang="en-US" sz="1100" b="0" strike="noStrike" spc="-1">
+                <a:solidFill>
+                  <a:srgbClr val="000000"/>
+                </a:solidFill>
+                <a:latin typeface="Arial" panose="020B0604020202020204"/>
               </a:rPr>
               <a:t>Specifically focus on what you need from others.</a:t>
             </a:r>
-            <a:endParaRPr b="0" lang="en-US" sz="1100" spc="-1" strike="noStrike">
-              <a:solidFill>
-                <a:srgbClr val="000000"/>
-              </a:solidFill>
-              <a:latin typeface="Arial"/>
-            </a:endParaRPr>
-          </a:p>
-          <a:p>
-            <a:pPr lvl="1" marL="628560" indent="-171360">
+            <a:endParaRPr lang="en-US" sz="1100" b="0" strike="noStrike" spc="-1">
+              <a:solidFill>
+                <a:srgbClr val="000000"/>
+              </a:solidFill>
+              <a:latin typeface="Arial" panose="020B0604020202020204"/>
+            </a:endParaRPr>
+          </a:p>
+          <a:p>
+            <a:pPr marL="628650" lvl="1" indent="-171450">
               <a:lnSpc>
                 <a:spcPct val="100000"/>
               </a:lnSpc>
@@ -617,57 +715,57 @@
               <a:buFont typeface="Wingdings 2" charset="2"/>
               <a:buChar char=""/>
               <a:tabLst>
-                <a:tab algn="l" pos="0"/>
+                <a:tab pos="0" algn="l"/>
               </a:tabLst>
             </a:pPr>
             <a:r>
-              <a:rPr b="0" lang="en-US" sz="1100" spc="-1" strike="noStrike">
-                <a:solidFill>
-                  <a:srgbClr val="000000"/>
-                </a:solidFill>
-                <a:latin typeface="Arial"/>
+              <a:rPr lang="en-US" sz="1100" b="0" strike="noStrike" spc="-1">
+                <a:solidFill>
+                  <a:srgbClr val="000000"/>
+                </a:solidFill>
+                <a:latin typeface="Arial" panose="020B0604020202020204"/>
               </a:rPr>
               <a:t>You don’t need to list items such as other classes where others cannot help resolve the issue</a:t>
             </a:r>
-            <a:endParaRPr b="0" lang="en-US" sz="1100" spc="-1" strike="noStrike">
-              <a:solidFill>
-                <a:srgbClr val="000000"/>
-              </a:solidFill>
-              <a:latin typeface="Arial"/>
-            </a:endParaRPr>
-          </a:p>
-          <a:p>
-            <a:pPr marL="171360" indent="-171360">
+            <a:endParaRPr lang="en-US" sz="1100" b="0" strike="noStrike" spc="-1">
+              <a:solidFill>
+                <a:srgbClr val="000000"/>
+              </a:solidFill>
+              <a:latin typeface="Arial" panose="020B0604020202020204"/>
+            </a:endParaRPr>
+          </a:p>
+          <a:p>
+            <a:pPr marL="171450" indent="-171450">
               <a:lnSpc>
                 <a:spcPct val="100000"/>
               </a:lnSpc>
               <a:buClr>
                 <a:srgbClr val="000000"/>
               </a:buClr>
-              <a:buFont typeface="Wingdings" charset="2"/>
+              <a:buFont typeface="Wingdings" panose="05000000000000000000" pitchFamily="2" charset="2"/>
               <a:buChar char=""/>
               <a:tabLst>
-                <a:tab algn="l" pos="0"/>
+                <a:tab pos="0" algn="l"/>
               </a:tabLst>
             </a:pPr>
             <a:r>
-              <a:rPr b="0" lang="en-US" sz="1100" spc="-1" strike="noStrike">
-                <a:solidFill>
-                  <a:srgbClr val="000000"/>
-                </a:solidFill>
-                <a:latin typeface="Arial"/>
+              <a:rPr lang="en-US" sz="1100" b="0" strike="noStrike" spc="-1">
+                <a:solidFill>
+                  <a:srgbClr val="000000"/>
+                </a:solidFill>
+                <a:latin typeface="Arial" panose="020B0604020202020204"/>
               </a:rPr>
               <a:t>Upcoming deliverables</a:t>
             </a:r>
-            <a:endParaRPr b="0" lang="en-US" sz="1100" spc="-1" strike="noStrike">
-              <a:solidFill>
-                <a:srgbClr val="000000"/>
-              </a:solidFill>
-              <a:latin typeface="Arial"/>
-            </a:endParaRPr>
-          </a:p>
-          <a:p>
-            <a:pPr lvl="1" marL="628560" indent="-171360">
+            <a:endParaRPr lang="en-US" sz="1100" b="0" strike="noStrike" spc="-1">
+              <a:solidFill>
+                <a:srgbClr val="000000"/>
+              </a:solidFill>
+              <a:latin typeface="Arial" panose="020B0604020202020204"/>
+            </a:endParaRPr>
+          </a:p>
+          <a:p>
+            <a:pPr marL="628650" lvl="1" indent="-171450">
               <a:lnSpc>
                 <a:spcPct val="100000"/>
               </a:lnSpc>
@@ -677,27 +775,27 @@
               <a:buFont typeface="Wingdings 2" charset="2"/>
               <a:buChar char=""/>
               <a:tabLst>
-                <a:tab algn="l" pos="0"/>
+                <a:tab pos="0" algn="l"/>
               </a:tabLst>
             </a:pPr>
             <a:r>
-              <a:rPr b="0" lang="en-US" sz="1100" spc="-1" strike="noStrike">
-                <a:solidFill>
-                  <a:srgbClr val="000000"/>
-                </a:solidFill>
-                <a:latin typeface="Arial"/>
+              <a:rPr lang="en-US" sz="1100" b="0" strike="noStrike" spc="-1">
+                <a:solidFill>
+                  <a:srgbClr val="000000"/>
+                </a:solidFill>
+                <a:latin typeface="Arial" panose="020B0604020202020204"/>
               </a:rPr>
               <a:t>In this section you should provide a longer term (4 week) forward looking view</a:t>
             </a:r>
-            <a:endParaRPr b="0" lang="en-US" sz="1100" spc="-1" strike="noStrike">
-              <a:solidFill>
-                <a:srgbClr val="000000"/>
-              </a:solidFill>
-              <a:latin typeface="Arial"/>
-            </a:endParaRPr>
-          </a:p>
-          <a:p>
-            <a:pPr lvl="1" marL="628560" indent="-171360">
+            <a:endParaRPr lang="en-US" sz="1100" b="0" strike="noStrike" spc="-1">
+              <a:solidFill>
+                <a:srgbClr val="000000"/>
+              </a:solidFill>
+              <a:latin typeface="Arial" panose="020B0604020202020204"/>
+            </a:endParaRPr>
+          </a:p>
+          <a:p>
+            <a:pPr marL="628650" lvl="1" indent="-171450">
               <a:lnSpc>
                 <a:spcPct val="100000"/>
               </a:lnSpc>
@@ -707,23 +805,23 @@
               <a:buFont typeface="Wingdings 2" charset="2"/>
               <a:buChar char=""/>
               <a:tabLst>
-                <a:tab algn="l" pos="0"/>
+                <a:tab pos="0" algn="l"/>
               </a:tabLst>
             </a:pPr>
             <a:r>
-              <a:rPr b="0" lang="en-US" sz="1100" spc="-1" strike="noStrike">
-                <a:solidFill>
-                  <a:srgbClr val="000000"/>
-                </a:solidFill>
-                <a:latin typeface="Arial"/>
+              <a:rPr lang="en-US" sz="1100" b="0" strike="noStrike" spc="-1">
+                <a:solidFill>
+                  <a:srgbClr val="000000"/>
+                </a:solidFill>
+                <a:latin typeface="Arial" panose="020B0604020202020204"/>
               </a:rPr>
               <a:t>What are the key items on your schedule that need to be completed in the next month</a:t>
             </a:r>
-            <a:endParaRPr b="0" lang="en-US" sz="1100" spc="-1" strike="noStrike">
-              <a:solidFill>
-                <a:srgbClr val="000000"/>
-              </a:solidFill>
-              <a:latin typeface="Arial"/>
+            <a:endParaRPr lang="en-US" sz="1100" b="0" strike="noStrike" spc="-1">
+              <a:solidFill>
+                <a:srgbClr val="000000"/>
+              </a:solidFill>
+              <a:latin typeface="Arial" panose="020B0604020202020204"/>
             </a:endParaRPr>
           </a:p>
           <a:p>
@@ -733,14 +831,14 @@
               </a:lnSpc>
               <a:buNone/>
               <a:tabLst>
-                <a:tab algn="l" pos="0"/>
+                <a:tab pos="0" algn="l"/>
               </a:tabLst>
             </a:pPr>
-            <a:endParaRPr b="0" lang="en-US" sz="1100" spc="-1" strike="noStrike">
-              <a:solidFill>
-                <a:srgbClr val="000000"/>
-              </a:solidFill>
-              <a:latin typeface="Arial"/>
+            <a:endParaRPr lang="en-US" sz="1100" b="0" strike="noStrike" spc="-1">
+              <a:solidFill>
+                <a:srgbClr val="000000"/>
+              </a:solidFill>
+              <a:latin typeface="Arial" panose="020B0604020202020204"/>
             </a:endParaRPr>
           </a:p>
           <a:p>
@@ -750,27 +848,27 @@
               </a:lnSpc>
               <a:buNone/>
               <a:tabLst>
-                <a:tab algn="l" pos="0"/>
+                <a:tab pos="0" algn="l"/>
               </a:tabLst>
             </a:pPr>
             <a:r>
-              <a:rPr b="0" lang="en-US" sz="1100" spc="-1" strike="noStrike">
-                <a:solidFill>
-                  <a:srgbClr val="000000"/>
-                </a:solidFill>
-                <a:latin typeface="Arial"/>
+              <a:rPr lang="en-US" sz="1100" b="0" strike="noStrike" spc="-1">
+                <a:solidFill>
+                  <a:srgbClr val="000000"/>
+                </a:solidFill>
+                <a:latin typeface="Arial" panose="020B0604020202020204"/>
               </a:rPr>
               <a:t>Color Code</a:t>
             </a:r>
-            <a:endParaRPr b="0" lang="en-US" sz="1100" spc="-1" strike="noStrike">
-              <a:solidFill>
-                <a:srgbClr val="000000"/>
-              </a:solidFill>
-              <a:latin typeface="Arial"/>
-            </a:endParaRPr>
-          </a:p>
-          <a:p>
-            <a:pPr lvl="1" marL="628560" indent="-171360">
+            <a:endParaRPr lang="en-US" sz="1100" b="0" strike="noStrike" spc="-1">
+              <a:solidFill>
+                <a:srgbClr val="000000"/>
+              </a:solidFill>
+              <a:latin typeface="Arial" panose="020B0604020202020204"/>
+            </a:endParaRPr>
+          </a:p>
+          <a:p>
+            <a:pPr marL="628650" lvl="1" indent="-171450">
               <a:lnSpc>
                 <a:spcPct val="100000"/>
               </a:lnSpc>
@@ -780,27 +878,27 @@
               <a:buFont typeface="Wingdings 2" charset="2"/>
               <a:buChar char=""/>
               <a:tabLst>
-                <a:tab algn="l" pos="0"/>
+                <a:tab pos="0" algn="l"/>
               </a:tabLst>
             </a:pPr>
             <a:r>
-              <a:rPr b="0" lang="en-US" sz="1100" spc="-1" strike="noStrike">
-                <a:solidFill>
-                  <a:srgbClr val="000000"/>
-                </a:solidFill>
-                <a:latin typeface="Arial"/>
+              <a:rPr lang="en-US" sz="1100" b="0" strike="noStrike" spc="-1">
+                <a:solidFill>
+                  <a:srgbClr val="000000"/>
+                </a:solidFill>
+                <a:latin typeface="Arial" panose="020B0604020202020204"/>
               </a:rPr>
               <a:t>Green – overall on track and deliverables on track for upcoming deliverables</a:t>
             </a:r>
-            <a:endParaRPr b="0" lang="en-US" sz="1100" spc="-1" strike="noStrike">
-              <a:solidFill>
-                <a:srgbClr val="000000"/>
-              </a:solidFill>
-              <a:latin typeface="Arial"/>
-            </a:endParaRPr>
-          </a:p>
-          <a:p>
-            <a:pPr lvl="1" marL="628560" indent="-171360">
+            <a:endParaRPr lang="en-US" sz="1100" b="0" strike="noStrike" spc="-1">
+              <a:solidFill>
+                <a:srgbClr val="000000"/>
+              </a:solidFill>
+              <a:latin typeface="Arial" panose="020B0604020202020204"/>
+            </a:endParaRPr>
+          </a:p>
+          <a:p>
+            <a:pPr marL="628650" lvl="1" indent="-171450">
               <a:lnSpc>
                 <a:spcPct val="100000"/>
               </a:lnSpc>
@@ -810,27 +908,27 @@
               <a:buFont typeface="Wingdings 2" charset="2"/>
               <a:buChar char=""/>
               <a:tabLst>
-                <a:tab algn="l" pos="0"/>
+                <a:tab pos="0" algn="l"/>
               </a:tabLst>
             </a:pPr>
             <a:r>
-              <a:rPr b="0" lang="en-US" sz="1100" spc="-1" strike="noStrike">
-                <a:solidFill>
-                  <a:srgbClr val="000000"/>
-                </a:solidFill>
-                <a:latin typeface="Arial"/>
+              <a:rPr lang="en-US" sz="1100" b="0" strike="noStrike" spc="-1">
+                <a:solidFill>
+                  <a:srgbClr val="000000"/>
+                </a:solidFill>
+                <a:latin typeface="Arial" panose="020B0604020202020204"/>
               </a:rPr>
               <a:t>Yellow – Concerns about current status and about the ability to deliver current deliverable on time</a:t>
             </a:r>
-            <a:endParaRPr b="0" lang="en-US" sz="1100" spc="-1" strike="noStrike">
-              <a:solidFill>
-                <a:srgbClr val="000000"/>
-              </a:solidFill>
-              <a:latin typeface="Arial"/>
-            </a:endParaRPr>
-          </a:p>
-          <a:p>
-            <a:pPr lvl="1" marL="628560" indent="-171360">
+            <a:endParaRPr lang="en-US" sz="1100" b="0" strike="noStrike" spc="-1">
+              <a:solidFill>
+                <a:srgbClr val="000000"/>
+              </a:solidFill>
+              <a:latin typeface="Arial" panose="020B0604020202020204"/>
+            </a:endParaRPr>
+          </a:p>
+          <a:p>
+            <a:pPr marL="628650" lvl="1" indent="-171450">
               <a:lnSpc>
                 <a:spcPct val="100000"/>
               </a:lnSpc>
@@ -840,23 +938,23 @@
               <a:buFont typeface="Wingdings 2" charset="2"/>
               <a:buChar char=""/>
               <a:tabLst>
-                <a:tab algn="l" pos="0"/>
+                <a:tab pos="0" algn="l"/>
               </a:tabLst>
             </a:pPr>
             <a:r>
-              <a:rPr b="0" lang="en-US" sz="1100" spc="-1" strike="noStrike">
-                <a:solidFill>
-                  <a:srgbClr val="000000"/>
-                </a:solidFill>
-                <a:latin typeface="Arial"/>
+              <a:rPr lang="en-US" sz="1100" b="0" strike="noStrike" spc="-1">
+                <a:solidFill>
+                  <a:srgbClr val="000000"/>
+                </a:solidFill>
+                <a:latin typeface="Arial" panose="020B0604020202020204"/>
               </a:rPr>
               <a:t>Red – “I need help”  things are falling apart and deliverables have missed the planned deadline.</a:t>
             </a:r>
-            <a:endParaRPr b="0" lang="en-US" sz="1100" spc="-1" strike="noStrike">
-              <a:solidFill>
-                <a:srgbClr val="000000"/>
-              </a:solidFill>
-              <a:latin typeface="Arial"/>
+            <a:endParaRPr lang="en-US" sz="1100" b="0" strike="noStrike" spc="-1">
+              <a:solidFill>
+                <a:srgbClr val="000000"/>
+              </a:solidFill>
+              <a:latin typeface="Arial" panose="020B0604020202020204"/>
             </a:endParaRPr>
           </a:p>
           <a:p>
@@ -866,25 +964,28 @@
               </a:lnSpc>
               <a:buNone/>
               <a:tabLst>
-                <a:tab algn="l" pos="0"/>
+                <a:tab pos="0" algn="l"/>
               </a:tabLst>
             </a:pPr>
-            <a:endParaRPr b="0" lang="en-US" sz="1100" spc="-1" strike="noStrike">
-              <a:solidFill>
-                <a:srgbClr val="000000"/>
-              </a:solidFill>
-              <a:latin typeface="Arial"/>
+            <a:endParaRPr lang="en-US" sz="1100" b="0" strike="noStrike" spc="-1">
+              <a:solidFill>
+                <a:srgbClr val="000000"/>
+              </a:solidFill>
+              <a:latin typeface="Arial" panose="020B0604020202020204"/>
             </a:endParaRPr>
           </a:p>
         </p:txBody>
       </p:sp>
     </p:spTree>
   </p:cSld>
+  <p:clrMapOvr>
+    <a:masterClrMapping/>
+  </p:clrMapOvr>
 </p:notes>
 </file>
 
 <file path=ppt/slideLayouts/slideLayout1.xml><?xml version="1.0" encoding="utf-8"?>
-<p:sldLayout xmlns:a="http://schemas.openxmlformats.org/drawingml/2006/main" xmlns:p="http://schemas.openxmlformats.org/presentationml/2006/main" xmlns:r="http://schemas.openxmlformats.org/officeDocument/2006/relationships" xmlns:p14="http://schemas.microsoft.com/office/powerpoint/2010/main" xmlns:p15="http://schemas.microsoft.com/office/powerpoint/2012/main" xmlns:mc="http://schemas.openxmlformats.org/markup-compatibility/2006" type="blank" preserve="1">
+<p:sldLayout xmlns:a="http://schemas.openxmlformats.org/drawingml/2006/main" xmlns:r="http://schemas.openxmlformats.org/officeDocument/2006/relationships" xmlns:p="http://schemas.openxmlformats.org/presentationml/2006/main" type="blank" preserve="1">
   <p:cSld name="TITLE_AND_BODY">
     <p:spTree>
       <p:nvGrpSpPr>
@@ -902,17 +1003,21 @@
       </p:grpSpPr>
     </p:spTree>
   </p:cSld>
+  <p:clrMapOvr>
+    <a:masterClrMapping/>
+  </p:clrMapOvr>
 </p:sldLayout>
 </file>
 
 <file path=ppt/slideMasters/slideMaster1.xml><?xml version="1.0" encoding="utf-8"?>
-<p:sldMaster xmlns:a="http://schemas.openxmlformats.org/drawingml/2006/main" xmlns:p="http://schemas.openxmlformats.org/presentationml/2006/main" xmlns:r="http://schemas.openxmlformats.org/officeDocument/2006/relationships" xmlns:p14="http://schemas.microsoft.com/office/powerpoint/2010/main" xmlns:p15="http://schemas.microsoft.com/office/powerpoint/2012/main" xmlns:mc="http://schemas.openxmlformats.org/markup-compatibility/2006">
+<p:sldMaster xmlns:a="http://schemas.openxmlformats.org/drawingml/2006/main" xmlns:r="http://schemas.openxmlformats.org/officeDocument/2006/relationships" xmlns:p="http://schemas.openxmlformats.org/presentationml/2006/main">
   <p:cSld>
     <p:bg>
       <p:bgPr>
         <a:solidFill>
           <a:schemeClr val="lt1"/>
         </a:solidFill>
+        <a:effectLst/>
       </p:bgPr>
     </p:bg>
     <p:spTree>
@@ -946,13 +1051,13 @@
           <a:gradFill rotWithShape="0">
             <a:gsLst>
               <a:gs pos="0">
-                <a:srgbClr val="f2f2f2"/>
+                <a:srgbClr val="F2F2F2"/>
               </a:gs>
               <a:gs pos="67000">
-                <a:srgbClr val="f2f2f2"/>
+                <a:srgbClr val="F2F2F2"/>
               </a:gs>
               <a:gs pos="100000">
-                <a:srgbClr val="d8d8d8"/>
+                <a:srgbClr val="D8D8D8"/>
               </a:gs>
             </a:gsLst>
             <a:lin ang="5400000"/>
@@ -962,13 +1067,19 @@
           </a:ln>
         </p:spPr>
         <p:style>
-          <a:lnRef idx="0"/>
-          <a:fillRef idx="0"/>
-          <a:effectRef idx="0"/>
+          <a:lnRef idx="0">
+            <a:srgbClr val="FFFFFF"/>
+          </a:lnRef>
+          <a:fillRef idx="0">
+            <a:srgbClr val="FFFFFF"/>
+          </a:fillRef>
+          <a:effectRef idx="0">
+            <a:srgbClr val="FFFFFF"/>
+          </a:effectRef>
           <a:fontRef idx="minor"/>
         </p:style>
         <p:txBody>
-          <a:bodyPr lIns="68400" rIns="68400" tIns="34200" bIns="34200" anchor="t">
+          <a:bodyPr lIns="68400" tIns="34200" rIns="68400" bIns="34200" anchor="t">
             <a:noAutofit/>
           </a:bodyPr>
           <a:p>
@@ -977,31 +1088,31 @@
                 <a:spcPct val="100000"/>
               </a:lnSpc>
               <a:tabLst>
-                <a:tab algn="l" pos="0"/>
+                <a:tab pos="0" algn="l"/>
               </a:tabLst>
             </a:pPr>
             <a:r>
-              <a:rPr b="1" lang="en" sz="1500" spc="-1" strike="noStrike">
-                <a:solidFill>
-                  <a:srgbClr val="000000"/>
-                </a:solidFill>
-                <a:latin typeface="Arial"/>
-                <a:ea typeface="Arial"/>
+              <a:rPr lang="en-GB" sz="1500" b="1" strike="noStrike" spc="-1">
+                <a:solidFill>
+                  <a:srgbClr val="000000"/>
+                </a:solidFill>
+                <a:latin typeface="Arial" panose="020B0604020202020204"/>
+                <a:ea typeface="Arial" panose="020B0604020202020204"/>
               </a:rPr>
               <a:t>Deliverables Tracking</a:t>
             </a:r>
-            <a:endParaRPr b="0" lang="en-US" sz="1500" spc="-1" strike="noStrike">
-              <a:solidFill>
-                <a:srgbClr val="000000"/>
-              </a:solidFill>
-              <a:latin typeface="Arial"/>
+            <a:endParaRPr lang="en-US" sz="1500" b="0" strike="noStrike" spc="-1">
+              <a:solidFill>
+                <a:srgbClr val="000000"/>
+              </a:solidFill>
+              <a:latin typeface="Arial" panose="020B0604020202020204"/>
             </a:endParaRPr>
           </a:p>
         </p:txBody>
       </p:sp>
       <p:sp>
         <p:nvSpPr>
-          <p:cNvPr id="1" name="Google Shape;7;p1"/>
+          <p:cNvPr id="2" name="Google Shape;7;p1"/>
           <p:cNvSpPr/>
           <p:nvPr/>
         </p:nvSpPr>
@@ -1016,13 +1127,13 @@
           <a:gradFill rotWithShape="0">
             <a:gsLst>
               <a:gs pos="0">
-                <a:srgbClr val="f2f2f2"/>
+                <a:srgbClr val="F2F2F2"/>
               </a:gs>
               <a:gs pos="67000">
-                <a:srgbClr val="f2f2f2"/>
+                <a:srgbClr val="F2F2F2"/>
               </a:gs>
               <a:gs pos="100000">
-                <a:srgbClr val="d8d8d8"/>
+                <a:srgbClr val="D8D8D8"/>
               </a:gs>
             </a:gsLst>
             <a:lin ang="5400000"/>
@@ -1032,13 +1143,19 @@
           </a:ln>
         </p:spPr>
         <p:style>
-          <a:lnRef idx="0"/>
-          <a:fillRef idx="0"/>
-          <a:effectRef idx="0"/>
+          <a:lnRef idx="0">
+            <a:srgbClr val="FFFFFF"/>
+          </a:lnRef>
+          <a:fillRef idx="0">
+            <a:srgbClr val="FFFFFF"/>
+          </a:fillRef>
+          <a:effectRef idx="0">
+            <a:srgbClr val="FFFFFF"/>
+          </a:effectRef>
           <a:fontRef idx="minor"/>
         </p:style>
         <p:txBody>
-          <a:bodyPr lIns="68400" rIns="68400" tIns="34200" bIns="34200" anchor="t">
+          <a:bodyPr lIns="68400" tIns="34200" rIns="68400" bIns="34200" anchor="t">
             <a:noAutofit/>
           </a:bodyPr>
           <a:p>
@@ -1047,41 +1164,41 @@
                 <a:spcPct val="100000"/>
               </a:lnSpc>
               <a:tabLst>
-                <a:tab algn="l" pos="0"/>
+                <a:tab pos="0" algn="l"/>
               </a:tabLst>
             </a:pPr>
             <a:r>
-              <a:rPr b="1" lang="en" sz="1500" spc="-1" strike="noStrike">
-                <a:solidFill>
-                  <a:srgbClr val="000000"/>
-                </a:solidFill>
-                <a:latin typeface="Arial"/>
-                <a:ea typeface="Arial"/>
+              <a:rPr lang="en-GB" sz="1500" b="1" strike="noStrike" spc="-1">
+                <a:solidFill>
+                  <a:srgbClr val="000000"/>
+                </a:solidFill>
+                <a:latin typeface="Arial" panose="020B0604020202020204"/>
+                <a:ea typeface="Arial" panose="020B0604020202020204"/>
               </a:rPr>
               <a:t>Plan for the Week</a:t>
             </a:r>
             <a:r>
-              <a:rPr b="1" lang="en" sz="1400" spc="-1" strike="noStrike">
-                <a:solidFill>
-                  <a:srgbClr val="000000"/>
-                </a:solidFill>
-                <a:latin typeface="Arial"/>
+              <a:rPr lang="en-GB" sz="1400" b="1" strike="noStrike" spc="-1">
+                <a:solidFill>
+                  <a:srgbClr val="000000"/>
+                </a:solidFill>
+                <a:latin typeface="Arial" panose="020B0604020202020204"/>
                 <a:ea typeface="Calibri"/>
               </a:rPr>
               <a:t>	</a:t>
             </a:r>
-            <a:endParaRPr b="0" lang="en-US" sz="1400" spc="-1" strike="noStrike">
-              <a:solidFill>
-                <a:srgbClr val="000000"/>
-              </a:solidFill>
-              <a:latin typeface="Arial"/>
+            <a:endParaRPr lang="en-US" sz="1400" b="0" strike="noStrike" spc="-1">
+              <a:solidFill>
+                <a:srgbClr val="000000"/>
+              </a:solidFill>
+              <a:latin typeface="Arial" panose="020B0604020202020204"/>
             </a:endParaRPr>
           </a:p>
         </p:txBody>
       </p:sp>
       <p:cxnSp>
         <p:nvCxnSpPr>
-          <p:cNvPr id="2" name="Google Shape;8;p1"/>
+          <p:cNvPr id="3" name="Google Shape;8;p1"/>
           <p:cNvCxnSpPr/>
           <p:nvPr/>
         </p:nvCxnSpPr>
@@ -1095,7 +1212,7 @@
           </a:prstGeom>
           <a:ln w="28575">
             <a:solidFill>
-              <a:srgbClr val="7f7f7f"/>
+              <a:srgbClr val="7F7F7F"/>
             </a:solidFill>
             <a:round/>
           </a:ln>
@@ -1103,7 +1220,7 @@
       </p:cxnSp>
       <p:sp>
         <p:nvSpPr>
-          <p:cNvPr id="3" name="Google Shape;9;p1"/>
+          <p:cNvPr id="4" name="Google Shape;9;p1"/>
           <p:cNvSpPr/>
           <p:nvPr/>
         </p:nvSpPr>
@@ -1118,13 +1235,13 @@
           <a:gradFill rotWithShape="0">
             <a:gsLst>
               <a:gs pos="0">
-                <a:srgbClr val="f2f2f2"/>
+                <a:srgbClr val="F2F2F2"/>
               </a:gs>
               <a:gs pos="67000">
-                <a:srgbClr val="f2f2f2"/>
+                <a:srgbClr val="F2F2F2"/>
               </a:gs>
               <a:gs pos="100000">
-                <a:srgbClr val="d8d8d8"/>
+                <a:srgbClr val="D8D8D8"/>
               </a:gs>
             </a:gsLst>
             <a:lin ang="5400000"/>
@@ -1134,13 +1251,19 @@
           </a:ln>
         </p:spPr>
         <p:style>
-          <a:lnRef idx="0"/>
-          <a:fillRef idx="0"/>
-          <a:effectRef idx="0"/>
+          <a:lnRef idx="0">
+            <a:srgbClr val="FFFFFF"/>
+          </a:lnRef>
+          <a:fillRef idx="0">
+            <a:srgbClr val="FFFFFF"/>
+          </a:fillRef>
+          <a:effectRef idx="0">
+            <a:srgbClr val="FFFFFF"/>
+          </a:effectRef>
           <a:fontRef idx="minor"/>
         </p:style>
         <p:txBody>
-          <a:bodyPr lIns="68400" rIns="68400" tIns="34200" bIns="34200" anchor="t">
+          <a:bodyPr lIns="68400" tIns="34200" rIns="68400" bIns="34200" anchor="t">
             <a:noAutofit/>
           </a:bodyPr>
           <a:p>
@@ -1149,21 +1272,21 @@
                 <a:spcPct val="100000"/>
               </a:lnSpc>
               <a:tabLst>
-                <a:tab algn="l" pos="0"/>
+                <a:tab pos="0" algn="l"/>
               </a:tabLst>
             </a:pPr>
             <a:r>
-              <a:rPr b="1" lang="en" sz="1500" spc="-1" strike="noStrike">
-                <a:solidFill>
-                  <a:srgbClr val="000000"/>
-                </a:solidFill>
-                <a:latin typeface="Arial"/>
-                <a:ea typeface="Arial"/>
+              <a:rPr lang="en-GB" sz="1500" b="1" strike="noStrike" spc="-1">
+                <a:solidFill>
+                  <a:srgbClr val="000000"/>
+                </a:solidFill>
+                <a:latin typeface="Arial" panose="020B0604020202020204"/>
+                <a:ea typeface="Arial" panose="020B0604020202020204"/>
               </a:rPr>
               <a:t>Issues Impeding Progress</a:t>
             </a:r>
             <a:r>
-              <a:rPr b="1" lang="en" sz="1400" spc="-1" strike="noStrike">
+              <a:rPr lang="en-GB" sz="1400" b="1" strike="noStrike" spc="-1">
                 <a:solidFill>
                   <a:srgbClr val="000000"/>
                 </a:solidFill>
@@ -1172,18 +1295,18 @@
               </a:rPr>
               <a:t>	</a:t>
             </a:r>
-            <a:endParaRPr b="0" lang="en-US" sz="1400" spc="-1" strike="noStrike">
-              <a:solidFill>
-                <a:srgbClr val="000000"/>
-              </a:solidFill>
-              <a:latin typeface="Arial"/>
+            <a:endParaRPr lang="en-US" sz="1400" b="0" strike="noStrike" spc="-1">
+              <a:solidFill>
+                <a:srgbClr val="000000"/>
+              </a:solidFill>
+              <a:latin typeface="Arial" panose="020B0604020202020204"/>
             </a:endParaRPr>
           </a:p>
         </p:txBody>
       </p:sp>
       <p:sp>
         <p:nvSpPr>
-          <p:cNvPr id="4" name="Google Shape;10;p1"/>
+          <p:cNvPr id="5" name="Google Shape;10;p1"/>
           <p:cNvSpPr/>
           <p:nvPr/>
         </p:nvSpPr>
@@ -1198,32 +1321,38 @@
           <a:gradFill rotWithShape="0">
             <a:gsLst>
               <a:gs pos="0">
-                <a:srgbClr val="f2f2f2"/>
+                <a:srgbClr val="F2F2F2"/>
               </a:gs>
               <a:gs pos="67000">
-                <a:srgbClr val="f2f2f2"/>
+                <a:srgbClr val="F2F2F2"/>
               </a:gs>
               <a:gs pos="100000">
-                <a:srgbClr val="d8d8d8"/>
+                <a:srgbClr val="D8D8D8"/>
               </a:gs>
             </a:gsLst>
             <a:lin ang="5400000"/>
           </a:gradFill>
           <a:ln w="9525">
             <a:solidFill>
-              <a:srgbClr val="eeeeee"/>
+              <a:srgbClr val="EEEEEE"/>
             </a:solidFill>
             <a:round/>
           </a:ln>
         </p:spPr>
         <p:style>
-          <a:lnRef idx="0"/>
-          <a:fillRef idx="0"/>
-          <a:effectRef idx="0"/>
+          <a:lnRef idx="0">
+            <a:srgbClr val="FFFFFF"/>
+          </a:lnRef>
+          <a:fillRef idx="0">
+            <a:srgbClr val="FFFFFF"/>
+          </a:fillRef>
+          <a:effectRef idx="0">
+            <a:srgbClr val="FFFFFF"/>
+          </a:effectRef>
           <a:fontRef idx="minor"/>
         </p:style>
         <p:txBody>
-          <a:bodyPr lIns="68400" rIns="68400" tIns="34200" bIns="34200" anchor="t">
+          <a:bodyPr lIns="68400" tIns="34200" rIns="68400" bIns="34200" anchor="t">
             <a:noAutofit/>
           </a:bodyPr>
           <a:p>
@@ -1232,21 +1361,21 @@
                 <a:spcPct val="100000"/>
               </a:lnSpc>
               <a:tabLst>
-                <a:tab algn="l" pos="0"/>
+                <a:tab pos="0" algn="l"/>
               </a:tabLst>
             </a:pPr>
             <a:r>
-              <a:rPr b="1" lang="en" sz="1500" spc="-1" strike="noStrike">
-                <a:solidFill>
-                  <a:srgbClr val="000000"/>
-                </a:solidFill>
-                <a:latin typeface="Arial"/>
-                <a:ea typeface="Arial"/>
+              <a:rPr lang="en-GB" sz="1500" b="1" strike="noStrike" spc="-1">
+                <a:solidFill>
+                  <a:srgbClr val="000000"/>
+                </a:solidFill>
+                <a:latin typeface="Arial" panose="020B0604020202020204"/>
+                <a:ea typeface="Arial" panose="020B0604020202020204"/>
               </a:rPr>
               <a:t>Accomplishments</a:t>
             </a:r>
             <a:r>
-              <a:rPr b="1" lang="en" sz="1400" spc="-1" strike="noStrike">
+              <a:rPr lang="en-GB" sz="1400" b="1" strike="noStrike" spc="-1">
                 <a:solidFill>
                   <a:srgbClr val="000000"/>
                 </a:solidFill>
@@ -1255,18 +1384,18 @@
               </a:rPr>
               <a:t>	</a:t>
             </a:r>
-            <a:endParaRPr b="0" lang="en-US" sz="1400" spc="-1" strike="noStrike">
-              <a:solidFill>
-                <a:srgbClr val="000000"/>
-              </a:solidFill>
-              <a:latin typeface="Arial"/>
+            <a:endParaRPr lang="en-US" sz="1400" b="0" strike="noStrike" spc="-1">
+              <a:solidFill>
+                <a:srgbClr val="000000"/>
+              </a:solidFill>
+              <a:latin typeface="Arial" panose="020B0604020202020204"/>
             </a:endParaRPr>
           </a:p>
         </p:txBody>
       </p:sp>
       <p:cxnSp>
         <p:nvCxnSpPr>
-          <p:cNvPr id="5" name="Google Shape;11;p1"/>
+          <p:cNvPr id="6" name="Google Shape;11;p1"/>
           <p:cNvCxnSpPr/>
           <p:nvPr/>
         </p:nvCxnSpPr>
@@ -1280,7 +1409,7 @@
           </a:prstGeom>
           <a:ln w="28575">
             <a:solidFill>
-              <a:srgbClr val="7f7f7f"/>
+              <a:srgbClr val="7F7F7F"/>
             </a:solidFill>
             <a:round/>
           </a:ln>
@@ -1288,7 +1417,7 @@
       </p:cxnSp>
       <p:sp>
         <p:nvSpPr>
-          <p:cNvPr id="6" name="Google Shape;12;p1"/>
+          <p:cNvPr id="7" name="Google Shape;12;p1"/>
           <p:cNvSpPr/>
           <p:nvPr/>
         </p:nvSpPr>
@@ -1306,13 +1435,19 @@
           </a:ln>
         </p:spPr>
         <p:style>
-          <a:lnRef idx="0"/>
-          <a:fillRef idx="0"/>
-          <a:effectRef idx="0"/>
+          <a:lnRef idx="0">
+            <a:srgbClr val="FFFFFF"/>
+          </a:lnRef>
+          <a:fillRef idx="0">
+            <a:srgbClr val="FFFFFF"/>
+          </a:fillRef>
+          <a:effectRef idx="0">
+            <a:srgbClr val="FFFFFF"/>
+          </a:effectRef>
           <a:fontRef idx="minor"/>
         </p:style>
         <p:txBody>
-          <a:bodyPr lIns="90000" rIns="90000" tIns="91440" bIns="91440" anchor="t">
+          <a:bodyPr lIns="90000" tIns="91440" rIns="90000" bIns="91440" anchor="t">
             <a:noAutofit/>
           </a:bodyPr>
           <a:p>
@@ -1321,31 +1456,31 @@
                 <a:spcPct val="100000"/>
               </a:lnSpc>
               <a:tabLst>
-                <a:tab algn="l" pos="0"/>
+                <a:tab pos="0" algn="l"/>
               </a:tabLst>
             </a:pPr>
             <a:r>
-              <a:rPr b="0" lang="en" sz="1200" spc="-1" strike="noStrike">
-                <a:solidFill>
-                  <a:srgbClr val="000000"/>
-                </a:solidFill>
-                <a:latin typeface="Arial"/>
-                <a:ea typeface="Arial"/>
+              <a:rPr lang="en-GB" sz="1200" b="0" strike="noStrike" spc="-1">
+                <a:solidFill>
+                  <a:srgbClr val="000000"/>
+                </a:solidFill>
+                <a:latin typeface="Arial" panose="020B0604020202020204"/>
+                <a:ea typeface="Arial" panose="020B0604020202020204"/>
               </a:rPr>
               <a:t>Spring 2025</a:t>
             </a:r>
-            <a:endParaRPr b="0" lang="en-US" sz="1200" spc="-1" strike="noStrike">
-              <a:solidFill>
-                <a:srgbClr val="000000"/>
-              </a:solidFill>
-              <a:latin typeface="Arial"/>
+            <a:endParaRPr lang="en-US" sz="1200" b="0" strike="noStrike" spc="-1">
+              <a:solidFill>
+                <a:srgbClr val="000000"/>
+              </a:solidFill>
+              <a:latin typeface="Arial" panose="020B0604020202020204"/>
             </a:endParaRPr>
           </a:p>
         </p:txBody>
       </p:sp>
       <p:sp>
         <p:nvSpPr>
-          <p:cNvPr id="7" name="Google Shape;12;p1"/>
+          <p:cNvPr id="8" name="Google Shape;12;p1"/>
           <p:cNvSpPr/>
           <p:nvPr/>
         </p:nvSpPr>
@@ -1363,13 +1498,19 @@
           </a:ln>
         </p:spPr>
         <p:style>
-          <a:lnRef idx="0"/>
-          <a:fillRef idx="0"/>
-          <a:effectRef idx="0"/>
+          <a:lnRef idx="0">
+            <a:srgbClr val="FFFFFF"/>
+          </a:lnRef>
+          <a:fillRef idx="0">
+            <a:srgbClr val="FFFFFF"/>
+          </a:fillRef>
+          <a:effectRef idx="0">
+            <a:srgbClr val="FFFFFF"/>
+          </a:effectRef>
           <a:fontRef idx="minor"/>
         </p:style>
         <p:txBody>
-          <a:bodyPr lIns="90000" rIns="90000" tIns="91440" bIns="91440" anchor="t">
+          <a:bodyPr lIns="90000" tIns="91440" rIns="90000" bIns="91440" anchor="t">
             <a:noAutofit/>
           </a:bodyPr>
           <a:p>
@@ -1378,37 +1519,39 @@
                 <a:spcPct val="100000"/>
               </a:lnSpc>
               <a:tabLst>
-                <a:tab algn="l" pos="0"/>
+                <a:tab pos="0" algn="l"/>
               </a:tabLst>
             </a:pPr>
             <a:r>
-              <a:rPr b="0" lang="en" sz="1200" spc="-1" strike="noStrike">
-                <a:solidFill>
-                  <a:srgbClr val="000000"/>
-                </a:solidFill>
-                <a:latin typeface="Arial"/>
-                <a:ea typeface="Arial"/>
+              <a:rPr lang="en-GB" sz="1200" b="0" strike="noStrike" spc="-1">
+                <a:solidFill>
+                  <a:srgbClr val="000000"/>
+                </a:solidFill>
+                <a:latin typeface="Arial" panose="020B0604020202020204"/>
+                <a:ea typeface="Arial" panose="020B0604020202020204"/>
               </a:rPr>
               <a:t>Graduate Projects</a:t>
             </a:r>
-            <a:endParaRPr b="0" lang="en-US" sz="1200" spc="-1" strike="noStrike">
-              <a:solidFill>
-                <a:srgbClr val="000000"/>
-              </a:solidFill>
-              <a:latin typeface="Arial"/>
+            <a:endParaRPr lang="en-US" sz="1200" b="0" strike="noStrike" spc="-1">
+              <a:solidFill>
+                <a:srgbClr val="000000"/>
+              </a:solidFill>
+              <a:latin typeface="Arial" panose="020B0604020202020204"/>
             </a:endParaRPr>
           </a:p>
         </p:txBody>
       </p:sp>
       <p:pic>
         <p:nvPicPr>
-          <p:cNvPr id="8" name="Google Shape;26;p2" descr=""/>
+          <p:cNvPr id="9" name="Google Shape;26;p2"/>
           <p:cNvPicPr/>
           <p:nvPr/>
         </p:nvPicPr>
         <p:blipFill>
           <a:blip r:embed="rId2"/>
-          <a:stretch/>
+          <a:stretch>
+            <a:fillRect/>
+          </a:stretch>
         </p:blipFill>
         <p:spPr>
           <a:xfrm>
@@ -1425,7 +1568,7 @@
       </p:pic>
       <p:sp>
         <p:nvSpPr>
-          <p:cNvPr id="9" name="Google Shape;29;p2"/>
+          <p:cNvPr id="10" name="Google Shape;29;p2"/>
           <p:cNvSpPr/>
           <p:nvPr/>
         </p:nvSpPr>
@@ -1438,23 +1581,29 @@
             <a:avLst/>
           </a:prstGeom>
           <a:solidFill>
-            <a:srgbClr val="70ad47"/>
+            <a:srgbClr val="70AD47"/>
           </a:solidFill>
           <a:ln w="9525">
             <a:solidFill>
-              <a:srgbClr val="44546a"/>
+              <a:srgbClr val="44546A"/>
             </a:solidFill>
             <a:round/>
           </a:ln>
         </p:spPr>
         <p:style>
-          <a:lnRef idx="0"/>
-          <a:fillRef idx="0"/>
-          <a:effectRef idx="0"/>
+          <a:lnRef idx="0">
+            <a:srgbClr val="FFFFFF"/>
+          </a:lnRef>
+          <a:fillRef idx="0">
+            <a:srgbClr val="FFFFFF"/>
+          </a:fillRef>
+          <a:effectRef idx="0">
+            <a:srgbClr val="FFFFFF"/>
+          </a:effectRef>
           <a:fontRef idx="minor"/>
         </p:style>
         <p:txBody>
-          <a:bodyPr lIns="90000" rIns="90000" tIns="91440" bIns="91440" anchor="ctr">
+          <a:bodyPr lIns="90000" tIns="91440" rIns="90000" bIns="91440" anchor="ctr">
             <a:noAutofit/>
           </a:bodyPr>
           <a:p>
@@ -1463,22 +1612,22 @@
                 <a:spcPct val="100000"/>
               </a:lnSpc>
               <a:tabLst>
-                <a:tab algn="l" pos="0"/>
+                <a:tab pos="0" algn="l"/>
               </a:tabLst>
             </a:pPr>
-            <a:endParaRPr b="0" lang="en-US" sz="1400" spc="-1" strike="noStrike">
-              <a:solidFill>
-                <a:srgbClr val="000000"/>
-              </a:solidFill>
-              <a:latin typeface="Arial"/>
-              <a:ea typeface="Arial"/>
+            <a:endParaRPr lang="en-US" sz="1400" b="0" strike="noStrike" spc="-1">
+              <a:solidFill>
+                <a:srgbClr val="000000"/>
+              </a:solidFill>
+              <a:latin typeface="Arial" panose="020B0604020202020204"/>
+              <a:ea typeface="Arial" panose="020B0604020202020204"/>
             </a:endParaRPr>
           </a:p>
         </p:txBody>
       </p:sp>
       <p:cxnSp>
         <p:nvCxnSpPr>
-          <p:cNvPr id="10" name="Google Shape;30;p2"/>
+          <p:cNvPr id="11" name="Google Shape;30;p2"/>
           <p:cNvCxnSpPr/>
           <p:nvPr/>
         </p:nvCxnSpPr>
@@ -1500,7 +1649,7 @@
       </p:cxnSp>
       <p:cxnSp>
         <p:nvCxnSpPr>
-          <p:cNvPr id="11" name="Google Shape;31;p2"/>
+          <p:cNvPr id="12" name="Google Shape;31;p2"/>
           <p:cNvCxnSpPr/>
           <p:nvPr/>
         </p:nvCxnSpPr>
@@ -1522,15 +1671,20 @@
       </p:cxnSp>
     </p:spTree>
   </p:cSld>
-  <p:clrMap bg1="lt1" bg2="lt2" tx1="dk1" tx2="dk2" accent1="accent1" accent2="accent2" accent3="accent3" accent4="accent4" accent5="accent5" accent6="accent6" hlink="hlink" folHlink="folHlink"/>
+  <p:clrMap bg1="lt1" tx1="dk1" bg2="lt2" tx2="dk2" accent1="accent1" accent2="accent2" accent3="accent3" accent4="accent4" accent5="accent5" accent6="accent6" hlink="hlink" folHlink="folHlink"/>
   <p:sldLayoutIdLst>
-    <p:sldLayoutId id="2147483649" r:id="rId3"/>
+    <p:sldLayoutId id="2147483649" r:id="rId1"/>
   </p:sldLayoutIdLst>
+  <p:txStyles>
+    <p:titleStyle/>
+    <p:bodyStyle/>
+    <p:otherStyle/>
+  </p:txStyles>
 </p:sldMaster>
 </file>
 
 <file path=ppt/slides/slide1.xml><?xml version="1.0" encoding="utf-8"?>
-<p:sld xmlns:a="http://schemas.openxmlformats.org/drawingml/2006/main" xmlns:p="http://schemas.openxmlformats.org/presentationml/2006/main" xmlns:r="http://schemas.openxmlformats.org/officeDocument/2006/relationships" xmlns:p14="http://schemas.microsoft.com/office/powerpoint/2010/main" xmlns:p15="http://schemas.microsoft.com/office/powerpoint/2012/main" xmlns:mc="http://schemas.openxmlformats.org/markup-compatibility/2006">
+<p:sld xmlns:a="http://schemas.openxmlformats.org/drawingml/2006/main" xmlns:r="http://schemas.openxmlformats.org/officeDocument/2006/relationships" xmlns:p="http://schemas.openxmlformats.org/presentationml/2006/main">
   <p:cSld>
     <p:spTree>
       <p:nvGrpSpPr>
@@ -1570,187 +1724,111 @@
           </a:ln>
         </p:spPr>
         <p:txBody>
-          <a:bodyPr lIns="91440" rIns="91440" tIns="91440" bIns="91440" anchor="t">
+          <a:bodyPr lIns="91440" tIns="91440" rIns="91440" bIns="91440" anchor="t">
             <a:noAutofit/>
           </a:bodyPr>
           <a:p>
-            <a:pPr marL="285840" indent="0">
+            <a:pPr marL="571500" indent="-285750">
               <a:lnSpc>
                 <a:spcPct val="100000"/>
               </a:lnSpc>
-              <a:buNone/>
-            </a:pPr>
-            <a:r>
-              <a:rPr b="0" lang="en" sz="900" spc="-1" strike="noStrike">
-                <a:solidFill>
-                  <a:srgbClr val="000000"/>
-                </a:solidFill>
-                <a:latin typeface="Arial"/>
-                <a:ea typeface="Arial"/>
-              </a:rPr>
-              <a:t>Met with Drhuva, learned more about the packet structure of the Lithium</a:t>
-            </a:r>
-            <a:endParaRPr b="0" lang="en-US" sz="900" spc="-1" strike="noStrike">
-              <a:solidFill>
-                <a:srgbClr val="000000"/>
-              </a:solidFill>
-              <a:latin typeface="Arial"/>
-            </a:endParaRPr>
-          </a:p>
-          <a:p>
-            <a:pPr lvl="1" marL="864000" indent="-324000">
+              <a:buFont typeface="Arial" panose="020B0604020202020204" pitchFamily="34" charset="0"/>
+              <a:buChar char="•"/>
+            </a:pPr>
+            <a:r>
+              <a:rPr lang="en-US" altLang="en-GB" sz="1400" b="0" strike="noStrike" spc="-1">
+                <a:solidFill>
+                  <a:srgbClr val="000000"/>
+                </a:solidFill>
+                <a:latin typeface="Arial" panose="020B0604020202020204"/>
+                <a:ea typeface="Arial" panose="020B0604020202020204"/>
+              </a:rPr>
+              <a:t>Hydra development</a:t>
+            </a:r>
+            <a:endParaRPr lang="en-US" altLang="en-GB" sz="1400" b="0" strike="noStrike" spc="-1">
+              <a:solidFill>
+                <a:srgbClr val="000000"/>
+              </a:solidFill>
+              <a:latin typeface="Arial" panose="020B0604020202020204"/>
+              <a:ea typeface="Arial" panose="020B0604020202020204"/>
+            </a:endParaRPr>
+          </a:p>
+          <a:p>
+            <a:pPr marL="571500" indent="-285750">
               <a:lnSpc>
                 <a:spcPct val="100000"/>
               </a:lnSpc>
-              <a:spcBef>
-                <a:spcPts val="1134"/>
-              </a:spcBef>
-              <a:buClr>
-                <a:srgbClr val="000000"/>
-              </a:buClr>
-              <a:buSzPct val="75000"/>
-              <a:buFont typeface="Symbol" charset="2"/>
-              <a:buChar char=""/>
-            </a:pPr>
-            <a:r>
-              <a:rPr b="0" lang="en" sz="900" spc="-1" strike="noStrike">
-                <a:solidFill>
-                  <a:srgbClr val="000000"/>
-                </a:solidFill>
-                <a:latin typeface="Arial"/>
-                <a:ea typeface="Arial"/>
-              </a:rPr>
-              <a:t>Learned more about the state of the radio</a:t>
-            </a:r>
-            <a:endParaRPr b="0" lang="en-US" sz="900" spc="-1" strike="noStrike">
-              <a:solidFill>
-                <a:srgbClr val="000000"/>
-              </a:solidFill>
-              <a:latin typeface="Arial"/>
-            </a:endParaRPr>
-          </a:p>
-          <a:p>
-            <a:pPr lvl="1" marL="864000" indent="-324000">
+              <a:buFont typeface="Arial" panose="020B0604020202020204" pitchFamily="34" charset="0"/>
+              <a:buChar char="•"/>
+            </a:pPr>
+            <a:r>
+              <a:rPr lang="en-US" altLang="en-GB" sz="1400" b="0" strike="noStrike" spc="-1">
+                <a:solidFill>
+                  <a:srgbClr val="000000"/>
+                </a:solidFill>
+                <a:latin typeface="Arial" panose="020B0604020202020204"/>
+                <a:ea typeface="Arial" panose="020B0604020202020204"/>
+              </a:rPr>
+              <a:t>Hardwired Hydra into Lithium for verification</a:t>
+            </a:r>
+            <a:endParaRPr lang="en-US" altLang="en-GB" sz="1400" b="0" strike="noStrike" spc="-1">
+              <a:solidFill>
+                <a:srgbClr val="000000"/>
+              </a:solidFill>
+              <a:latin typeface="Arial" panose="020B0604020202020204"/>
+              <a:ea typeface="Arial" panose="020B0604020202020204"/>
+            </a:endParaRPr>
+          </a:p>
+          <a:p>
+            <a:pPr marL="1028700" lvl="1" indent="-285750">
               <a:lnSpc>
                 <a:spcPct val="100000"/>
               </a:lnSpc>
-              <a:spcBef>
-                <a:spcPts val="1134"/>
-              </a:spcBef>
-              <a:buClr>
-                <a:srgbClr val="000000"/>
-              </a:buClr>
-              <a:buSzPct val="75000"/>
-              <a:buFont typeface="Symbol" charset="2"/>
-              <a:buChar char=""/>
-            </a:pPr>
-            <a:r>
-              <a:rPr b="0" lang="en" sz="900" spc="-1" strike="noStrike">
-                <a:solidFill>
-                  <a:srgbClr val="000000"/>
-                </a:solidFill>
-                <a:latin typeface="Arial"/>
-                <a:ea typeface="Arial"/>
-              </a:rPr>
-              <a:t>Need to check the AX 25 framing on CDH packet </a:t>
-            </a:r>
-            <a:endParaRPr b="0" lang="en-US" sz="900" spc="-1" strike="noStrike">
-              <a:solidFill>
-                <a:srgbClr val="000000"/>
-              </a:solidFill>
-              <a:latin typeface="Arial"/>
-            </a:endParaRPr>
-          </a:p>
-          <a:p>
-            <a:pPr marL="285840" indent="-285840">
+              <a:buFont typeface="Arial" panose="020B0604020202020204" pitchFamily="34" charset="0"/>
+              <a:buChar char="•"/>
+            </a:pPr>
+            <a:r>
+              <a:rPr lang="en-US" altLang="en-GB" sz="1400" b="0" strike="noStrike" spc="-1">
+                <a:solidFill>
+                  <a:srgbClr val="000000"/>
+                </a:solidFill>
+                <a:latin typeface="Arial" panose="020B0604020202020204"/>
+                <a:ea typeface="Arial" panose="020B0604020202020204"/>
+              </a:rPr>
+              <a:t>still need CDH in the loop but this shows commands are working properly</a:t>
+            </a:r>
+            <a:endParaRPr lang="en-US" altLang="en-GB" sz="1400" b="0" strike="noStrike" spc="-1">
+              <a:solidFill>
+                <a:srgbClr val="000000"/>
+              </a:solidFill>
+              <a:latin typeface="Arial" panose="020B0604020202020204"/>
+              <a:ea typeface="Arial" panose="020B0604020202020204"/>
+            </a:endParaRPr>
+          </a:p>
+          <a:p>
+            <a:pPr marL="571500" indent="-285750">
               <a:lnSpc>
                 <a:spcPct val="100000"/>
               </a:lnSpc>
-              <a:buClr>
-                <a:srgbClr val="000000"/>
-              </a:buClr>
-              <a:buFont typeface="Calibri,Sans-Serif"/>
-              <a:buChar char="-"/>
-            </a:pPr>
-            <a:r>
-              <a:rPr b="0" lang="en" sz="900" spc="-1" strike="noStrike">
-                <a:solidFill>
-                  <a:srgbClr val="000000"/>
-                </a:solidFill>
-                <a:latin typeface="Arial"/>
-                <a:ea typeface="Arial"/>
-              </a:rPr>
-              <a:t>Attempted MCT</a:t>
-            </a:r>
-            <a:endParaRPr b="0" lang="en-US" sz="900" spc="-1" strike="noStrike">
-              <a:solidFill>
-                <a:srgbClr val="000000"/>
-              </a:solidFill>
-              <a:latin typeface="Arial"/>
-            </a:endParaRPr>
-          </a:p>
-          <a:p>
-            <a:pPr lvl="1" marL="864000" indent="-324000">
-              <a:lnSpc>
-                <a:spcPct val="100000"/>
-              </a:lnSpc>
-              <a:spcBef>
-                <a:spcPts val="1134"/>
-              </a:spcBef>
-              <a:buClr>
-                <a:srgbClr val="000000"/>
-              </a:buClr>
-              <a:buSzPct val="75000"/>
-              <a:buFont typeface="Symbol" charset="2"/>
-              <a:buChar char=""/>
-            </a:pPr>
-            <a:r>
-              <a:rPr b="0" lang="en" sz="900" spc="-1" strike="noStrike">
-                <a:solidFill>
-                  <a:srgbClr val="000000"/>
-                </a:solidFill>
-                <a:latin typeface="Arial"/>
-                <a:ea typeface="Arial"/>
-              </a:rPr>
-              <a:t>Using the manual and a multimeter found the pins we are concerned about </a:t>
-            </a:r>
-            <a:endParaRPr b="0" lang="en-US" sz="900" spc="-1" strike="noStrike">
-              <a:solidFill>
-                <a:srgbClr val="000000"/>
-              </a:solidFill>
-              <a:latin typeface="Arial"/>
-            </a:endParaRPr>
-          </a:p>
-          <a:p>
-            <a:pPr lvl="1" marL="864000" indent="-324000">
-              <a:lnSpc>
-                <a:spcPct val="100000"/>
-              </a:lnSpc>
-              <a:spcBef>
-                <a:spcPts val="1134"/>
-              </a:spcBef>
-              <a:buClr>
-                <a:srgbClr val="000000"/>
-              </a:buClr>
-              <a:buSzPct val="75000"/>
-              <a:buFont typeface="Symbol" charset="2"/>
-              <a:buChar char=""/>
-            </a:pPr>
-            <a:r>
-              <a:rPr b="0" lang="en" sz="900" spc="-1" strike="noStrike">
-                <a:solidFill>
-                  <a:srgbClr val="000000"/>
-                </a:solidFill>
-                <a:latin typeface="Arial"/>
-                <a:ea typeface="Arial"/>
-              </a:rPr>
-              <a:t>More hydra development is needed, commands are missing</a:t>
-            </a:r>
-            <a:endParaRPr b="0" lang="en-US" sz="900" spc="-1" strike="noStrike">
-              <a:solidFill>
-                <a:srgbClr val="000000"/>
-              </a:solidFill>
-              <a:latin typeface="Arial"/>
+              <a:buFont typeface="Arial" panose="020B0604020202020204" pitchFamily="34" charset="0"/>
+              <a:buChar char="•"/>
+            </a:pPr>
+            <a:r>
+              <a:rPr lang="en-US" altLang="en-GB" sz="1400" b="0" strike="noStrike" spc="-1">
+                <a:solidFill>
+                  <a:srgbClr val="000000"/>
+                </a:solidFill>
+                <a:latin typeface="Arial" panose="020B0604020202020204"/>
+                <a:ea typeface="Arial" panose="020B0604020202020204"/>
+              </a:rPr>
+              <a:t>Started doc for the STIG ground station PC</a:t>
+            </a:r>
+            <a:endParaRPr lang="en-US" altLang="en-GB" sz="1400" b="0" strike="noStrike" spc="-1">
+              <a:solidFill>
+                <a:srgbClr val="000000"/>
+              </a:solidFill>
+              <a:latin typeface="Arial" panose="020B0604020202020204"/>
+              <a:ea typeface="Arial" panose="020B0604020202020204"/>
             </a:endParaRPr>
           </a:p>
         </p:txBody>
@@ -1779,59 +1857,59 @@
           </a:ln>
         </p:spPr>
         <p:txBody>
-          <a:bodyPr lIns="91440" rIns="91440" tIns="91440" bIns="91440" anchor="t">
+          <a:bodyPr lIns="91440" tIns="91440" rIns="91440" bIns="91440" anchor="t">
             <a:noAutofit/>
           </a:bodyPr>
           <a:p>
-            <a:pPr marL="457200" indent="-317520">
+            <a:pPr marL="742950" indent="-285750">
               <a:lnSpc>
                 <a:spcPct val="100000"/>
               </a:lnSpc>
-              <a:buClr>
-                <a:srgbClr val="000000"/>
-              </a:buClr>
-              <a:buFont typeface="Arial"/>
-              <a:buChar char="●"/>
-            </a:pPr>
-            <a:r>
-              <a:rPr b="0" lang="en" sz="1400" spc="-1" strike="noStrike">
-                <a:solidFill>
-                  <a:srgbClr val="000000"/>
-                </a:solidFill>
-                <a:latin typeface="Arial"/>
-                <a:ea typeface="Arial"/>
-              </a:rPr>
-              <a:t>Palo assessing machines in the lab</a:t>
-            </a:r>
-            <a:endParaRPr b="0" lang="en-US" sz="1400" spc="-1" strike="noStrike">
-              <a:solidFill>
-                <a:srgbClr val="000000"/>
-              </a:solidFill>
-              <a:latin typeface="Arial"/>
-            </a:endParaRPr>
-          </a:p>
-          <a:p>
-            <a:pPr marL="457200" indent="0">
+              <a:buFont typeface="Arial" panose="020B0604020202020204" pitchFamily="34" charset="0"/>
+              <a:buChar char="•"/>
+            </a:pPr>
+            <a:r>
+              <a:rPr lang="en-US" altLang="" sz="1400" b="0" strike="noStrike" spc="-1">
+                <a:solidFill>
+                  <a:srgbClr val="000000"/>
+                </a:solidFill>
+                <a:latin typeface="Arial" panose="020B0604020202020204"/>
+                <a:ea typeface="Arial" panose="020B0604020202020204"/>
+              </a:rPr>
+              <a:t>CDH development</a:t>
+            </a:r>
+            <a:endParaRPr lang="en-US" altLang="" sz="1400" b="0" strike="noStrike" spc="-1">
+              <a:solidFill>
+                <a:srgbClr val="000000"/>
+              </a:solidFill>
+              <a:latin typeface="Arial" panose="020B0604020202020204"/>
+              <a:ea typeface="Arial" panose="020B0604020202020204"/>
+            </a:endParaRPr>
+          </a:p>
+          <a:p>
+            <a:pPr marL="742950" indent="-285750">
               <a:lnSpc>
                 <a:spcPct val="100000"/>
               </a:lnSpc>
-              <a:buNone/>
-            </a:pPr>
-            <a:r>
-              <a:rPr b="0" lang="en" sz="1400" spc="-1" strike="noStrike">
-                <a:solidFill>
-                  <a:srgbClr val="000000"/>
-                </a:solidFill>
-                <a:latin typeface="Arial"/>
-                <a:ea typeface="Arial"/>
-              </a:rPr>
-              <a:t> </a:t>
-            </a:r>
-            <a:endParaRPr b="0" lang="en-US" sz="1400" spc="-1" strike="noStrike">
-              <a:solidFill>
-                <a:srgbClr val="000000"/>
-              </a:solidFill>
-              <a:latin typeface="Arial"/>
+              <a:buFont typeface="Arial" panose="020B0604020202020204" pitchFamily="34" charset="0"/>
+              <a:buChar char="•"/>
+            </a:pPr>
+            <a:r>
+              <a:rPr lang="en-US" altLang="en-GB" sz="1400" b="0" strike="noStrike" spc="-1">
+                <a:solidFill>
+                  <a:srgbClr val="000000"/>
+                </a:solidFill>
+                <a:latin typeface="Arial" panose="020B0604020202020204"/>
+                <a:ea typeface="Arial" panose="020B0604020202020204"/>
+              </a:rPr>
+              <a:t>Hydra development</a:t>
+            </a:r>
+            <a:endParaRPr lang="en-US" altLang="en-GB" sz="1400" b="0" strike="noStrike" spc="-1">
+              <a:solidFill>
+                <a:srgbClr val="000000"/>
+              </a:solidFill>
+              <a:latin typeface="Arial" panose="020B0604020202020204"/>
+              <a:ea typeface="Arial" panose="020B0604020202020204"/>
             </a:endParaRPr>
           </a:p>
         </p:txBody>
@@ -1860,21 +1938,21 @@
           </a:ln>
         </p:spPr>
         <p:txBody>
-          <a:bodyPr lIns="91440" rIns="91440" tIns="91440" bIns="91440" anchor="t">
+          <a:bodyPr lIns="91440" tIns="91440" rIns="91440" bIns="91440" anchor="t">
             <a:noAutofit/>
           </a:bodyPr>
           <a:p>
             <a:pPr indent="0">
               <a:spcBef>
-                <a:spcPts val="972"/>
+                <a:spcPts val="970"/>
               </a:spcBef>
               <a:buNone/>
             </a:pPr>
-            <a:endParaRPr b="0" lang="en-US" sz="1800" spc="-1" strike="noStrike">
-              <a:solidFill>
-                <a:srgbClr val="000000"/>
-              </a:solidFill>
-              <a:latin typeface="Arial"/>
+            <a:endParaRPr lang="en-US" sz="1800" b="0" strike="noStrike" spc="-1">
+              <a:solidFill>
+                <a:srgbClr val="000000"/>
+              </a:solidFill>
+              <a:latin typeface="Arial" panose="020B0604020202020204"/>
             </a:endParaRPr>
           </a:p>
         </p:txBody>
@@ -1903,11 +1981,11 @@
           </a:ln>
         </p:spPr>
         <p:txBody>
-          <a:bodyPr lIns="91440" rIns="91440" tIns="91440" bIns="91440" anchor="t">
+          <a:bodyPr lIns="91440" tIns="91440" rIns="91440" bIns="91440" anchor="t">
             <a:noAutofit/>
           </a:bodyPr>
           <a:p>
-            <a:pPr marL="457200" indent="-317520">
+            <a:pPr marL="457200" indent="-317500">
               <a:lnSpc>
                 <a:spcPct val="100000"/>
               </a:lnSpc>
@@ -1918,24 +1996,23 @@
               <a:buChar char="-"/>
             </a:pPr>
             <a:r>
-              <a:rPr b="0" lang="en-US" sz="1400" spc="-1" strike="noStrike">
-                <a:solidFill>
-                  <a:schemeClr val="dk1"/>
-                </a:solidFill>
-                <a:latin typeface="Arial"/>
-                <a:ea typeface="Arial"/>
-              </a:rPr>
-              <a:t>Meet with Saanika, learn about Hydra and what we need for our COMMs testing</a:t>
-            </a:r>
-            <a:endParaRPr b="0" lang="en-US" sz="1400" spc="-1" strike="noStrike">
-              <a:solidFill>
-                <a:srgbClr val="000000"/>
-              </a:solidFill>
-              <a:latin typeface="Arial"/>
-            </a:endParaRPr>
-          </a:p>
-          <a:p>
-            <a:pPr marL="457200" indent="-317520">
+              <a:rPr lang="en-US" sz="1400" b="0" strike="noStrike" spc="-1">
+                <a:solidFill>
+                  <a:srgbClr val="000000"/>
+                </a:solidFill>
+                <a:latin typeface="Arial" panose="020B0604020202020204"/>
+              </a:rPr>
+              <a:t>Work with CDH to fix how command byte is being read in, wrap up MCT</a:t>
+            </a:r>
+            <a:endParaRPr lang="en-US" sz="1400" b="0" strike="noStrike" spc="-1">
+              <a:solidFill>
+                <a:srgbClr val="000000"/>
+              </a:solidFill>
+              <a:latin typeface="Arial" panose="020B0604020202020204"/>
+            </a:endParaRPr>
+          </a:p>
+          <a:p>
+            <a:pPr marL="457200" indent="-317500">
               <a:lnSpc>
                 <a:spcPct val="100000"/>
               </a:lnSpc>
@@ -1946,84 +2023,73 @@
               <a:buChar char="-"/>
             </a:pPr>
             <a:r>
-              <a:rPr b="0" lang="en-US" sz="1400" spc="-1" strike="noStrike">
-                <a:solidFill>
-                  <a:schemeClr val="dk1"/>
-                </a:solidFill>
-                <a:latin typeface="Arial"/>
-                <a:ea typeface="Arial"/>
-              </a:rPr>
-              <a:t>Following road map of test:</a:t>
-            </a:r>
-            <a:endParaRPr b="0" lang="en-US" sz="1400" spc="-1" strike="noStrike">
-              <a:solidFill>
-                <a:srgbClr val="000000"/>
-              </a:solidFill>
-              <a:latin typeface="Arial"/>
-            </a:endParaRPr>
-          </a:p>
-          <a:p>
-            <a:pPr lvl="1" marL="864000" indent="-324000">
+              <a:rPr lang="en-US" sz="1400" b="0" strike="noStrike" spc="-1">
+                <a:solidFill>
+                  <a:srgbClr val="000000"/>
+                </a:solidFill>
+                <a:latin typeface="Arial" panose="020B0604020202020204"/>
+              </a:rPr>
+              <a:t>Updating MCT documentation</a:t>
+            </a:r>
+            <a:endParaRPr lang="en-US" sz="1400" b="0" strike="noStrike" spc="-1">
+              <a:solidFill>
+                <a:srgbClr val="000000"/>
+              </a:solidFill>
+              <a:latin typeface="Arial" panose="020B0604020202020204"/>
+            </a:endParaRPr>
+          </a:p>
+          <a:p>
+            <a:pPr marL="457200" indent="-317500">
               <a:lnSpc>
                 <a:spcPct val="100000"/>
               </a:lnSpc>
-              <a:spcBef>
-                <a:spcPts val="1134"/>
-              </a:spcBef>
               <a:buClr>
                 <a:srgbClr val="000000"/>
               </a:buClr>
-              <a:buSzPct val="75000"/>
-              <a:buFont typeface="Symbol" charset="2"/>
-              <a:buChar char=""/>
-            </a:pPr>
-            <a:r>
-              <a:rPr b="0" lang="en-US" sz="1400" spc="-1" strike="noStrike">
-                <a:solidFill>
-                  <a:schemeClr val="dk1"/>
-                </a:solidFill>
-                <a:latin typeface="Arial"/>
-                <a:ea typeface="Arial"/>
-              </a:rPr>
-              <a:t>Hydra -&gt; Li2</a:t>
-            </a:r>
-            <a:endParaRPr b="0" lang="en-US" sz="1400" spc="-1" strike="noStrike">
-              <a:solidFill>
-                <a:srgbClr val="000000"/>
-              </a:solidFill>
-              <a:latin typeface="Arial"/>
-            </a:endParaRPr>
-          </a:p>
-          <a:p>
-            <a:pPr lvl="1" marL="864000" indent="-324000">
+              <a:buFont typeface="Calibri,Sans-Serif"/>
+              <a:buChar char="-"/>
+            </a:pPr>
+            <a:r>
+              <a:rPr lang="en-US" sz="1400" b="0" strike="noStrike" spc="-1">
+                <a:solidFill>
+                  <a:srgbClr val="000000"/>
+                </a:solidFill>
+                <a:latin typeface="Arial" panose="020B0604020202020204"/>
+              </a:rPr>
+              <a:t>Prepare for re running SCT</a:t>
+            </a:r>
+            <a:endParaRPr lang="en-US" sz="1400" b="0" strike="noStrike" spc="-1">
+              <a:solidFill>
+                <a:srgbClr val="000000"/>
+              </a:solidFill>
+              <a:latin typeface="Arial" panose="020B0604020202020204"/>
+            </a:endParaRPr>
+          </a:p>
+          <a:p>
+            <a:pPr marL="457200" indent="-317500">
               <a:lnSpc>
                 <a:spcPct val="100000"/>
               </a:lnSpc>
-              <a:spcBef>
-                <a:spcPts val="1134"/>
-              </a:spcBef>
               <a:buClr>
                 <a:srgbClr val="000000"/>
               </a:buClr>
-              <a:buSzPct val="75000"/>
-              <a:buFont typeface="Symbol" charset="2"/>
-              <a:buChar char=""/>
-            </a:pPr>
-            <a:r>
-              <a:rPr b="0" lang="en-US" sz="1400" spc="-1" strike="noStrike">
-                <a:solidFill>
-                  <a:schemeClr val="dk1"/>
-                </a:solidFill>
-                <a:latin typeface="Arial"/>
-                <a:ea typeface="Arial"/>
-              </a:rPr>
-              <a:t>Hydra →CDH→Li2</a:t>
-            </a:r>
-            <a:endParaRPr b="0" lang="en-US" sz="1400" spc="-1" strike="noStrike">
-              <a:solidFill>
-                <a:srgbClr val="000000"/>
-              </a:solidFill>
-              <a:latin typeface="Arial"/>
+              <a:buFont typeface="Calibri,Sans-Serif"/>
+              <a:buChar char="-"/>
+            </a:pPr>
+            <a:r>
+              <a:rPr lang="en-US" sz="1400" b="0" strike="noStrike" spc="-1">
+                <a:solidFill>
+                  <a:srgbClr val="000000"/>
+                </a:solidFill>
+                <a:latin typeface="Arial" panose="020B0604020202020204"/>
+              </a:rPr>
+              <a:t>Move forward on testing two gs pcs to see if it helps hydra crashes</a:t>
+            </a:r>
+            <a:endParaRPr lang="en-US" sz="1400" b="0" strike="noStrike" spc="-1">
+              <a:solidFill>
+                <a:srgbClr val="000000"/>
+              </a:solidFill>
+              <a:latin typeface="Arial" panose="020B0604020202020204"/>
             </a:endParaRPr>
           </a:p>
         </p:txBody>
@@ -2052,7 +2118,7 @@
           </a:ln>
         </p:spPr>
         <p:txBody>
-          <a:bodyPr lIns="91440" rIns="91440" tIns="91440" bIns="91440" anchor="t">
+          <a:bodyPr lIns="91440" tIns="91440" rIns="91440" bIns="91440" anchor="t">
             <a:noAutofit/>
           </a:bodyPr>
           <a:p>
@@ -2062,24 +2128,64 @@
               </a:lnSpc>
               <a:buNone/>
               <a:tabLst>
-                <a:tab algn="l" pos="0"/>
+                <a:tab pos="0" algn="l"/>
               </a:tabLst>
             </a:pPr>
             <a:r>
-              <a:rPr b="0" lang="en" sz="1400" spc="-1" strike="noStrike">
-                <a:solidFill>
-                  <a:srgbClr val="000000"/>
-                </a:solidFill>
-                <a:latin typeface="Arial"/>
-                <a:ea typeface="Arial"/>
-              </a:rPr>
-              <a:t>Justin Le 9/18/2026</a:t>
-            </a:r>
-            <a:endParaRPr b="0" lang="en-US" sz="1400" spc="-1" strike="noStrike">
-              <a:solidFill>
-                <a:srgbClr val="000000"/>
-              </a:solidFill>
-              <a:latin typeface="Arial"/>
+              <a:rPr lang="en-GB" sz="1400" b="0" strike="noStrike" spc="-1">
+                <a:solidFill>
+                  <a:srgbClr val="000000"/>
+                </a:solidFill>
+                <a:latin typeface="Arial" panose="020B0604020202020204"/>
+                <a:ea typeface="Arial" panose="020B0604020202020204"/>
+              </a:rPr>
+              <a:t>Justin Le </a:t>
+            </a:r>
+            <a:r>
+              <a:rPr lang="en-US" altLang="en-GB" sz="1400" b="0" strike="noStrike" spc="-1">
+                <a:solidFill>
+                  <a:srgbClr val="000000"/>
+                </a:solidFill>
+                <a:latin typeface="Arial" panose="020B0604020202020204"/>
+                <a:ea typeface="Arial" panose="020B0604020202020204"/>
+              </a:rPr>
+              <a:t>10</a:t>
+            </a:r>
+            <a:r>
+              <a:rPr lang="en-GB" sz="1400" b="0" strike="noStrike" spc="-1">
+                <a:solidFill>
+                  <a:srgbClr val="000000"/>
+                </a:solidFill>
+                <a:latin typeface="Arial" panose="020B0604020202020204"/>
+                <a:ea typeface="Arial" panose="020B0604020202020204"/>
+              </a:rPr>
+              <a:t>/</a:t>
+            </a:r>
+            <a:r>
+              <a:rPr lang="en-US" altLang="en-GB" sz="1400" b="0" strike="noStrike" spc="-1">
+                <a:solidFill>
+                  <a:srgbClr val="000000"/>
+                </a:solidFill>
+                <a:latin typeface="Arial" panose="020B0604020202020204"/>
+                <a:ea typeface="Arial" panose="020B0604020202020204"/>
+              </a:rPr>
+              <a:t>2</a:t>
+            </a:r>
+            <a:r>
+              <a:rPr lang="en-GB" sz="1400" b="0" strike="noStrike" spc="-1">
+                <a:solidFill>
+                  <a:srgbClr val="000000"/>
+                </a:solidFill>
+                <a:latin typeface="Arial" panose="020B0604020202020204"/>
+                <a:ea typeface="Arial" panose="020B0604020202020204"/>
+              </a:rPr>
+              <a:t>/2026</a:t>
+            </a:r>
+            <a:endParaRPr lang="en-US" sz="1400" b="0" strike="noStrike" spc="-1">
+              <a:solidFill>
+                <a:srgbClr val="000000"/>
+              </a:solidFill>
+              <a:latin typeface="Arial" panose="020B0604020202020204"/>
             </a:endParaRPr>
           </a:p>
         </p:txBody>
@@ -2092,7 +2198,7 @@
         </p:nvGraphicFramePr>
         <p:xfrm>
           <a:off x="4604400" y="2577600"/>
-          <a:ext cx="4538160" cy="2039760"/>
+          <a:ext cx="4538520" cy="2040120"/>
         </p:xfrm>
         <a:graphic>
           <a:graphicData uri="http://schemas.openxmlformats.org/drawingml/2006/table">
@@ -2107,8 +2213,8 @@
               <a:tr h="445320">
                 <a:tc>
                   <a:txBody>
-                    <a:bodyPr anchor="t">
-                      <a:noAutofit/>
+                    <a:bodyPr>
+                      <a:spAutoFit/>
                     </a:bodyPr>
                     <a:p>
                       <a:pPr>
@@ -2117,45 +2223,45 @@
                         </a:lnSpc>
                       </a:pPr>
                       <a:r>
-                        <a:rPr b="0" lang="en-US" sz="1100" spc="-1" strike="noStrike">
+                        <a:rPr lang="en-US" sz="1100" b="0" strike="noStrike" spc="-1">
                           <a:solidFill>
-                            <a:srgbClr val="ffffff"/>
+                            <a:srgbClr val="FFFFFF"/>
                           </a:solidFill>
-                          <a:latin typeface="Arial"/>
-                          <a:ea typeface="Arial"/>
+                          <a:latin typeface="Arial" panose="020B0604020202020204"/>
+                          <a:ea typeface="Arial" panose="020B0604020202020204"/>
                         </a:rPr>
                         <a:t>Upcoming Deliverables​</a:t>
                       </a:r>
-                      <a:endParaRPr b="0" lang="en-US" sz="1100" spc="-1" strike="noStrike">
+                      <a:endParaRPr lang="en-US" sz="1100" b="0" strike="noStrike" spc="-1">
                         <a:solidFill>
-                          <a:srgbClr val="ffffff"/>
+                          <a:srgbClr val="FFFFFF"/>
                         </a:solidFill>
-                        <a:latin typeface="Arial"/>
+                        <a:latin typeface="Arial" panose="020B0604020202020204"/>
                       </a:endParaRPr>
                     </a:p>
                   </a:txBody>
-                  <a:tcPr anchor="t" marL="91440" marR="91440">
+                  <a:tcPr anchor="t">
                     <a:lnL w="13680">
                       <a:solidFill>
-                        <a:srgbClr val="ffffff"/>
+                        <a:srgbClr val="FFFFFF"/>
                       </a:solidFill>
                       <a:prstDash val="solid"/>
                     </a:lnL>
                     <a:lnR w="13680">
                       <a:solidFill>
-                        <a:srgbClr val="ffffff"/>
+                        <a:srgbClr val="FFFFFF"/>
                       </a:solidFill>
                       <a:prstDash val="solid"/>
                     </a:lnR>
                     <a:lnT w="13680">
                       <a:solidFill>
-                        <a:srgbClr val="ffffff"/>
+                        <a:srgbClr val="FFFFFF"/>
                       </a:solidFill>
                       <a:prstDash val="solid"/>
                     </a:lnT>
                     <a:lnB w="13680">
                       <a:solidFill>
-                        <a:srgbClr val="ffffff"/>
+                        <a:srgbClr val="FFFFFF"/>
                       </a:solidFill>
                       <a:prstDash val="solid"/>
                     </a:lnB>
@@ -2166,8 +2272,8 @@
                 </a:tc>
                 <a:tc>
                   <a:txBody>
-                    <a:bodyPr anchor="t">
-                      <a:noAutofit/>
+                    <a:bodyPr>
+                      <a:spAutoFit/>
                     </a:bodyPr>
                     <a:p>
                       <a:pPr algn="ctr">
@@ -2176,45 +2282,45 @@
                         </a:lnSpc>
                       </a:pPr>
                       <a:r>
-                        <a:rPr b="0" lang="en-US" sz="1100" spc="-1" strike="noStrike">
+                        <a:rPr lang="en-US" sz="1100" b="0" strike="noStrike" spc="-1">
                           <a:solidFill>
-                            <a:srgbClr val="ffffff"/>
+                            <a:srgbClr val="FFFFFF"/>
                           </a:solidFill>
-                          <a:latin typeface="Arial"/>
-                          <a:ea typeface="Arial"/>
+                          <a:latin typeface="Arial" panose="020B0604020202020204"/>
+                          <a:ea typeface="Arial" panose="020B0604020202020204"/>
                         </a:rPr>
                         <a:t>Planned​</a:t>
                       </a:r>
-                      <a:endParaRPr b="0" lang="en-US" sz="1100" spc="-1" strike="noStrike">
+                      <a:endParaRPr lang="en-US" sz="1100" b="0" strike="noStrike" spc="-1">
                         <a:solidFill>
-                          <a:srgbClr val="ffffff"/>
+                          <a:srgbClr val="FFFFFF"/>
                         </a:solidFill>
-                        <a:latin typeface="Arial"/>
+                        <a:latin typeface="Arial" panose="020B0604020202020204"/>
                       </a:endParaRPr>
                     </a:p>
                   </a:txBody>
-                  <a:tcPr anchor="t" marL="91440" marR="91440">
+                  <a:tcPr anchor="t">
                     <a:lnL w="13680">
                       <a:solidFill>
-                        <a:srgbClr val="ffffff"/>
+                        <a:srgbClr val="FFFFFF"/>
                       </a:solidFill>
                       <a:prstDash val="solid"/>
                     </a:lnL>
                     <a:lnR w="13680">
                       <a:solidFill>
-                        <a:srgbClr val="ffffff"/>
+                        <a:srgbClr val="FFFFFF"/>
                       </a:solidFill>
                       <a:prstDash val="solid"/>
                     </a:lnR>
                     <a:lnT w="13680">
                       <a:solidFill>
-                        <a:srgbClr val="ffffff"/>
+                        <a:srgbClr val="FFFFFF"/>
                       </a:solidFill>
                       <a:prstDash val="solid"/>
                     </a:lnT>
                     <a:lnB w="13680">
                       <a:solidFill>
-                        <a:srgbClr val="ffffff"/>
+                        <a:srgbClr val="FFFFFF"/>
                       </a:solidFill>
                       <a:prstDash val="solid"/>
                     </a:lnB>
@@ -2225,8 +2331,8 @@
                 </a:tc>
                 <a:tc>
                   <a:txBody>
-                    <a:bodyPr anchor="t">
-                      <a:noAutofit/>
+                    <a:bodyPr>
+                      <a:spAutoFit/>
                     </a:bodyPr>
                     <a:p>
                       <a:pPr algn="ctr">
@@ -2235,45 +2341,45 @@
                         </a:lnSpc>
                       </a:pPr>
                       <a:r>
-                        <a:rPr b="0" lang="en-US" sz="1100" spc="-1" strike="noStrike">
+                        <a:rPr lang="en-US" sz="1100" b="0" strike="noStrike" spc="-1">
                           <a:solidFill>
-                            <a:srgbClr val="ffffff"/>
+                            <a:srgbClr val="FFFFFF"/>
                           </a:solidFill>
-                          <a:latin typeface="Arial"/>
-                          <a:ea typeface="Arial"/>
+                          <a:latin typeface="Arial" panose="020B0604020202020204"/>
+                          <a:ea typeface="Arial" panose="020B0604020202020204"/>
                         </a:rPr>
                         <a:t>Revised​</a:t>
                       </a:r>
-                      <a:endParaRPr b="0" lang="en-US" sz="1100" spc="-1" strike="noStrike">
+                      <a:endParaRPr lang="en-US" sz="1100" b="0" strike="noStrike" spc="-1">
                         <a:solidFill>
-                          <a:srgbClr val="ffffff"/>
+                          <a:srgbClr val="FFFFFF"/>
                         </a:solidFill>
-                        <a:latin typeface="Arial"/>
+                        <a:latin typeface="Arial" panose="020B0604020202020204"/>
                       </a:endParaRPr>
                     </a:p>
                   </a:txBody>
-                  <a:tcPr anchor="t" marL="91440" marR="91440">
+                  <a:tcPr anchor="t">
                     <a:lnL w="13680">
                       <a:solidFill>
-                        <a:srgbClr val="ffffff"/>
+                        <a:srgbClr val="FFFFFF"/>
                       </a:solidFill>
                       <a:prstDash val="solid"/>
                     </a:lnL>
                     <a:lnR w="13680">
                       <a:solidFill>
-                        <a:srgbClr val="ffffff"/>
+                        <a:srgbClr val="FFFFFF"/>
                       </a:solidFill>
                       <a:prstDash val="solid"/>
                     </a:lnR>
                     <a:lnT w="13680">
                       <a:solidFill>
-                        <a:srgbClr val="ffffff"/>
+                        <a:srgbClr val="FFFFFF"/>
                       </a:solidFill>
                       <a:prstDash val="solid"/>
                     </a:lnT>
                     <a:lnB w="13680">
                       <a:solidFill>
-                        <a:srgbClr val="ffffff"/>
+                        <a:srgbClr val="FFFFFF"/>
                       </a:solidFill>
                       <a:prstDash val="solid"/>
                     </a:lnB>
@@ -2284,8 +2390,8 @@
                 </a:tc>
                 <a:tc>
                   <a:txBody>
-                    <a:bodyPr anchor="t">
-                      <a:noAutofit/>
+                    <a:bodyPr>
+                      <a:spAutoFit/>
                     </a:bodyPr>
                     <a:p>
                       <a:pPr algn="ctr">
@@ -2294,45 +2400,45 @@
                         </a:lnSpc>
                       </a:pPr>
                       <a:r>
-                        <a:rPr b="0" lang="en-US" sz="1100" spc="-1" strike="noStrike">
+                        <a:rPr lang="en-US" sz="1100" b="0" strike="noStrike" spc="-1">
                           <a:solidFill>
-                            <a:srgbClr val="ffffff"/>
+                            <a:srgbClr val="FFFFFF"/>
                           </a:solidFill>
-                          <a:latin typeface="Arial"/>
-                          <a:ea typeface="Arial"/>
+                          <a:latin typeface="Arial" panose="020B0604020202020204"/>
+                          <a:ea typeface="Arial" panose="020B0604020202020204"/>
                         </a:rPr>
                         <a:t>Remaining​</a:t>
                       </a:r>
-                      <a:endParaRPr b="0" lang="en-US" sz="1100" spc="-1" strike="noStrike">
+                      <a:endParaRPr lang="en-US" sz="1100" b="0" strike="noStrike" spc="-1">
                         <a:solidFill>
-                          <a:srgbClr val="ffffff"/>
+                          <a:srgbClr val="FFFFFF"/>
                         </a:solidFill>
-                        <a:latin typeface="Arial"/>
+                        <a:latin typeface="Arial" panose="020B0604020202020204"/>
                       </a:endParaRPr>
                     </a:p>
                   </a:txBody>
-                  <a:tcPr anchor="t" marL="91440" marR="91440">
+                  <a:tcPr anchor="t">
                     <a:lnL w="13680">
                       <a:solidFill>
-                        <a:srgbClr val="ffffff"/>
+                        <a:srgbClr val="FFFFFF"/>
                       </a:solidFill>
                       <a:prstDash val="solid"/>
                     </a:lnL>
                     <a:lnR w="13680">
                       <a:solidFill>
-                        <a:srgbClr val="ffffff"/>
+                        <a:srgbClr val="FFFFFF"/>
                       </a:solidFill>
                       <a:prstDash val="solid"/>
                     </a:lnR>
                     <a:lnT w="13680">
                       <a:solidFill>
-                        <a:srgbClr val="ffffff"/>
+                        <a:srgbClr val="FFFFFF"/>
                       </a:solidFill>
                       <a:prstDash val="solid"/>
                     </a:lnT>
                     <a:lnB w="13680">
                       <a:solidFill>
-                        <a:srgbClr val="ffffff"/>
+                        <a:srgbClr val="FFFFFF"/>
                       </a:solidFill>
                       <a:prstDash val="solid"/>
                     </a:lnB>
@@ -2345,8 +2451,8 @@
               <a:tr h="423000">
                 <a:tc>
                   <a:txBody>
-                    <a:bodyPr anchor="t">
-                      <a:noAutofit/>
+                    <a:bodyPr>
+                      <a:spAutoFit/>
                     </a:bodyPr>
                     <a:p>
                       <a:pPr>
@@ -2355,57 +2461,57 @@
                         </a:lnSpc>
                       </a:pPr>
                       <a:r>
-                        <a:rPr b="0" lang="en" sz="1000" spc="-1" strike="noStrike">
+                        <a:rPr lang="en-GB" sz="1000" b="0" strike="noStrike" spc="-1">
                           <a:solidFill>
                             <a:srgbClr val="000000"/>
                           </a:solidFill>
-                          <a:latin typeface="Arial"/>
-                          <a:ea typeface="Arial"/>
+                          <a:latin typeface="Arial" panose="020B0604020202020204"/>
+                          <a:ea typeface="Arial" panose="020B0604020202020204"/>
                         </a:rPr>
                         <a:t>Re run MCT</a:t>
                       </a:r>
-                      <a:endParaRPr b="0" lang="en-US" sz="1000" spc="-1" strike="noStrike">
+                      <a:endParaRPr lang="en-US" sz="1000" b="0" strike="noStrike" spc="-1">
                         <a:solidFill>
                           <a:srgbClr val="000000"/>
                         </a:solidFill>
-                        <a:latin typeface="Arial"/>
+                        <a:latin typeface="Arial" panose="020B0604020202020204"/>
                       </a:endParaRPr>
                     </a:p>
                   </a:txBody>
-                  <a:tcPr anchor="t" marL="91440" marR="91440">
+                  <a:tcPr anchor="t">
                     <a:lnL w="13680">
                       <a:solidFill>
-                        <a:srgbClr val="ffffff"/>
+                        <a:srgbClr val="FFFFFF"/>
                       </a:solidFill>
                       <a:prstDash val="solid"/>
                     </a:lnL>
                     <a:lnR w="13680">
                       <a:solidFill>
-                        <a:srgbClr val="ffffff"/>
+                        <a:srgbClr val="FFFFFF"/>
                       </a:solidFill>
                       <a:prstDash val="solid"/>
                     </a:lnR>
                     <a:lnT w="13680">
                       <a:solidFill>
-                        <a:srgbClr val="ffffff"/>
+                        <a:srgbClr val="FFFFFF"/>
                       </a:solidFill>
                       <a:prstDash val="solid"/>
                     </a:lnT>
                     <a:lnB w="13680">
                       <a:solidFill>
-                        <a:srgbClr val="ffffff"/>
+                        <a:srgbClr val="FFFFFF"/>
                       </a:solidFill>
                       <a:prstDash val="solid"/>
                     </a:lnB>
                     <a:solidFill>
-                      <a:srgbClr val="e7e7e7"/>
+                      <a:srgbClr val="E7E7E7"/>
                     </a:solidFill>
                   </a:tcPr>
                 </a:tc>
                 <a:tc>
                   <a:txBody>
-                    <a:bodyPr anchor="ctr">
-                      <a:noAutofit/>
+                    <a:bodyPr>
+                      <a:spAutoFit/>
                     </a:bodyPr>
                     <a:p>
                       <a:pPr algn="ctr">
@@ -2414,57 +2520,57 @@
                         </a:lnSpc>
                       </a:pPr>
                       <a:r>
-                        <a:rPr b="0" lang="en-US" sz="1000" spc="-1" strike="noStrike">
+                        <a:rPr lang="en-US" sz="1000" b="0" strike="noStrike" spc="-1">
                           <a:solidFill>
                             <a:srgbClr val="000000"/>
                           </a:solidFill>
-                          <a:latin typeface="Arial"/>
-                          <a:ea typeface="Arial"/>
+                          <a:latin typeface="Arial" panose="020B0604020202020204"/>
+                          <a:ea typeface="Arial" panose="020B0604020202020204"/>
                         </a:rPr>
                         <a:t>9/21</a:t>
                       </a:r>
-                      <a:endParaRPr b="0" lang="en-US" sz="1000" spc="-1" strike="noStrike">
+                      <a:endParaRPr lang="en-US" sz="1000" b="0" strike="noStrike" spc="-1">
                         <a:solidFill>
                           <a:srgbClr val="000000"/>
                         </a:solidFill>
-                        <a:latin typeface="Arial"/>
+                        <a:latin typeface="Arial" panose="020B0604020202020204"/>
                       </a:endParaRPr>
                     </a:p>
                   </a:txBody>
-                  <a:tcPr anchor="ctr" marL="91440" marR="91440">
+                  <a:tcPr anchor="ctr">
                     <a:lnL w="13680">
                       <a:solidFill>
-                        <a:srgbClr val="ffffff"/>
+                        <a:srgbClr val="FFFFFF"/>
                       </a:solidFill>
                       <a:prstDash val="solid"/>
                     </a:lnL>
                     <a:lnR w="13680">
                       <a:solidFill>
-                        <a:srgbClr val="ffffff"/>
+                        <a:srgbClr val="FFFFFF"/>
                       </a:solidFill>
                       <a:prstDash val="solid"/>
                     </a:lnR>
                     <a:lnT w="13680">
                       <a:solidFill>
-                        <a:srgbClr val="ffffff"/>
+                        <a:srgbClr val="FFFFFF"/>
                       </a:solidFill>
                       <a:prstDash val="solid"/>
                     </a:lnT>
                     <a:lnB w="13680">
                       <a:solidFill>
-                        <a:srgbClr val="ffffff"/>
+                        <a:srgbClr val="FFFFFF"/>
                       </a:solidFill>
                       <a:prstDash val="solid"/>
                     </a:lnB>
                     <a:solidFill>
-                      <a:srgbClr val="93c47d"/>
+                      <a:srgbClr val="93C47D"/>
                     </a:solidFill>
                   </a:tcPr>
                 </a:tc>
                 <a:tc>
                   <a:txBody>
-                    <a:bodyPr anchor="ctr">
-                      <a:noAutofit/>
+                    <a:bodyPr>
+                      <a:spAutoFit/>
                     </a:bodyPr>
                     <a:p>
                       <a:pPr algn="ctr">
@@ -2473,57 +2579,57 @@
                         </a:lnSpc>
                       </a:pPr>
                       <a:r>
-                        <a:rPr b="0" lang="en-US" sz="1000" spc="-1" strike="noStrike">
+                        <a:rPr lang="en-US" sz="1000" b="0" strike="noStrike" spc="-1">
                           <a:solidFill>
                             <a:srgbClr val="000000"/>
                           </a:solidFill>
-                          <a:latin typeface="Arial"/>
-                          <a:ea typeface="Arial"/>
+                          <a:latin typeface="Arial" panose="020B0604020202020204"/>
+                          <a:ea typeface="Arial" panose="020B0604020202020204"/>
                         </a:rPr>
                         <a:t>10/5</a:t>
                       </a:r>
-                      <a:endParaRPr b="0" lang="en-US" sz="1000" spc="-1" strike="noStrike">
+                      <a:endParaRPr lang="en-US" sz="1000" b="0" strike="noStrike" spc="-1">
                         <a:solidFill>
                           <a:srgbClr val="000000"/>
                         </a:solidFill>
-                        <a:latin typeface="Arial"/>
+                        <a:latin typeface="Arial" panose="020B0604020202020204"/>
                       </a:endParaRPr>
                     </a:p>
                   </a:txBody>
-                  <a:tcPr anchor="ctr" marL="91440" marR="91440">
+                  <a:tcPr anchor="ctr">
                     <a:lnL w="13680">
                       <a:solidFill>
-                        <a:srgbClr val="ffffff"/>
+                        <a:srgbClr val="FFFFFF"/>
                       </a:solidFill>
                       <a:prstDash val="solid"/>
                     </a:lnL>
                     <a:lnR w="13680">
                       <a:solidFill>
-                        <a:srgbClr val="ffffff"/>
+                        <a:srgbClr val="FFFFFF"/>
                       </a:solidFill>
                       <a:prstDash val="solid"/>
                     </a:lnR>
                     <a:lnT w="13680">
                       <a:solidFill>
-                        <a:srgbClr val="ffffff"/>
+                        <a:srgbClr val="FFFFFF"/>
                       </a:solidFill>
                       <a:prstDash val="solid"/>
                     </a:lnT>
                     <a:lnB w="13680">
                       <a:solidFill>
-                        <a:srgbClr val="ffffff"/>
+                        <a:srgbClr val="FFFFFF"/>
                       </a:solidFill>
                       <a:prstDash val="solid"/>
                     </a:lnB>
                     <a:solidFill>
-                      <a:srgbClr val="93c47d"/>
+                      <a:srgbClr val="93C47D"/>
                     </a:solidFill>
                   </a:tcPr>
                 </a:tc>
                 <a:tc>
                   <a:txBody>
-                    <a:bodyPr anchor="ctr">
-                      <a:noAutofit/>
+                    <a:bodyPr>
+                      <a:spAutoFit/>
                     </a:bodyPr>
                     <a:p>
                       <a:pPr algn="ctr">
@@ -2532,50 +2638,50 @@
                         </a:lnSpc>
                       </a:pPr>
                       <a:r>
-                        <a:rPr b="0" lang="en-US" sz="1000" spc="-1" strike="noStrike">
+                        <a:rPr lang="en-US" sz="1000" b="0" strike="noStrike" spc="-1">
                           <a:solidFill>
                             <a:srgbClr val="000000"/>
                           </a:solidFill>
-                          <a:latin typeface="Arial"/>
-                          <a:ea typeface="Arial"/>
+                          <a:latin typeface="Arial" panose="020B0604020202020204"/>
+                          <a:ea typeface="Arial" panose="020B0604020202020204"/>
                         </a:rPr>
                         <a:t>8hrs</a:t>
                       </a:r>
-                      <a:endParaRPr b="0" lang="en-US" sz="1000" spc="-1" strike="noStrike">
+                      <a:endParaRPr lang="en-US" sz="1000" b="0" strike="noStrike" spc="-1">
                         <a:solidFill>
                           <a:srgbClr val="000000"/>
                         </a:solidFill>
-                        <a:latin typeface="Arial"/>
+                        <a:latin typeface="Arial" panose="020B0604020202020204"/>
                       </a:endParaRPr>
                     </a:p>
                   </a:txBody>
-                  <a:tcPr anchor="ctr" marL="91440" marR="91440">
+                  <a:tcPr anchor="ctr">
                     <a:lnL w="13680">
                       <a:solidFill>
-                        <a:srgbClr val="ffffff"/>
+                        <a:srgbClr val="FFFFFF"/>
                       </a:solidFill>
                       <a:prstDash val="solid"/>
                     </a:lnL>
                     <a:lnR w="13680">
                       <a:solidFill>
-                        <a:srgbClr val="ffffff"/>
+                        <a:srgbClr val="FFFFFF"/>
                       </a:solidFill>
                       <a:prstDash val="solid"/>
                     </a:lnR>
                     <a:lnT w="13680">
                       <a:solidFill>
-                        <a:srgbClr val="ffffff"/>
+                        <a:srgbClr val="FFFFFF"/>
                       </a:solidFill>
                       <a:prstDash val="solid"/>
                     </a:lnT>
                     <a:lnB w="13680">
                       <a:solidFill>
-                        <a:srgbClr val="ffffff"/>
+                        <a:srgbClr val="FFFFFF"/>
                       </a:solidFill>
                       <a:prstDash val="solid"/>
                     </a:lnB>
                     <a:solidFill>
-                      <a:srgbClr val="93c47d"/>
+                      <a:srgbClr val="93C47D"/>
                     </a:solidFill>
                   </a:tcPr>
                 </a:tc>
@@ -2583,8 +2689,8 @@
               <a:tr h="364680">
                 <a:tc>
                   <a:txBody>
-                    <a:bodyPr anchor="t">
-                      <a:noAutofit/>
+                    <a:bodyPr>
+                      <a:spAutoFit/>
                     </a:bodyPr>
                     <a:p>
                       <a:pPr>
@@ -2593,56 +2699,56 @@
                         </a:lnSpc>
                       </a:pPr>
                       <a:r>
-                        <a:rPr b="0" lang="en-US" sz="1000" spc="-1" strike="noStrike">
+                        <a:rPr lang="en-US" sz="1000" b="0" strike="noStrike" spc="-1">
                           <a:solidFill>
                             <a:srgbClr val="000000"/>
                           </a:solidFill>
-                          <a:latin typeface="Arial"/>
+                          <a:latin typeface="Arial" panose="020B0604020202020204"/>
                         </a:rPr>
                         <a:t>Re run SCT 1</a:t>
                       </a:r>
-                      <a:endParaRPr b="0" lang="en-US" sz="1000" spc="-1" strike="noStrike">
+                      <a:endParaRPr lang="en-US" sz="1000" b="0" strike="noStrike" spc="-1">
                         <a:solidFill>
                           <a:srgbClr val="000000"/>
                         </a:solidFill>
-                        <a:latin typeface="Arial"/>
+                        <a:latin typeface="Arial" panose="020B0604020202020204"/>
                       </a:endParaRPr>
                     </a:p>
                   </a:txBody>
-                  <a:tcPr anchor="t" marL="91440" marR="91440">
+                  <a:tcPr anchor="t">
                     <a:lnL w="13680">
                       <a:solidFill>
-                        <a:srgbClr val="ffffff"/>
+                        <a:srgbClr val="FFFFFF"/>
                       </a:solidFill>
                       <a:prstDash val="solid"/>
                     </a:lnL>
                     <a:lnR w="13680">
                       <a:solidFill>
-                        <a:srgbClr val="ffffff"/>
+                        <a:srgbClr val="FFFFFF"/>
                       </a:solidFill>
                       <a:prstDash val="solid"/>
                     </a:lnR>
                     <a:lnT w="13680">
                       <a:solidFill>
-                        <a:srgbClr val="ffffff"/>
+                        <a:srgbClr val="FFFFFF"/>
                       </a:solidFill>
                       <a:prstDash val="solid"/>
                     </a:lnT>
                     <a:lnB w="13680">
                       <a:solidFill>
-                        <a:srgbClr val="ffffff"/>
+                        <a:srgbClr val="FFFFFF"/>
                       </a:solidFill>
                       <a:prstDash val="solid"/>
                     </a:lnB>
                     <a:solidFill>
-                      <a:srgbClr val="e7e7e7"/>
+                      <a:srgbClr val="E7E7E7"/>
                     </a:solidFill>
                   </a:tcPr>
                 </a:tc>
                 <a:tc>
                   <a:txBody>
-                    <a:bodyPr anchor="ctr">
-                      <a:noAutofit/>
+                    <a:bodyPr>
+                      <a:spAutoFit/>
                     </a:bodyPr>
                     <a:p>
                       <a:pPr algn="ctr">
@@ -2651,56 +2757,56 @@
                         </a:lnSpc>
                       </a:pPr>
                       <a:r>
-                        <a:rPr b="0" lang="en-US" sz="1000" spc="-1" strike="noStrike">
+                        <a:rPr lang="en-US" sz="1000" b="0" strike="noStrike" spc="-1">
                           <a:solidFill>
                             <a:srgbClr val="000000"/>
                           </a:solidFill>
-                          <a:latin typeface="Arial"/>
+                          <a:latin typeface="Arial" panose="020B0604020202020204"/>
                         </a:rPr>
                         <a:t>9/30</a:t>
                       </a:r>
-                      <a:endParaRPr b="0" lang="en-US" sz="1000" spc="-1" strike="noStrike">
+                      <a:endParaRPr lang="en-US" sz="1000" b="0" strike="noStrike" spc="-1">
                         <a:solidFill>
                           <a:srgbClr val="000000"/>
                         </a:solidFill>
-                        <a:latin typeface="Arial"/>
+                        <a:latin typeface="Arial" panose="020B0604020202020204"/>
                       </a:endParaRPr>
                     </a:p>
                   </a:txBody>
-                  <a:tcPr anchor="ctr" marL="91440" marR="91440">
+                  <a:tcPr anchor="ctr">
                     <a:lnL w="13680">
                       <a:solidFill>
-                        <a:srgbClr val="ffffff"/>
+                        <a:srgbClr val="FFFFFF"/>
                       </a:solidFill>
                       <a:prstDash val="solid"/>
                     </a:lnL>
                     <a:lnR w="13680">
                       <a:solidFill>
-                        <a:srgbClr val="ffffff"/>
+                        <a:srgbClr val="FFFFFF"/>
                       </a:solidFill>
                       <a:prstDash val="solid"/>
                     </a:lnR>
                     <a:lnT w="13680">
                       <a:solidFill>
-                        <a:srgbClr val="ffffff"/>
+                        <a:srgbClr val="FFFFFF"/>
                       </a:solidFill>
                       <a:prstDash val="solid"/>
                     </a:lnT>
                     <a:lnB w="13680">
                       <a:solidFill>
-                        <a:srgbClr val="ffffff"/>
+                        <a:srgbClr val="FFFFFF"/>
                       </a:solidFill>
                       <a:prstDash val="solid"/>
                     </a:lnB>
                     <a:solidFill>
-                      <a:srgbClr val="93c47d"/>
+                      <a:srgbClr val="93C47D"/>
                     </a:solidFill>
                   </a:tcPr>
                 </a:tc>
                 <a:tc>
                   <a:txBody>
-                    <a:bodyPr anchor="ctr">
-                      <a:noAutofit/>
+                    <a:bodyPr>
+                      <a:spAutoFit/>
                     </a:bodyPr>
                     <a:p>
                       <a:pPr algn="ctr">
@@ -2709,56 +2815,56 @@
                         </a:lnSpc>
                       </a:pPr>
                       <a:r>
-                        <a:rPr b="0" lang="en-US" sz="1000" spc="-1" strike="noStrike">
+                        <a:rPr lang="en-US" sz="1000" b="0" strike="noStrike" spc="-1">
                           <a:solidFill>
                             <a:srgbClr val="000000"/>
                           </a:solidFill>
-                          <a:latin typeface="Arial"/>
+                          <a:latin typeface="Arial" panose="020B0604020202020204"/>
                         </a:rPr>
                         <a:t>10/20</a:t>
                       </a:r>
-                      <a:endParaRPr b="0" lang="en-US" sz="1000" spc="-1" strike="noStrike">
+                      <a:endParaRPr lang="en-US" sz="1000" b="0" strike="noStrike" spc="-1">
                         <a:solidFill>
                           <a:srgbClr val="000000"/>
                         </a:solidFill>
-                        <a:latin typeface="Arial"/>
+                        <a:latin typeface="Arial" panose="020B0604020202020204"/>
                       </a:endParaRPr>
                     </a:p>
                   </a:txBody>
-                  <a:tcPr anchor="ctr" marL="91440" marR="91440">
+                  <a:tcPr anchor="ctr">
                     <a:lnL w="13680">
                       <a:solidFill>
-                        <a:srgbClr val="ffffff"/>
+                        <a:srgbClr val="FFFFFF"/>
                       </a:solidFill>
                       <a:prstDash val="solid"/>
                     </a:lnL>
                     <a:lnR w="13680">
                       <a:solidFill>
-                        <a:srgbClr val="ffffff"/>
+                        <a:srgbClr val="FFFFFF"/>
                       </a:solidFill>
                       <a:prstDash val="solid"/>
                     </a:lnR>
                     <a:lnT w="13680">
                       <a:solidFill>
-                        <a:srgbClr val="ffffff"/>
+                        <a:srgbClr val="FFFFFF"/>
                       </a:solidFill>
                       <a:prstDash val="solid"/>
                     </a:lnT>
                     <a:lnB w="13680">
                       <a:solidFill>
-                        <a:srgbClr val="ffffff"/>
+                        <a:srgbClr val="FFFFFF"/>
                       </a:solidFill>
                       <a:prstDash val="solid"/>
                     </a:lnB>
                     <a:solidFill>
-                      <a:srgbClr val="93c47d"/>
+                      <a:srgbClr val="93C47D"/>
                     </a:solidFill>
                   </a:tcPr>
                 </a:tc>
                 <a:tc>
                   <a:txBody>
-                    <a:bodyPr anchor="ctr">
-                      <a:noAutofit/>
+                    <a:bodyPr>
+                      <a:spAutoFit/>
                     </a:bodyPr>
                     <a:p>
                       <a:pPr algn="ctr">
@@ -2767,49 +2873,49 @@
                         </a:lnSpc>
                       </a:pPr>
                       <a:r>
-                        <a:rPr b="0" lang="en-US" sz="1000" spc="-1" strike="noStrike">
+                        <a:rPr lang="en-US" sz="1000" b="0" strike="noStrike" spc="-1">
                           <a:solidFill>
                             <a:srgbClr val="000000"/>
                           </a:solidFill>
-                          <a:latin typeface="Arial"/>
+                          <a:latin typeface="Arial" panose="020B0604020202020204"/>
                         </a:rPr>
                         <a:t>30hrs</a:t>
                       </a:r>
-                      <a:endParaRPr b="0" lang="en-US" sz="1000" spc="-1" strike="noStrike">
+                      <a:endParaRPr lang="en-US" sz="1000" b="0" strike="noStrike" spc="-1">
                         <a:solidFill>
                           <a:srgbClr val="000000"/>
                         </a:solidFill>
-                        <a:latin typeface="Arial"/>
+                        <a:latin typeface="Arial" panose="020B0604020202020204"/>
                       </a:endParaRPr>
                     </a:p>
                   </a:txBody>
-                  <a:tcPr anchor="ctr" marL="91440" marR="91440">
+                  <a:tcPr anchor="ctr">
                     <a:lnL w="13680">
                       <a:solidFill>
-                        <a:srgbClr val="ffffff"/>
+                        <a:srgbClr val="FFFFFF"/>
                       </a:solidFill>
                       <a:prstDash val="solid"/>
                     </a:lnL>
                     <a:lnR w="13680">
                       <a:solidFill>
-                        <a:srgbClr val="ffffff"/>
+                        <a:srgbClr val="FFFFFF"/>
                       </a:solidFill>
                       <a:prstDash val="solid"/>
                     </a:lnR>
                     <a:lnT w="13680">
                       <a:solidFill>
-                        <a:srgbClr val="ffffff"/>
+                        <a:srgbClr val="FFFFFF"/>
                       </a:solidFill>
                       <a:prstDash val="solid"/>
                     </a:lnT>
                     <a:lnB w="13680">
                       <a:solidFill>
-                        <a:srgbClr val="ffffff"/>
+                        <a:srgbClr val="FFFFFF"/>
                       </a:solidFill>
                       <a:prstDash val="solid"/>
                     </a:lnB>
                     <a:solidFill>
-                      <a:srgbClr val="93c47d"/>
+                      <a:srgbClr val="93C47D"/>
                     </a:solidFill>
                   </a:tcPr>
                 </a:tc>
@@ -2817,8 +2923,8 @@
               <a:tr h="391680">
                 <a:tc>
                   <a:txBody>
-                    <a:bodyPr anchor="t">
-                      <a:noAutofit/>
+                    <a:bodyPr>
+                      <a:spAutoFit/>
                     </a:bodyPr>
                     <a:p>
                       <a:pPr>
@@ -2827,56 +2933,56 @@
                         </a:lnSpc>
                       </a:pPr>
                       <a:r>
-                        <a:rPr b="0" lang="en-US" sz="1000" spc="-1" strike="noStrike">
+                        <a:rPr lang="en-US" sz="1000" b="0" strike="noStrike" spc="-1">
                           <a:solidFill>
                             <a:srgbClr val="000000"/>
                           </a:solidFill>
-                          <a:latin typeface="Arial"/>
+                          <a:latin typeface="Arial" panose="020B0604020202020204"/>
                         </a:rPr>
                         <a:t>Ground Station PC test</a:t>
                       </a:r>
-                      <a:endParaRPr b="0" lang="en-US" sz="1000" spc="-1" strike="noStrike">
+                      <a:endParaRPr lang="en-US" sz="1000" b="0" strike="noStrike" spc="-1">
                         <a:solidFill>
                           <a:srgbClr val="000000"/>
                         </a:solidFill>
-                        <a:latin typeface="Arial"/>
+                        <a:latin typeface="Arial" panose="020B0604020202020204"/>
                       </a:endParaRPr>
                     </a:p>
                   </a:txBody>
-                  <a:tcPr anchor="t" marL="91440" marR="91440">
+                  <a:tcPr anchor="t">
                     <a:lnL w="13680">
                       <a:solidFill>
-                        <a:srgbClr val="ffffff"/>
+                        <a:srgbClr val="FFFFFF"/>
                       </a:solidFill>
                       <a:prstDash val="solid"/>
                     </a:lnL>
                     <a:lnR w="13680">
                       <a:solidFill>
-                        <a:srgbClr val="ffffff"/>
+                        <a:srgbClr val="FFFFFF"/>
                       </a:solidFill>
                       <a:prstDash val="solid"/>
                     </a:lnR>
                     <a:lnT w="13680">
                       <a:solidFill>
-                        <a:srgbClr val="ffffff"/>
+                        <a:srgbClr val="FFFFFF"/>
                       </a:solidFill>
                       <a:prstDash val="solid"/>
                     </a:lnT>
                     <a:lnB w="13680">
                       <a:solidFill>
-                        <a:srgbClr val="ffffff"/>
+                        <a:srgbClr val="FFFFFF"/>
                       </a:solidFill>
                       <a:prstDash val="solid"/>
                     </a:lnB>
                     <a:solidFill>
-                      <a:srgbClr val="e7e7e7"/>
+                      <a:srgbClr val="E7E7E7"/>
                     </a:solidFill>
                   </a:tcPr>
                 </a:tc>
                 <a:tc>
                   <a:txBody>
-                    <a:bodyPr anchor="ctr">
-                      <a:noAutofit/>
+                    <a:bodyPr>
+                      <a:spAutoFit/>
                     </a:bodyPr>
                     <a:p>
                       <a:pPr algn="ctr">
@@ -2885,56 +2991,56 @@
                         </a:lnSpc>
                       </a:pPr>
                       <a:r>
-                        <a:rPr b="0" lang="en-US" sz="1000" spc="-1" strike="noStrike">
+                        <a:rPr lang="en-US" sz="1000" b="0" strike="noStrike" spc="-1">
                           <a:solidFill>
                             <a:srgbClr val="000000"/>
                           </a:solidFill>
-                          <a:latin typeface="Arial"/>
+                          <a:latin typeface="Arial" panose="020B0604020202020204"/>
                         </a:rPr>
                         <a:t>9/23</a:t>
                       </a:r>
-                      <a:endParaRPr b="0" lang="en-US" sz="1000" spc="-1" strike="noStrike">
+                      <a:endParaRPr lang="en-US" sz="1000" b="0" strike="noStrike" spc="-1">
                         <a:solidFill>
                           <a:srgbClr val="000000"/>
                         </a:solidFill>
-                        <a:latin typeface="Arial"/>
+                        <a:latin typeface="Arial" panose="020B0604020202020204"/>
                       </a:endParaRPr>
                     </a:p>
                   </a:txBody>
-                  <a:tcPr anchor="ctr" marL="91440" marR="91440">
+                  <a:tcPr anchor="ctr">
                     <a:lnL w="13680">
                       <a:solidFill>
-                        <a:srgbClr val="ffffff"/>
+                        <a:srgbClr val="FFFFFF"/>
                       </a:solidFill>
                       <a:prstDash val="solid"/>
                     </a:lnL>
                     <a:lnR w="13680">
                       <a:solidFill>
-                        <a:srgbClr val="ffffff"/>
+                        <a:srgbClr val="FFFFFF"/>
                       </a:solidFill>
                       <a:prstDash val="solid"/>
                     </a:lnR>
                     <a:lnT w="13680">
                       <a:solidFill>
-                        <a:srgbClr val="ffffff"/>
+                        <a:srgbClr val="FFFFFF"/>
                       </a:solidFill>
                       <a:prstDash val="solid"/>
                     </a:lnT>
                     <a:lnB w="13680">
                       <a:solidFill>
-                        <a:srgbClr val="ffffff"/>
+                        <a:srgbClr val="FFFFFF"/>
                       </a:solidFill>
                       <a:prstDash val="solid"/>
                     </a:lnB>
                     <a:solidFill>
-                      <a:srgbClr val="93c47d"/>
+                      <a:srgbClr val="93C47D"/>
                     </a:solidFill>
                   </a:tcPr>
                 </a:tc>
                 <a:tc>
                   <a:txBody>
-                    <a:bodyPr anchor="ctr">
-                      <a:noAutofit/>
+                    <a:bodyPr>
+                      <a:spAutoFit/>
                     </a:bodyPr>
                     <a:p>
                       <a:pPr algn="ctr">
@@ -2943,56 +3049,56 @@
                         </a:lnSpc>
                       </a:pPr>
                       <a:r>
-                        <a:rPr b="0" lang="en-US" sz="1000" spc="-1" strike="noStrike">
+                        <a:rPr lang="en-US" sz="1000" b="0" strike="noStrike" spc="-1">
                           <a:solidFill>
                             <a:srgbClr val="000000"/>
                           </a:solidFill>
-                          <a:latin typeface="Arial"/>
+                          <a:latin typeface="Arial" panose="020B0604020202020204"/>
                         </a:rPr>
                         <a:t>10/23</a:t>
                       </a:r>
-                      <a:endParaRPr b="0" lang="en-US" sz="1000" spc="-1" strike="noStrike">
+                      <a:endParaRPr lang="en-US" sz="1000" b="0" strike="noStrike" spc="-1">
                         <a:solidFill>
                           <a:srgbClr val="000000"/>
                         </a:solidFill>
-                        <a:latin typeface="Arial"/>
+                        <a:latin typeface="Arial" panose="020B0604020202020204"/>
                       </a:endParaRPr>
                     </a:p>
                   </a:txBody>
-                  <a:tcPr anchor="ctr" marL="91440" marR="91440">
+                  <a:tcPr anchor="ctr">
                     <a:lnL w="13680">
                       <a:solidFill>
-                        <a:srgbClr val="ffffff"/>
+                        <a:srgbClr val="FFFFFF"/>
                       </a:solidFill>
                       <a:prstDash val="solid"/>
                     </a:lnL>
                     <a:lnR w="13680">
                       <a:solidFill>
-                        <a:srgbClr val="ffffff"/>
+                        <a:srgbClr val="FFFFFF"/>
                       </a:solidFill>
                       <a:prstDash val="solid"/>
                     </a:lnR>
                     <a:lnT w="13680">
                       <a:solidFill>
-                        <a:srgbClr val="ffffff"/>
+                        <a:srgbClr val="FFFFFF"/>
                       </a:solidFill>
                       <a:prstDash val="solid"/>
                     </a:lnT>
                     <a:lnB w="13680">
                       <a:solidFill>
-                        <a:srgbClr val="ffffff"/>
+                        <a:srgbClr val="FFFFFF"/>
                       </a:solidFill>
                       <a:prstDash val="solid"/>
                     </a:lnB>
                     <a:solidFill>
-                      <a:srgbClr val="93c47d"/>
+                      <a:srgbClr val="93C47D"/>
                     </a:solidFill>
                   </a:tcPr>
                 </a:tc>
                 <a:tc>
                   <a:txBody>
-                    <a:bodyPr anchor="ctr">
-                      <a:noAutofit/>
+                    <a:bodyPr>
+                      <a:spAutoFit/>
                     </a:bodyPr>
                     <a:p>
                       <a:pPr algn="ctr">
@@ -3001,49 +3107,49 @@
                         </a:lnSpc>
                       </a:pPr>
                       <a:r>
-                        <a:rPr b="0" lang="en-US" sz="1000" spc="-1" strike="noStrike">
+                        <a:rPr lang="en-US" sz="1000" b="0" strike="noStrike" spc="-1">
                           <a:solidFill>
                             <a:srgbClr val="000000"/>
                           </a:solidFill>
-                          <a:latin typeface="Arial"/>
+                          <a:latin typeface="Arial" panose="020B0604020202020204"/>
                         </a:rPr>
                         <a:t>26hrs</a:t>
                       </a:r>
-                      <a:endParaRPr b="0" lang="en-US" sz="1000" spc="-1" strike="noStrike">
+                      <a:endParaRPr lang="en-US" sz="1000" b="0" strike="noStrike" spc="-1">
                         <a:solidFill>
                           <a:srgbClr val="000000"/>
                         </a:solidFill>
-                        <a:latin typeface="Arial"/>
+                        <a:latin typeface="Arial" panose="020B0604020202020204"/>
                       </a:endParaRPr>
                     </a:p>
                   </a:txBody>
-                  <a:tcPr anchor="ctr" marL="91440" marR="91440">
+                  <a:tcPr anchor="ctr">
                     <a:lnL w="13680">
                       <a:solidFill>
-                        <a:srgbClr val="ffffff"/>
+                        <a:srgbClr val="FFFFFF"/>
                       </a:solidFill>
                       <a:prstDash val="solid"/>
                     </a:lnL>
                     <a:lnR w="13680">
                       <a:solidFill>
-                        <a:srgbClr val="ffffff"/>
+                        <a:srgbClr val="FFFFFF"/>
                       </a:solidFill>
                       <a:prstDash val="solid"/>
                     </a:lnR>
                     <a:lnT w="13680">
                       <a:solidFill>
-                        <a:srgbClr val="ffffff"/>
+                        <a:srgbClr val="FFFFFF"/>
                       </a:solidFill>
                       <a:prstDash val="solid"/>
                     </a:lnT>
                     <a:lnB w="13680">
                       <a:solidFill>
-                        <a:srgbClr val="ffffff"/>
+                        <a:srgbClr val="FFFFFF"/>
                       </a:solidFill>
                       <a:prstDash val="solid"/>
                     </a:lnB>
                     <a:solidFill>
-                      <a:srgbClr val="93c47d"/>
+                      <a:srgbClr val="93C47D"/>
                     </a:solidFill>
                   </a:tcPr>
                 </a:tc>
@@ -3051,177 +3157,177 @@
               <a:tr h="415440">
                 <a:tc>
                   <a:txBody>
-                    <a:bodyPr anchor="t">
-                      <a:noAutofit/>
+                    <a:bodyPr>
+                      <a:spAutoFit/>
                     </a:bodyPr>
                     <a:p>
-                      <a:endParaRPr b="0" lang="en-US" sz="1800" spc="-1" strike="noStrike">
+                      <a:endParaRPr lang="en-US" sz="1800" b="0" strike="noStrike" spc="-1">
                         <a:solidFill>
                           <a:srgbClr val="000000"/>
                         </a:solidFill>
-                        <a:latin typeface="Arial"/>
+                        <a:latin typeface="Arial" panose="020B0604020202020204"/>
                       </a:endParaRPr>
                     </a:p>
                   </a:txBody>
-                  <a:tcPr anchor="t" marL="91440" marR="91440">
+                  <a:tcPr anchor="t">
                     <a:lnL w="13680">
                       <a:solidFill>
-                        <a:srgbClr val="ffffff"/>
+                        <a:srgbClr val="FFFFFF"/>
                       </a:solidFill>
                       <a:prstDash val="solid"/>
                     </a:lnL>
                     <a:lnR w="13680">
                       <a:solidFill>
-                        <a:srgbClr val="ffffff"/>
+                        <a:srgbClr val="FFFFFF"/>
                       </a:solidFill>
                       <a:prstDash val="solid"/>
                     </a:lnR>
                     <a:lnT w="13680">
                       <a:solidFill>
-                        <a:srgbClr val="ffffff"/>
+                        <a:srgbClr val="FFFFFF"/>
                       </a:solidFill>
                       <a:prstDash val="solid"/>
                     </a:lnT>
                     <a:lnB w="13680">
                       <a:solidFill>
-                        <a:srgbClr val="ffffff"/>
+                        <a:srgbClr val="FFFFFF"/>
                       </a:solidFill>
                       <a:prstDash val="solid"/>
                     </a:lnB>
                     <a:solidFill>
-                      <a:srgbClr val="e7e7e7"/>
+                      <a:srgbClr val="E7E7E7"/>
                     </a:solidFill>
                   </a:tcPr>
                 </a:tc>
                 <a:tc>
                   <a:txBody>
-                    <a:bodyPr anchor="ctr">
-                      <a:noAutofit/>
+                    <a:bodyPr>
+                      <a:spAutoFit/>
                     </a:bodyPr>
                     <a:p>
-                      <a:endParaRPr b="0" lang="en-US" sz="1800" spc="-1" strike="noStrike">
+                      <a:endParaRPr lang="en-US" sz="1800" b="0" strike="noStrike" spc="-1">
                         <a:solidFill>
                           <a:srgbClr val="000000"/>
                         </a:solidFill>
-                        <a:latin typeface="Arial"/>
+                        <a:latin typeface="Arial" panose="020B0604020202020204"/>
                       </a:endParaRPr>
                     </a:p>
                   </a:txBody>
-                  <a:tcPr anchor="ctr" marL="91440" marR="91440">
+                  <a:tcPr anchor="ctr">
                     <a:lnL w="13680">
                       <a:solidFill>
-                        <a:srgbClr val="ffffff"/>
+                        <a:srgbClr val="FFFFFF"/>
                       </a:solidFill>
                       <a:prstDash val="solid"/>
                     </a:lnL>
                     <a:lnR w="13680">
                       <a:solidFill>
-                        <a:srgbClr val="ffffff"/>
+                        <a:srgbClr val="FFFFFF"/>
                       </a:solidFill>
                       <a:prstDash val="solid"/>
                     </a:lnR>
                     <a:lnT w="13680">
                       <a:solidFill>
-                        <a:srgbClr val="ffffff"/>
+                        <a:srgbClr val="FFFFFF"/>
                       </a:solidFill>
                       <a:prstDash val="solid"/>
                     </a:lnT>
                     <a:lnB w="13680">
                       <a:solidFill>
-                        <a:srgbClr val="ffffff"/>
+                        <a:srgbClr val="FFFFFF"/>
                       </a:solidFill>
                       <a:prstDash val="solid"/>
                     </a:lnB>
                     <a:solidFill>
-                      <a:srgbClr val="93c47d"/>
+                      <a:srgbClr val="93C47D"/>
                     </a:solidFill>
                   </a:tcPr>
                 </a:tc>
                 <a:tc>
                   <a:txBody>
-                    <a:bodyPr anchor="ctr">
-                      <a:noAutofit/>
+                    <a:bodyPr>
+                      <a:spAutoFit/>
                     </a:bodyPr>
                     <a:p>
-                      <a:endParaRPr b="0" lang="en-US" sz="1800" spc="-1" strike="noStrike">
+                      <a:endParaRPr lang="en-US" sz="1800" b="0" strike="noStrike" spc="-1">
                         <a:solidFill>
                           <a:srgbClr val="000000"/>
                         </a:solidFill>
-                        <a:latin typeface="Arial"/>
+                        <a:latin typeface="Arial" panose="020B0604020202020204"/>
                       </a:endParaRPr>
                     </a:p>
                   </a:txBody>
-                  <a:tcPr anchor="ctr" marL="91440" marR="91440">
+                  <a:tcPr anchor="ctr">
                     <a:lnL w="13680">
                       <a:solidFill>
-                        <a:srgbClr val="ffffff"/>
+                        <a:srgbClr val="FFFFFF"/>
                       </a:solidFill>
                       <a:prstDash val="solid"/>
                     </a:lnL>
                     <a:lnR w="13680">
                       <a:solidFill>
-                        <a:srgbClr val="ffffff"/>
+                        <a:srgbClr val="FFFFFF"/>
                       </a:solidFill>
                       <a:prstDash val="solid"/>
                     </a:lnR>
                     <a:lnT w="13680">
                       <a:solidFill>
-                        <a:srgbClr val="ffffff"/>
+                        <a:srgbClr val="FFFFFF"/>
                       </a:solidFill>
                       <a:prstDash val="solid"/>
                     </a:lnT>
                     <a:lnB w="13680">
                       <a:solidFill>
-                        <a:srgbClr val="ffffff"/>
+                        <a:srgbClr val="FFFFFF"/>
                       </a:solidFill>
                       <a:prstDash val="solid"/>
                     </a:lnB>
                     <a:solidFill>
-                      <a:srgbClr val="93c47d"/>
+                      <a:srgbClr val="93C47D"/>
                     </a:solidFill>
                   </a:tcPr>
                 </a:tc>
                 <a:tc>
                   <a:txBody>
-                    <a:bodyPr anchor="ctr">
-                      <a:noAutofit/>
+                    <a:bodyPr>
+                      <a:spAutoFit/>
                     </a:bodyPr>
                     <a:p>
-                      <a:endParaRPr b="0" lang="en-US" sz="1800" spc="-1" strike="noStrike">
+                      <a:endParaRPr lang="en-US" sz="1800" b="0" strike="noStrike" spc="-1">
                         <a:solidFill>
                           <a:srgbClr val="000000"/>
                         </a:solidFill>
-                        <a:latin typeface="Arial"/>
+                        <a:latin typeface="Arial" panose="020B0604020202020204"/>
                       </a:endParaRPr>
                     </a:p>
                   </a:txBody>
-                  <a:tcPr anchor="ctr" marL="91440" marR="91440">
+                  <a:tcPr anchor="ctr">
                     <a:lnL w="13680">
                       <a:solidFill>
-                        <a:srgbClr val="ffffff"/>
+                        <a:srgbClr val="FFFFFF"/>
                       </a:solidFill>
                       <a:prstDash val="solid"/>
                     </a:lnL>
                     <a:lnR w="13680">
                       <a:solidFill>
-                        <a:srgbClr val="ffffff"/>
+                        <a:srgbClr val="FFFFFF"/>
                       </a:solidFill>
                       <a:prstDash val="solid"/>
                     </a:lnR>
                     <a:lnT w="13680">
                       <a:solidFill>
-                        <a:srgbClr val="ffffff"/>
+                        <a:srgbClr val="FFFFFF"/>
                       </a:solidFill>
                       <a:prstDash val="solid"/>
                     </a:lnT>
                     <a:lnB w="13680">
                       <a:solidFill>
-                        <a:srgbClr val="ffffff"/>
+                        <a:srgbClr val="FFFFFF"/>
                       </a:solidFill>
                       <a:prstDash val="solid"/>
                     </a:lnB>
                     <a:solidFill>
-                      <a:srgbClr val="93c47d"/>
+                      <a:srgbClr val="93C47D"/>
                     </a:solidFill>
                   </a:tcPr>
                 </a:tc>
@@ -3250,13 +3356,19 @@
           </a:ln>
         </p:spPr>
         <p:style>
-          <a:lnRef idx="0"/>
-          <a:fillRef idx="0"/>
-          <a:effectRef idx="0"/>
+          <a:lnRef idx="0">
+            <a:srgbClr val="FFFFFF"/>
+          </a:lnRef>
+          <a:fillRef idx="0">
+            <a:srgbClr val="FFFFFF"/>
+          </a:fillRef>
+          <a:effectRef idx="0">
+            <a:srgbClr val="FFFFFF"/>
+          </a:effectRef>
           <a:fontRef idx="minor"/>
         </p:style>
         <p:txBody>
-          <a:bodyPr lIns="90000" rIns="90000" tIns="91440" bIns="91440" anchor="t">
+          <a:bodyPr lIns="90000" tIns="91440" rIns="90000" bIns="91440" anchor="t">
             <a:noAutofit/>
           </a:bodyPr>
           <a:p>
@@ -3266,28 +3378,31 @@
               </a:lnSpc>
             </a:pPr>
             <a:r>
-              <a:rPr b="0" lang="en-US" sz="2300" spc="-1" strike="noStrike">
-                <a:solidFill>
-                  <a:srgbClr val="000000"/>
-                </a:solidFill>
-                <a:latin typeface="Arial"/>
-                <a:ea typeface="Arial"/>
+              <a:rPr lang="en-US" sz="2300" b="0" strike="noStrike" spc="-1">
+                <a:solidFill>
+                  <a:srgbClr val="000000"/>
+                </a:solidFill>
+                <a:latin typeface="Arial" panose="020B0604020202020204"/>
+                <a:ea typeface="Arial" panose="020B0604020202020204"/>
               </a:rPr>
               <a:t>COMMs</a:t>
             </a:r>
-            <a:endParaRPr b="0" lang="en-US" sz="2300" spc="-1" strike="noStrike">
-              <a:solidFill>
-                <a:srgbClr val="000000"/>
-              </a:solidFill>
-              <a:latin typeface="Arial"/>
+            <a:endParaRPr lang="en-US" sz="2300" b="0" strike="noStrike" spc="-1">
+              <a:solidFill>
+                <a:srgbClr val="000000"/>
+              </a:solidFill>
+              <a:latin typeface="Arial" panose="020B0604020202020204"/>
             </a:endParaRPr>
           </a:p>
         </p:txBody>
       </p:sp>
     </p:spTree>
   </p:cSld>
-  <mc:AlternateContent>
-    <mc:Choice Requires="p14">
+  <p:clrMapOvr>
+    <a:masterClrMapping/>
+  </p:clrMapOvr>
+  <mc:AlternateContent xmlns:mc="http://schemas.openxmlformats.org/markup-compatibility/2006">
+    <mc:Choice xmlns:p14="http://schemas.microsoft.com/office/powerpoint/2010/main" Requires="p14">
       <p:transition spd="slow" p14:dur="2000"/>
     </mc:Choice>
     <mc:Fallback>
@@ -3297,60 +3412,289 @@
 </p:sld>
 </file>
 
+<file path=ppt/slides/slide2.xml><?xml version="1.0" encoding="utf-8"?>
+<p:sld xmlns:a="http://schemas.openxmlformats.org/drawingml/2006/main" xmlns:r="http://schemas.openxmlformats.org/officeDocument/2006/relationships" xmlns:p="http://schemas.openxmlformats.org/presentationml/2006/main">
+  <p:cSld>
+    <p:spTree>
+      <p:nvGrpSpPr>
+        <p:cNvPr id="1" name=""/>
+        <p:cNvGrpSpPr/>
+        <p:nvPr/>
+      </p:nvGrpSpPr>
+      <p:grpSpPr/>
+      <p:sp>
+        <p:nvSpPr>
+          <p:cNvPr id="5" name="Rectangles 4"/>
+          <p:cNvSpPr/>
+          <p:nvPr/>
+        </p:nvSpPr>
+        <p:spPr>
+          <a:xfrm>
+            <a:off x="0" y="-20320"/>
+            <a:ext cx="9144000" cy="5163820"/>
+          </a:xfrm>
+          <a:prstGeom prst="rect">
+            <a:avLst/>
+          </a:prstGeom>
+          <a:solidFill>
+            <a:schemeClr val="bg1"/>
+          </a:solidFill>
+        </p:spPr>
+        <p:style>
+          <a:lnRef idx="2">
+            <a:schemeClr val="accent1">
+              <a:shade val="50000"/>
+            </a:schemeClr>
+          </a:lnRef>
+          <a:fillRef idx="1">
+            <a:schemeClr val="accent1"/>
+          </a:fillRef>
+          <a:effectRef idx="0">
+            <a:schemeClr val="accent1"/>
+          </a:effectRef>
+          <a:fontRef idx="minor">
+            <a:schemeClr val="lt1"/>
+          </a:fontRef>
+        </p:style>
+        <p:txBody>
+          <a:bodyPr rtlCol="0" anchor="ctr"/>
+          <a:p>
+            <a:pPr algn="ctr"/>
+            <a:r>
+              <a:rPr lang="en-US">
+                <a:sym typeface="+mn-ea"/>
+              </a:rPr>
+              <a:t>li2 no op</a:t>
+            </a:r>
+            <a:endParaRPr lang="en-US"/>
+          </a:p>
+        </p:txBody>
+      </p:sp>
+      <p:pic>
+        <p:nvPicPr>
+          <p:cNvPr id="2" name="Picture 1"/>
+          <p:cNvPicPr>
+            <a:picLocks noChangeAspect="1"/>
+          </p:cNvPicPr>
+          <p:nvPr/>
+        </p:nvPicPr>
+        <p:blipFill>
+          <a:blip r:embed="rId1"/>
+          <a:stretch>
+            <a:fillRect/>
+          </a:stretch>
+        </p:blipFill>
+        <p:spPr>
+          <a:xfrm>
+            <a:off x="1043940" y="267335"/>
+            <a:ext cx="5785485" cy="1574165"/>
+          </a:xfrm>
+          <a:prstGeom prst="rect">
+            <a:avLst/>
+          </a:prstGeom>
+        </p:spPr>
+      </p:pic>
+      <p:pic>
+        <p:nvPicPr>
+          <p:cNvPr id="3" name="Picture 2"/>
+          <p:cNvPicPr>
+            <a:picLocks noChangeAspect="1"/>
+          </p:cNvPicPr>
+          <p:nvPr/>
+        </p:nvPicPr>
+        <p:blipFill>
+          <a:blip r:embed="rId2"/>
+          <a:stretch>
+            <a:fillRect/>
+          </a:stretch>
+        </p:blipFill>
+        <p:spPr>
+          <a:xfrm>
+            <a:off x="1043940" y="2067560"/>
+            <a:ext cx="6501765" cy="1273810"/>
+          </a:xfrm>
+          <a:prstGeom prst="rect">
+            <a:avLst/>
+          </a:prstGeom>
+        </p:spPr>
+      </p:pic>
+      <p:pic>
+        <p:nvPicPr>
+          <p:cNvPr id="4" name="Picture 3"/>
+          <p:cNvPicPr>
+            <a:picLocks noChangeAspect="1"/>
+          </p:cNvPicPr>
+          <p:nvPr/>
+        </p:nvPicPr>
+        <p:blipFill>
+          <a:blip r:embed="rId3"/>
+          <a:stretch>
+            <a:fillRect/>
+          </a:stretch>
+        </p:blipFill>
+        <p:spPr>
+          <a:xfrm>
+            <a:off x="1619885" y="3567430"/>
+            <a:ext cx="4439285" cy="1196340"/>
+          </a:xfrm>
+          <a:prstGeom prst="rect">
+            <a:avLst/>
+          </a:prstGeom>
+        </p:spPr>
+      </p:pic>
+      <p:sp>
+        <p:nvSpPr>
+          <p:cNvPr id="6" name="Text Box 5"/>
+          <p:cNvSpPr txBox="1"/>
+          <p:nvPr/>
+        </p:nvSpPr>
+        <p:spPr>
+          <a:xfrm>
+            <a:off x="7077075" y="414020"/>
+            <a:ext cx="1743710" cy="368300"/>
+          </a:xfrm>
+          <a:prstGeom prst="rect">
+            <a:avLst/>
+          </a:prstGeom>
+          <a:noFill/>
+        </p:spPr>
+        <p:txBody>
+          <a:bodyPr wrap="square" rtlCol="0">
+            <a:spAutoFit/>
+          </a:bodyPr>
+          <a:p>
+            <a:r>
+              <a:rPr lang="en-US"/>
+              <a:t>li2 no op</a:t>
+            </a:r>
+            <a:endParaRPr lang="en-US"/>
+          </a:p>
+        </p:txBody>
+      </p:sp>
+      <p:sp>
+        <p:nvSpPr>
+          <p:cNvPr id="7" name="Text Box 6"/>
+          <p:cNvSpPr txBox="1"/>
+          <p:nvPr/>
+        </p:nvSpPr>
+        <p:spPr>
+          <a:xfrm>
+            <a:off x="7812405" y="2520315"/>
+            <a:ext cx="1287780" cy="368300"/>
+          </a:xfrm>
+          <a:prstGeom prst="rect">
+            <a:avLst/>
+          </a:prstGeom>
+          <a:noFill/>
+        </p:spPr>
+        <p:txBody>
+          <a:bodyPr wrap="none" rtlCol="0" anchor="t">
+            <a:spAutoFit/>
+          </a:bodyPr>
+          <a:p>
+            <a:r>
+              <a:rPr lang="en-US">
+                <a:sym typeface="+mn-ea"/>
+              </a:rPr>
+              <a:t>li2 transmit</a:t>
+            </a:r>
+            <a:endParaRPr lang="en-US"/>
+          </a:p>
+        </p:txBody>
+      </p:sp>
+      <p:sp>
+        <p:nvSpPr>
+          <p:cNvPr id="8" name="Text Box 7"/>
+          <p:cNvSpPr txBox="1"/>
+          <p:nvPr/>
+        </p:nvSpPr>
+        <p:spPr>
+          <a:xfrm>
+            <a:off x="6228080" y="4011930"/>
+            <a:ext cx="982980" cy="368300"/>
+          </a:xfrm>
+          <a:prstGeom prst="rect">
+            <a:avLst/>
+          </a:prstGeom>
+          <a:noFill/>
+        </p:spPr>
+        <p:txBody>
+          <a:bodyPr wrap="none" rtlCol="0" anchor="t">
+            <a:spAutoFit/>
+          </a:bodyPr>
+          <a:p>
+            <a:r>
+              <a:rPr lang="en-US">
+                <a:sym typeface="+mn-ea"/>
+              </a:rPr>
+              <a:t>li2 reset</a:t>
+            </a:r>
+            <a:endParaRPr lang="en-US"/>
+          </a:p>
+        </p:txBody>
+      </p:sp>
+    </p:spTree>
+  </p:cSld>
+  <p:clrMapOvr>
+    <a:masterClrMapping/>
+  </p:clrMapOvr>
+</p:sld>
+</file>
+
 <file path=ppt/theme/theme1.xml><?xml version="1.0" encoding="utf-8"?>
-<a:theme xmlns:a="http://schemas.openxmlformats.org/drawingml/2006/main" xmlns:r="http://schemas.openxmlformats.org/officeDocument/2006/relationships" name="Simple Light">
+<a:theme xmlns:a="http://schemas.openxmlformats.org/drawingml/2006/main" name="Simple Light">
   <a:themeElements>
     <a:clrScheme name="Simple Light">
       <a:dk1>
         <a:srgbClr val="000000"/>
       </a:dk1>
       <a:lt1>
-        <a:srgbClr val="ffffff"/>
+        <a:srgbClr val="FFFFFF"/>
       </a:lt1>
       <a:dk2>
         <a:srgbClr val="595959"/>
       </a:dk2>
       <a:lt2>
-        <a:srgbClr val="eeeeee"/>
+        <a:srgbClr val="EEEEEE"/>
       </a:lt2>
       <a:accent1>
-        <a:srgbClr val="4285f4"/>
+        <a:srgbClr val="4285F4"/>
       </a:accent1>
       <a:accent2>
         <a:srgbClr val="212121"/>
       </a:accent2>
       <a:accent3>
-        <a:srgbClr val="78909c"/>
+        <a:srgbClr val="78909C"/>
       </a:accent3>
       <a:accent4>
-        <a:srgbClr val="ffab40"/>
+        <a:srgbClr val="FFAB40"/>
       </a:accent4>
       <a:accent5>
-        <a:srgbClr val="0097a7"/>
+        <a:srgbClr val="0097A7"/>
       </a:accent5>
       <a:accent6>
-        <a:srgbClr val="eeff41"/>
+        <a:srgbClr val="EEFF41"/>
       </a:accent6>
       <a:hlink>
-        <a:srgbClr val="0097a7"/>
+        <a:srgbClr val="0097A7"/>
       </a:hlink>
       <a:folHlink>
-        <a:srgbClr val="0097a7"/>
+        <a:srgbClr val="0097A7"/>
       </a:folHlink>
     </a:clrScheme>
     <a:fontScheme name="Office">
       <a:majorFont>
-        <a:latin typeface="Arial" pitchFamily="0" charset="1"/>
+        <a:latin typeface="Arial"/>
         <a:ea typeface=""/>
         <a:cs typeface=""/>
       </a:majorFont>
       <a:minorFont>
-        <a:latin typeface="Arial" pitchFamily="0" charset="1"/>
+        <a:latin typeface="Arial"/>
         <a:ea typeface=""/>
         <a:cs typeface=""/>
       </a:minorFont>
     </a:fontScheme>
-    <a:fmtScheme>
+    <a:fmtScheme name="">
       <a:fillStyleLst>
         <a:solidFill>
           <a:schemeClr val="phClr"/>
@@ -3374,7 +3718,7 @@
             </a:gs>
           </a:gsLst>
           <a:lin ang="16200000" scaled="1"/>
-          <a:tileRect l="0" t="0" r="0" b="0"/>
+          <a:tileRect/>
         </a:gradFill>
         <a:gradFill>
           <a:gsLst>
@@ -3392,7 +3736,7 @@
             </a:gs>
           </a:gsLst>
           <a:lin ang="16200000" scaled="0"/>
-          <a:tileRect l="0" t="0" r="0" b="0"/>
+          <a:tileRect/>
         </a:gradFill>
       </a:fillStyleLst>
       <a:lnStyleLst>
@@ -3443,7 +3787,7 @@
           <a:path path="circle">
             <a:fillToRect l="50000" t="-80000" r="50000" b="180000"/>
           </a:path>
-          <a:tileRect l="0" t="0" r="0" b="0"/>
+          <a:tileRect/>
         </a:gradFill>
         <a:gradFill>
           <a:gsLst>
@@ -3461,68 +3805,73 @@
           <a:path path="circle">
             <a:fillToRect l="50000" t="50000" r="50000" b="50000"/>
           </a:path>
-          <a:tileRect l="0" t="0" r="0" b="0"/>
+          <a:tileRect/>
         </a:gradFill>
       </a:bgFillStyleLst>
     </a:fmtScheme>
   </a:themeElements>
+  <a:extLst>
+    <a:ext uri="{05A4C25C-085E-4340-85A3-A5531E510DB2}">
+      <thm15:themeFamily xmlns:thm15="http://schemas.microsoft.com/office/thememl/2012/main" name="Office Theme" id="{62F939B6-93AF-4DB8-9C6B-D6C7DFDC589F}" vid="{4A3C46E8-61CC-4603-A589-7422A47A8E4A}"/>
+    </a:ext>
+  </a:extLst>
 </a:theme>
 </file>
 
 <file path=ppt/theme/theme2.xml><?xml version="1.0" encoding="utf-8"?>
-<a:theme xmlns:a="http://schemas.openxmlformats.org/drawingml/2006/main" xmlns:r="http://schemas.openxmlformats.org/officeDocument/2006/relationships" name="Office Theme">
+<a:theme xmlns:a="http://schemas.openxmlformats.org/drawingml/2006/main" name="Office Theme">
   <a:themeElements>
     <a:clrScheme name="LibreOffice">
       <a:dk1>
         <a:srgbClr val="000000"/>
       </a:dk1>
       <a:lt1>
-        <a:srgbClr val="ffffff"/>
+        <a:srgbClr val="FFFFFF"/>
       </a:lt1>
       <a:dk2>
         <a:srgbClr val="000000"/>
       </a:dk2>
       <a:lt2>
-        <a:srgbClr val="ffffff"/>
+        <a:srgbClr val="FFFFFF"/>
       </a:lt2>
       <a:accent1>
-        <a:srgbClr val="18a303"/>
+        <a:srgbClr val="18A303"/>
       </a:accent1>
       <a:accent2>
-        <a:srgbClr val="0369a3"/>
+        <a:srgbClr val="0369A3"/>
       </a:accent2>
       <a:accent3>
-        <a:srgbClr val="a33e03"/>
+        <a:srgbClr val="A33E03"/>
       </a:accent3>
       <a:accent4>
-        <a:srgbClr val="8e03a3"/>
+        <a:srgbClr val="8E03A3"/>
       </a:accent4>
       <a:accent5>
-        <a:srgbClr val="c99c00"/>
+        <a:srgbClr val="C99C00"/>
       </a:accent5>
       <a:accent6>
-        <a:srgbClr val="c9211e"/>
+        <a:srgbClr val="C9211E"/>
       </a:accent6>
       <a:hlink>
-        <a:srgbClr val="0000ee"/>
+        <a:srgbClr val="0000EE"/>
       </a:hlink>
       <a:folHlink>
-        <a:srgbClr val="551a8b"/>
+        <a:srgbClr val="551A8B"/>
       </a:folHlink>
     </a:clrScheme>
     <a:fontScheme name="Office">
       <a:majorFont>
-        <a:latin typeface="Arial" pitchFamily="0" charset="1"/>
-        <a:ea typeface="DejaVu Sans" pitchFamily="0" charset="1"/>
-        <a:cs typeface="DejaVu Sans" pitchFamily="0" charset="1"/>
+        <a:latin typeface="Arial"/>
+        <a:ea typeface="DejaVu Sans"/>
+        <a:cs typeface="DejaVu Sans"/>
       </a:majorFont>
       <a:minorFont>
-        <a:latin typeface="Arial" pitchFamily="0" charset="1"/>
-        <a:ea typeface="DejaVu Sans" pitchFamily="0" charset="1"/>
-        <a:cs typeface="DejaVu Sans" pitchFamily="0" charset="1"/>
+        <a:latin typeface="Arial"/>
+        <a:ea typeface="DejaVu Sans"/>
+        <a:cs typeface="DejaVu Sans"/>
       </a:minorFont>
     </a:fontScheme>
-    <a:fmtScheme>
+    <a:fmtScheme name="">
       <a:fillStyleLst>
         <a:solidFill>
           <a:schemeClr val="phClr"/>
@@ -3572,292 +3921,10 @@
       </a:bgFillStyleLst>
     </a:fmtScheme>
   </a:themeElements>
+  <a:extLst>
+    <a:ext uri="{05A4C25C-085E-4340-85A3-A5531E510DB2}">
+      <thm15:themeFamily xmlns:thm15="http://schemas.microsoft.com/office/thememl/2012/main" name="Office Theme" id="{62F939B6-93AF-4DB8-9C6B-D6C7DFDC589F}" vid="{4A3C46E8-61CC-4603-A589-7422A47A8E4A}"/>
+    </a:ext>
+  </a:extLst>
 </a:theme>
-</file>
-
-<file path=customXml/item1.xml><?xml version="1.0" encoding="utf-8"?>
-<ct:contentTypeSchema xmlns:ct="http://schemas.microsoft.com/office/2006/metadata/contentType" xmlns:ma="http://schemas.microsoft.com/office/2006/metadata/properties/metaAttributes" ct:_="" ma:_="" ma:contentTypeName="Document" ma:contentTypeID="0x010100023378106403FF4F9FEFFD8DB19B1327" ma:contentTypeVersion="14" ma:contentTypeDescription="Create a new document." ma:contentTypeScope="" ma:versionID="480730001f801aca38e5123422cc6ec3">
-  <xsd:schema xmlns:xsd="http://www.w3.org/2001/XMLSchema" xmlns:xs="http://www.w3.org/2001/XMLSchema" xmlns:p="http://schemas.microsoft.com/office/2006/metadata/properties" xmlns:ns2="c780a065-0b04-4112-95af-a97bb2421eb1" xmlns:ns3="401457dc-c9f2-44f5-9435-e99f1bfdd774" targetNamespace="http://schemas.microsoft.com/office/2006/metadata/properties" ma:root="true" ma:fieldsID="babbaaf8a2e415dc01b2dad9fedea8bc" ns2:_="" ns3:_="">
-    <xsd:import namespace="c780a065-0b04-4112-95af-a97bb2421eb1"/>
-    <xsd:import namespace="401457dc-c9f2-44f5-9435-e99f1bfdd774"/>
-    <xsd:element name="properties">
-      <xsd:complexType>
-        <xsd:sequence>
-          <xsd:element name="documentManagement">
-            <xsd:complexType>
-              <xsd:all>
-                <xsd:element ref="ns2:SharedWithUsers" minOccurs="0"/>
-                <xsd:element ref="ns2:SharedWithDetails" minOccurs="0"/>
-                <xsd:element ref="ns3:MediaServiceMetadata" minOccurs="0"/>
-                <xsd:element ref="ns3:MediaServiceFastMetadata" minOccurs="0"/>
-                <xsd:element ref="ns3:MediaServiceDateTaken" minOccurs="0"/>
-                <xsd:element ref="ns3:MediaLengthInSeconds" minOccurs="0"/>
-                <xsd:element ref="ns3:lcf76f155ced4ddcb4097134ff3c332f" minOccurs="0"/>
-                <xsd:element ref="ns2:TaxCatchAll" minOccurs="0"/>
-                <xsd:element ref="ns3:MediaServiceOCR" minOccurs="0"/>
-                <xsd:element ref="ns3:MediaServiceGenerationTime" minOccurs="0"/>
-                <xsd:element ref="ns3:MediaServiceEventHashCode" minOccurs="0"/>
-                <xsd:element ref="ns3:MediaServiceObjectDetectorVersions" minOccurs="0"/>
-                <xsd:element ref="ns3:MediaServiceSearchProperties" minOccurs="0"/>
-              </xsd:all>
-            </xsd:complexType>
-          </xsd:element>
-        </xsd:sequence>
-      </xsd:complexType>
-    </xsd:element>
-  </xsd:schema>
-  <xsd:schema xmlns:xsd="http://www.w3.org/2001/XMLSchema" xmlns:xs="http://www.w3.org/2001/XMLSchema" xmlns:dms="http://schemas.microsoft.com/office/2006/documentManagement/types" xmlns:pc="http://schemas.microsoft.com/office/infopath/2007/PartnerControls" targetNamespace="c780a065-0b04-4112-95af-a97bb2421eb1" elementFormDefault="qualified">
-    <xsd:import namespace="http://schemas.microsoft.com/office/2006/documentManagement/types"/>
-    <xsd:import namespace="http://schemas.microsoft.com/office/infopath/2007/PartnerControls"/>
-    <xsd:element name="SharedWithUsers" ma:index="8" nillable="true" ma:displayName="Shared With" ma:internalName="SharedWithUsers" ma:readOnly="true">
-      <xsd:complexType>
-        <xsd:complexContent>
-          <xsd:extension base="dms:UserMulti">
-            <xsd:sequence>
-              <xsd:element name="UserInfo" minOccurs="0" maxOccurs="unbounded">
-                <xsd:complexType>
-                  <xsd:sequence>
-                    <xsd:element name="DisplayName" type="xsd:string" minOccurs="0"/>
-                    <xsd:element name="AccountId" type="dms:UserId" minOccurs="0" nillable="true"/>
-                    <xsd:element name="AccountType" type="xsd:string" minOccurs="0"/>
-                  </xsd:sequence>
-                </xsd:complexType>
-              </xsd:element>
-            </xsd:sequence>
-          </xsd:extension>
-        </xsd:complexContent>
-      </xsd:complexType>
-    </xsd:element>
-    <xsd:element name="SharedWithDetails" ma:index="9" nillable="true" ma:displayName="Shared With Details" ma:internalName="SharedWithDetails" ma:readOnly="true">
-      <xsd:simpleType>
-        <xsd:restriction base="dms:Note">
-          <xsd:maxLength value="255"/>
-        </xsd:restriction>
-      </xsd:simpleType>
-    </xsd:element>
-    <xsd:element name="TaxCatchAll" ma:index="16" nillable="true" ma:displayName="Taxonomy Catch All Column" ma:hidden="true" ma:list="{c24a34a3-7b04-4da0-866a-d3e336a7dfab}" ma:internalName="TaxCatchAll" ma:showField="CatchAllData" ma:web="c780a065-0b04-4112-95af-a97bb2421eb1">
-      <xsd:complexType>
-        <xsd:complexContent>
-          <xsd:extension base="dms:MultiChoiceLookup">
-            <xsd:sequence>
-              <xsd:element name="Value" type="dms:Lookup" maxOccurs="unbounded" minOccurs="0" nillable="true"/>
-            </xsd:sequence>
-          </xsd:extension>
-        </xsd:complexContent>
-      </xsd:complexType>
-    </xsd:element>
-  </xsd:schema>
-  <xsd:schema xmlns:xsd="http://www.w3.org/2001/XMLSchema" xmlns:xs="http://www.w3.org/2001/XMLSchema" xmlns:dms="http://schemas.microsoft.com/office/2006/documentManagement/types" xmlns:pc="http://schemas.microsoft.com/office/infopath/2007/PartnerControls" targetNamespace="401457dc-c9f2-44f5-9435-e99f1bfdd774" elementFormDefault="qualified">
-    <xsd:import namespace="http://schemas.microsoft.com/office/2006/documentManagement/types"/>
-    <xsd:import namespace="http://schemas.microsoft.com/office/infopath/2007/PartnerControls"/>
-    <xsd:element name="MediaServiceMetadata" ma:index="10" nillable="true" ma:displayName="MediaServiceMetadata" ma:hidden="true" ma:internalName="MediaServiceMetadata" ma:readOnly="true">
-      <xsd:simpleType>
-        <xsd:restriction base="dms:Note"/>
-      </xsd:simpleType>
-    </xsd:element>
-    <xsd:element name="MediaServiceFastMetadata" ma:index="11" nillable="true" ma:displayName="MediaServiceFastMetadata" ma:hidden="true" ma:internalName="MediaServiceFastMetadata" ma:readOnly="true">
-      <xsd:simpleType>
-        <xsd:restriction base="dms:Note"/>
-      </xsd:simpleType>
-    </xsd:element>
-    <xsd:element name="MediaServiceDateTaken" ma:index="12" nillable="true" ma:displayName="MediaServiceDateTaken" ma:description="" ma:hidden="true" ma:indexed="true" ma:internalName="MediaServiceDateTaken" ma:readOnly="true">
-      <xsd:simpleType>
-        <xsd:restriction base="dms:Text"/>
-      </xsd:simpleType>
-    </xsd:element>
-    <xsd:element name="MediaLengthInSeconds" ma:index="13" nillable="true" ma:displayName="MediaLengthInSeconds" ma:hidden="true" ma:internalName="MediaLengthInSeconds" ma:readOnly="true">
-      <xsd:simpleType>
-        <xsd:restriction base="dms:Unknown"/>
-      </xsd:simpleType>
-    </xsd:element>
-    <xsd:element name="lcf76f155ced4ddcb4097134ff3c332f" ma:index="15" nillable="true" ma:taxonomy="true" ma:internalName="lcf76f155ced4ddcb4097134ff3c332f" ma:taxonomyFieldName="MediaServiceImageTags" ma:displayName="Image Tags" ma:readOnly="false" ma:fieldId="{5cf76f15-5ced-4ddc-b409-7134ff3c332f}" ma:taxonomyMulti="true" ma:sspId="52802cc5-2881-4dd7-9d75-38905e9cf7fb" ma:termSetId="09814cd3-568e-fe90-9814-8d621ff8fb84" ma:anchorId="fba54fb3-c3e1-fe81-a776-ca4b69148c4d" ma:open="true" ma:isKeyword="false">
-      <xsd:complexType>
-        <xsd:sequence>
-          <xsd:element ref="pc:Terms" minOccurs="0" maxOccurs="1"/>
-        </xsd:sequence>
-      </xsd:complexType>
-    </xsd:element>
-    <xsd:element name="MediaServiceOCR" ma:index="17" nillable="true" ma:displayName="Extracted Text" ma:internalName="MediaServiceOCR" ma:readOnly="true">
-      <xsd:simpleType>
-        <xsd:restriction base="dms:Note">
-          <xsd:maxLength value="255"/>
-        </xsd:restriction>
-      </xsd:simpleType>
-    </xsd:element>
-    <xsd:element name="MediaServiceGenerationTime" ma:index="18" nillable="true" ma:displayName="MediaServiceGenerationTime" ma:hidden="true" ma:internalName="MediaServiceGenerationTime" ma:readOnly="true">
-      <xsd:simpleType>
-        <xsd:restriction base="dms:Text"/>
-      </xsd:simpleType>
-    </xsd:element>
-    <xsd:element name="MediaServiceEventHashCode" ma:index="19" nillable="true" ma:displayName="MediaServiceEventHashCode" ma:hidden="true" ma:internalName="MediaServiceEventHashCode" ma:readOnly="true">
-      <xsd:simpleType>
-        <xsd:restriction base="dms:Text"/>
-      </xsd:simpleType>
-    </xsd:element>
-    <xsd:element name="MediaServiceObjectDetectorVersions" ma:index="20" nillable="true" ma:displayName="MediaServiceObjectDetectorVersions" ma:hidden="true" ma:indexed="true" ma:internalName="MediaServiceObjectDetectorVersions" ma:readOnly="true">
-      <xsd:simpleType>
-        <xsd:restriction base="dms:Text"/>
-      </xsd:simpleType>
-    </xsd:element>
-    <xsd:element name="MediaServiceSearchProperties" ma:index="21" nillable="true" ma:displayName="MediaServiceSearchProperties" ma:hidden="true" ma:internalName="MediaServiceSearchProperties" ma:readOnly="true">
-      <xsd:simpleType>
-        <xsd:restriction base="dms:Note"/>
-      </xsd:simpleType>
-    </xsd:element>
-  </xsd:schema>
-  <xsd:schema xmlns="http://schemas.openxmlformats.org/package/2006/metadata/core-properties" xmlns:xsd="http://www.w3.org/2001/XMLSchema" xmlns:xsi="http://www.w3.org/2001/XMLSchema-instance" xmlns:dc="http://purl.org/dc/elements/1.1/" xmlns:dcterms="http://purl.org/dc/terms/" xmlns:odoc="http://schemas.microsoft.com/internal/obd" targetNamespace="http://schemas.openxmlformats.org/package/2006/metadata/core-properties" elementFormDefault="qualified" attributeFormDefault="unqualified" blockDefault="#all">
-    <xsd:import namespace="http://purl.org/dc/elements/1.1/" schemaLocation="http://dublincore.org/schemas/xmls/qdc/2003/04/02/dc.xsd"/>
-    <xsd:import namespace="http://purl.org/dc/terms/" schemaLocation="http://dublincore.org/schemas/xmls/qdc/2003/04/02/dcterms.xsd"/>
-    <xsd:element name="coreProperties" type="CT_coreProperties"/>
-    <xsd:complexType name="CT_coreProperties">
-      <xsd:all>
-        <xsd:element ref="dc:creator" minOccurs="0" maxOccurs="1"/>
-        <xsd:element ref="dcterms:created" minOccurs="0" maxOccurs="1"/>
-        <xsd:element ref="dc:identifier" minOccurs="0" maxOccurs="1"/>
-        <xsd:element name="contentType" minOccurs="0" maxOccurs="1" type="xsd:string" ma:index="0" ma:displayName="Content Type"/>
-        <xsd:element ref="dc:title" minOccurs="0" maxOccurs="1" ma:index="4" ma:displayName="Title"/>
-        <xsd:element ref="dc:subject" minOccurs="0" maxOccurs="1"/>
-        <xsd:element ref="dc:description" minOccurs="0" maxOccurs="1"/>
-        <xsd:element name="keywords" minOccurs="0" maxOccurs="1" type="xsd:string"/>
-        <xsd:element ref="dc:language" minOccurs="0" maxOccurs="1"/>
-        <xsd:element name="category" minOccurs="0" maxOccurs="1" type="xsd:string"/>
-        <xsd:element name="version" minOccurs="0" maxOccurs="1" type="xsd:string"/>
-        <xsd:element name="revision" minOccurs="0" maxOccurs="1" type="xsd:string">
-          <xsd:annotation>
-            <xsd:documentation>
-                        This value indicates the number of saves or revisions. The application is responsible for updating this value after each revision.
-                    </xsd:documentation>
-          </xsd:annotation>
-        </xsd:element>
-        <xsd:element name="lastModifiedBy" minOccurs="0" maxOccurs="1" type="xsd:string"/>
-        <xsd:element ref="dcterms:modified" minOccurs="0" maxOccurs="1"/>
-        <xsd:element name="contentStatus" minOccurs="0" maxOccurs="1" type="xsd:string"/>
-      </xsd:all>
-    </xsd:complexType>
-  </xsd:schema>
-  <xs:schema xmlns:pc="http://schemas.microsoft.com/office/infopath/2007/PartnerControls" xmlns:xs="http://www.w3.org/2001/XMLSchema" targetNamespace="http://schemas.microsoft.com/office/infopath/2007/PartnerControls" elementFormDefault="qualified" attributeFormDefault="unqualified">
-    <xs:element name="Person">
-      <xs:complexType>
-        <xs:sequence>
-          <xs:element ref="pc:DisplayName" minOccurs="0"/>
-          <xs:element ref="pc:AccountId" minOccurs="0"/>
-          <xs:element ref="pc:AccountType" minOccurs="0"/>
-        </xs:sequence>
-      </xs:complexType>
-    </xs:element>
-    <xs:element name="DisplayName" type="xs:string"/>
-    <xs:element name="AccountId" type="xs:string"/>
-    <xs:element name="AccountType" type="xs:string"/>
-    <xs:element name="BDCAssociatedEntity">
-      <xs:complexType>
-        <xs:sequence>
-          <xs:element ref="pc:BDCEntity" minOccurs="0" maxOccurs="unbounded"/>
-        </xs:sequence>
-        <xs:attribute ref="pc:EntityNamespace"/>
-        <xs:attribute ref="pc:EntityName"/>
-        <xs:attribute ref="pc:SystemInstanceName"/>
-        <xs:attribute ref="pc:AssociationName"/>
-      </xs:complexType>
-    </xs:element>
-    <xs:attribute name="EntityNamespace" type="xs:string"/>
-    <xs:attribute name="EntityName" type="xs:string"/>
-    <xs:attribute name="SystemInstanceName" type="xs:string"/>
-    <xs:attribute name="AssociationName" type="xs:string"/>
-    <xs:element name="BDCEntity">
-      <xs:complexType>
-        <xs:sequence>
-          <xs:element ref="pc:EntityDisplayName" minOccurs="0"/>
-          <xs:element ref="pc:EntityInstanceReference" minOccurs="0"/>
-          <xs:element ref="pc:EntityId1" minOccurs="0"/>
-          <xs:element ref="pc:EntityId2" minOccurs="0"/>
-          <xs:element ref="pc:EntityId3" minOccurs="0"/>
-          <xs:element ref="pc:EntityId4" minOccurs="0"/>
-          <xs:element ref="pc:EntityId5" minOccurs="0"/>
-        </xs:sequence>
-      </xs:complexType>
-    </xs:element>
-    <xs:element name="EntityDisplayName" type="xs:string"/>
-    <xs:element name="EntityInstanceReference" type="xs:string"/>
-    <xs:element name="EntityId1" type="xs:string"/>
-    <xs:element name="EntityId2" type="xs:string"/>
-    <xs:element name="EntityId3" type="xs:string"/>
-    <xs:element name="EntityId4" type="xs:string"/>
-    <xs:element name="EntityId5" type="xs:string"/>
-    <xs:element name="Terms">
-      <xs:complexType>
-        <xs:sequence>
-          <xs:element ref="pc:TermInfo" minOccurs="0" maxOccurs="unbounded"/>
-        </xs:sequence>
-      </xs:complexType>
-    </xs:element>
-    <xs:element name="TermInfo">
-      <xs:complexType>
-        <xs:sequence>
-          <xs:element ref="pc:TermName" minOccurs="0"/>
-          <xs:element ref="pc:TermId" minOccurs="0"/>
-        </xs:sequence>
-      </xs:complexType>
-    </xs:element>
-    <xs:element name="TermName" type="xs:string"/>
-    <xs:element name="TermId" type="xs:string"/>
-  </xs:schema>
-</ct:contentTypeSchema>
-</file>
-
-<file path=customXml/item2.xml><?xml version="1.0" encoding="utf-8"?>
-<?mso-contentType ?>
-<FormTemplates xmlns="http://schemas.microsoft.com/sharepoint/v3/contenttype/forms">
-  <Display>DocumentLibraryForm</Display>
-  <Edit>DocumentLibraryForm</Edit>
-  <New>DocumentLibraryForm</New>
-</FormTemplates>
-</file>
-
-<file path=customXml/item3.xml><?xml version="1.0" encoding="utf-8"?>
-<p:properties xmlns:p="http://schemas.microsoft.com/office/2006/metadata/properties" xmlns:xsi="http://www.w3.org/2001/XMLSchema-instance" xmlns:pc="http://schemas.microsoft.com/office/infopath/2007/PartnerControls">
-  <documentManagement>
-    <TaxCatchAll xmlns="c780a065-0b04-4112-95af-a97bb2421eb1" xsi:nil="true"/>
-    <lcf76f155ced4ddcb4097134ff3c332f xmlns="401457dc-c9f2-44f5-9435-e99f1bfdd774">
-      <Terms xmlns="http://schemas.microsoft.com/office/infopath/2007/PartnerControls"/>
-    </lcf76f155ced4ddcb4097134ff3c332f>
-  </documentManagement>
-</p:properties>
-</file>
-
-<file path=customXml/itemProps1.xml><?xml version="1.0" encoding="utf-8"?>
-<ds:datastoreItem xmlns:ds="http://schemas.openxmlformats.org/officeDocument/2006/customXml" ds:itemID="{D81A9056-462F-4995-AA25-B9A4ACB48731}">
-  <ds:schemaRefs>
-    <ds:schemaRef ds:uri="http://schemas.microsoft.com/office/2006/metadata/contentType"/>
-    <ds:schemaRef ds:uri="http://schemas.microsoft.com/office/2006/metadata/properties/metaAttributes"/>
-    <ds:schemaRef ds:uri="http://www.w3.org/2001/XMLSchema"/>
-    <ds:schemaRef ds:uri="http://schemas.microsoft.com/office/2006/metadata/properties"/>
-    <ds:schemaRef ds:uri="c780a065-0b04-4112-95af-a97bb2421eb1"/>
-    <ds:schemaRef ds:uri="401457dc-c9f2-44f5-9435-e99f1bfdd774"/>
-    <ds:schemaRef ds:uri="http://schemas.microsoft.com/office/2006/documentManagement/types"/>
-    <ds:schemaRef ds:uri="http://schemas.microsoft.com/office/infopath/2007/PartnerControls"/>
-    <ds:schemaRef ds:uri="http://schemas.openxmlformats.org/package/2006/metadata/core-properties"/>
-    <ds:schemaRef ds:uri="http://purl.org/dc/elements/1.1/"/>
-    <ds:schemaRef ds:uri="http://purl.org/dc/terms/"/>
-    <ds:schemaRef ds:uri="http://schemas.microsoft.com/internal/obd"/>
-  </ds:schemaRefs>
-</ds:datastoreItem>
-</file>
-
-<file path=customXml/itemProps2.xml><?xml version="1.0" encoding="utf-8"?>
-<ds:datastoreItem xmlns:ds="http://schemas.openxmlformats.org/officeDocument/2006/customXml" ds:itemID="{7C5BD26B-5702-46DE-A81F-CE1B9C368B3E}">
-  <ds:schemaRefs>
-    <ds:schemaRef ds:uri="http://schemas.microsoft.com/sharepoint/v3/contenttype/forms"/>
-  </ds:schemaRefs>
-</ds:datastoreItem>
-</file>
-
-<file path=customXml/itemProps3.xml><?xml version="1.0" encoding="utf-8"?>
-<ds:datastoreItem xmlns:ds="http://schemas.openxmlformats.org/officeDocument/2006/customXml" ds:itemID="{AC8DACF8-5979-4DD0-BB72-22EA4D021032}">
-  <ds:schemaRefs>
-    <ds:schemaRef ds:uri="http://schemas.microsoft.com/office/2006/metadata/properties"/>
-    <ds:schemaRef ds:uri="http://schemas.microsoft.com/office/infopath/2007/PartnerControls"/>
-    <ds:schemaRef ds:uri="c780a065-0b04-4112-95af-a97bb2421eb1"/>
-    <ds:schemaRef ds:uri="401457dc-c9f2-44f5-9435-e99f1bfdd774"/>
-  </ds:schemaRefs>
-</ds:datastoreItem>
 </file>
</xml_diff>